<commit_message>
Update PowerPoint with new logo
</commit_message>
<xml_diff>
--- a/LgFiles/Phase 3/Assessment 3 powerpoint.pptx
+++ b/LgFiles/Phase 3/Assessment 3 powerpoint.pptx
@@ -4,9 +4,13 @@
   <p:sldMasterIdLst>
     <p:sldMasterId id="2147483648" r:id="rId1"/>
   </p:sldMasterIdLst>
+  <p:notesMasterIdLst>
+    <p:notesMasterId r:id="rId5"/>
+  </p:notesMasterIdLst>
   <p:sldIdLst>
     <p:sldId id="256" r:id="rId2"/>
     <p:sldId id="257" r:id="rId3"/>
+    <p:sldId id="258" r:id="rId4"/>
   </p:sldIdLst>
   <p:sldSz cx="12192000" cy="6858000"/>
   <p:notesSz cx="6858000" cy="9144000"/>
@@ -105,7 +109,1152 @@
       </a:defRPr>
     </a:lvl9pPr>
   </p:defaultTextStyle>
+  <p:extLst>
+    <p:ext uri="{EFAFB233-063F-42B5-8137-9DF3F51BA10A}">
+      <p15:sldGuideLst xmlns:p15="http://schemas.microsoft.com/office/powerpoint/2012/main"/>
+    </p:ext>
+  </p:extLst>
 </p:presentation>
+</file>
+
+<file path=ppt/revisionInfo.xml><?xml version="1.0" encoding="utf-8"?>
+<p1510:revInfo xmlns:a="http://schemas.openxmlformats.org/drawingml/2006/main" xmlns:r="http://schemas.openxmlformats.org/officeDocument/2006/relationships" xmlns:p1510="http://schemas.microsoft.com/office/powerpoint/2015/10/main">
+  <p1510:revLst>
+    <p1510:client id="{6BAB4B05-1683-42F8-85CF-50B035D12F67}" v="45" dt="2025-06-01T00:03:08.692"/>
+  </p1510:revLst>
+</p1510:revInfo>
+</file>
+
+<file path=ppt/changesInfos/changesInfo1.xml><?xml version="1.0" encoding="utf-8"?>
+<pc:chgInfo xmlns:a="http://schemas.openxmlformats.org/drawingml/2006/main" xmlns:r="http://schemas.openxmlformats.org/officeDocument/2006/relationships" xmlns:ac="http://schemas.microsoft.com/office/drawing/2013/main/command" xmlns:pc="http://schemas.microsoft.com/office/powerpoint/2013/main/command">
+  <pc:docChgLst>
+    <pc:chgData name="RICHARD AVERY" userId="33041ff4-ef49-46cd-b021-6ff8b9862bb2" providerId="ADAL" clId="{6BAB4B05-1683-42F8-85CF-50B035D12F67}"/>
+    <pc:docChg chg="undo custSel addSld modSld">
+      <pc:chgData name="RICHARD AVERY" userId="33041ff4-ef49-46cd-b021-6ff8b9862bb2" providerId="ADAL" clId="{6BAB4B05-1683-42F8-85CF-50B035D12F67}" dt="2025-06-01T00:03:23.611" v="2459" actId="1076"/>
+      <pc:docMkLst>
+        <pc:docMk/>
+      </pc:docMkLst>
+      <pc:sldChg chg="addSp delSp modSp mod setBg">
+        <pc:chgData name="RICHARD AVERY" userId="33041ff4-ef49-46cd-b021-6ff8b9862bb2" providerId="ADAL" clId="{6BAB4B05-1683-42F8-85CF-50B035D12F67}" dt="2025-06-01T00:03:23.611" v="2459" actId="1076"/>
+        <pc:sldMkLst>
+          <pc:docMk/>
+          <pc:sldMk cId="2908254028" sldId="256"/>
+        </pc:sldMkLst>
+        <pc:spChg chg="mod">
+          <ac:chgData name="RICHARD AVERY" userId="33041ff4-ef49-46cd-b021-6ff8b9862bb2" providerId="ADAL" clId="{6BAB4B05-1683-42F8-85CF-50B035D12F67}" dt="2025-05-29T10:33:54.673" v="1875" actId="1076"/>
+          <ac:spMkLst>
+            <pc:docMk/>
+            <pc:sldMk cId="2908254028" sldId="256"/>
+            <ac:spMk id="4" creationId="{54A25444-AF9D-0465-313A-3273AF85D5D3}"/>
+          </ac:spMkLst>
+        </pc:spChg>
+        <pc:spChg chg="mod">
+          <ac:chgData name="RICHARD AVERY" userId="33041ff4-ef49-46cd-b021-6ff8b9862bb2" providerId="ADAL" clId="{6BAB4B05-1683-42F8-85CF-50B035D12F67}" dt="2025-05-29T10:33:50.259" v="1873" actId="1076"/>
+          <ac:spMkLst>
+            <pc:docMk/>
+            <pc:sldMk cId="2908254028" sldId="256"/>
+            <ac:spMk id="5" creationId="{2730DF34-2086-9D48-B211-E99499482C36}"/>
+          </ac:spMkLst>
+        </pc:spChg>
+        <pc:spChg chg="del">
+          <ac:chgData name="RICHARD AVERY" userId="33041ff4-ef49-46cd-b021-6ff8b9862bb2" providerId="ADAL" clId="{6BAB4B05-1683-42F8-85CF-50B035D12F67}" dt="2025-05-31T23:55:02.149" v="2385" actId="478"/>
+          <ac:spMkLst>
+            <pc:docMk/>
+            <pc:sldMk cId="2908254028" sldId="256"/>
+            <ac:spMk id="6" creationId="{E353CE8A-AB30-5564-F2BD-EECE9DC351D1}"/>
+          </ac:spMkLst>
+        </pc:spChg>
+        <pc:spChg chg="mod">
+          <ac:chgData name="RICHARD AVERY" userId="33041ff4-ef49-46cd-b021-6ff8b9862bb2" providerId="ADAL" clId="{6BAB4B05-1683-42F8-85CF-50B035D12F67}" dt="2025-05-29T11:41:46.399" v="2312" actId="20577"/>
+          <ac:spMkLst>
+            <pc:docMk/>
+            <pc:sldMk cId="2908254028" sldId="256"/>
+            <ac:spMk id="7" creationId="{A952360B-AA0A-B99E-A742-05502A9FBCB4}"/>
+          </ac:spMkLst>
+        </pc:spChg>
+        <pc:spChg chg="mod">
+          <ac:chgData name="RICHARD AVERY" userId="33041ff4-ef49-46cd-b021-6ff8b9862bb2" providerId="ADAL" clId="{6BAB4B05-1683-42F8-85CF-50B035D12F67}" dt="2025-05-29T11:42:04.588" v="2315" actId="120"/>
+          <ac:spMkLst>
+            <pc:docMk/>
+            <pc:sldMk cId="2908254028" sldId="256"/>
+            <ac:spMk id="8" creationId="{52C01278-3E2A-2FA0-8E59-305F6A29AAF0}"/>
+          </ac:spMkLst>
+        </pc:spChg>
+        <pc:spChg chg="mod">
+          <ac:chgData name="RICHARD AVERY" userId="33041ff4-ef49-46cd-b021-6ff8b9862bb2" providerId="ADAL" clId="{6BAB4B05-1683-42F8-85CF-50B035D12F67}" dt="2025-05-29T11:04:54.962" v="2135" actId="1076"/>
+          <ac:spMkLst>
+            <pc:docMk/>
+            <pc:sldMk cId="2908254028" sldId="256"/>
+            <ac:spMk id="9" creationId="{ED847631-9825-C933-5C77-A1E25AE5A169}"/>
+          </ac:spMkLst>
+        </pc:spChg>
+        <pc:picChg chg="add del mod">
+          <ac:chgData name="RICHARD AVERY" userId="33041ff4-ef49-46cd-b021-6ff8b9862bb2" providerId="ADAL" clId="{6BAB4B05-1683-42F8-85CF-50B035D12F67}" dt="2025-05-31T23:54:28.006" v="2380" actId="478"/>
+          <ac:picMkLst>
+            <pc:docMk/>
+            <pc:sldMk cId="2908254028" sldId="256"/>
+            <ac:picMk id="3" creationId="{C37CDDFB-2038-F3BE-58DF-3355B5EE8D88}"/>
+          </ac:picMkLst>
+        </pc:picChg>
+        <pc:picChg chg="add del mod">
+          <ac:chgData name="RICHARD AVERY" userId="33041ff4-ef49-46cd-b021-6ff8b9862bb2" providerId="ADAL" clId="{6BAB4B05-1683-42F8-85CF-50B035D12F67}" dt="2025-06-01T00:01:07.648" v="2410" actId="478"/>
+          <ac:picMkLst>
+            <pc:docMk/>
+            <pc:sldMk cId="2908254028" sldId="256"/>
+            <ac:picMk id="11" creationId="{D49E062C-0EBB-C291-57E5-1074CCCA8372}"/>
+          </ac:picMkLst>
+        </pc:picChg>
+        <pc:picChg chg="add del mod">
+          <ac:chgData name="RICHARD AVERY" userId="33041ff4-ef49-46cd-b021-6ff8b9862bb2" providerId="ADAL" clId="{6BAB4B05-1683-42F8-85CF-50B035D12F67}" dt="2025-06-01T00:01:14.456" v="2415" actId="478"/>
+          <ac:picMkLst>
+            <pc:docMk/>
+            <pc:sldMk cId="2908254028" sldId="256"/>
+            <ac:picMk id="13" creationId="{63EF905E-1DDE-6AA2-4699-35A47D5B6396}"/>
+          </ac:picMkLst>
+        </pc:picChg>
+        <pc:picChg chg="add mod">
+          <ac:chgData name="RICHARD AVERY" userId="33041ff4-ef49-46cd-b021-6ff8b9862bb2" providerId="ADAL" clId="{6BAB4B05-1683-42F8-85CF-50B035D12F67}" dt="2025-06-01T00:03:23.611" v="2459" actId="1076"/>
+          <ac:picMkLst>
+            <pc:docMk/>
+            <pc:sldMk cId="2908254028" sldId="256"/>
+            <ac:picMk id="15" creationId="{0177F9A6-E538-34A4-A8F0-3CC5D09B1C16}"/>
+          </ac:picMkLst>
+        </pc:picChg>
+        <pc:picChg chg="mod">
+          <ac:chgData name="RICHARD AVERY" userId="33041ff4-ef49-46cd-b021-6ff8b9862bb2" providerId="ADAL" clId="{6BAB4B05-1683-42F8-85CF-50B035D12F67}" dt="2025-06-01T00:03:08.691" v="2457" actId="1076"/>
+          <ac:picMkLst>
+            <pc:docMk/>
+            <pc:sldMk cId="2908254028" sldId="256"/>
+            <ac:picMk id="1030" creationId="{445C3104-AD31-4505-1171-164EB9E1EAAF}"/>
+          </ac:picMkLst>
+        </pc:picChg>
+        <pc:picChg chg="mod">
+          <ac:chgData name="RICHARD AVERY" userId="33041ff4-ef49-46cd-b021-6ff8b9862bb2" providerId="ADAL" clId="{6BAB4B05-1683-42F8-85CF-50B035D12F67}" dt="2025-05-29T10:33:48.193" v="1872" actId="1076"/>
+          <ac:picMkLst>
+            <pc:docMk/>
+            <pc:sldMk cId="2908254028" sldId="256"/>
+            <ac:picMk id="1032" creationId="{94FA7E5F-2DBF-F6F8-32D4-275375F816F4}"/>
+          </ac:picMkLst>
+        </pc:picChg>
+      </pc:sldChg>
+      <pc:sldChg chg="addSp delSp modSp mod setBg modNotesTx">
+        <pc:chgData name="RICHARD AVERY" userId="33041ff4-ef49-46cd-b021-6ff8b9862bb2" providerId="ADAL" clId="{6BAB4B05-1683-42F8-85CF-50B035D12F67}" dt="2025-06-01T00:02:47.497" v="2456"/>
+        <pc:sldMkLst>
+          <pc:docMk/>
+          <pc:sldMk cId="93593808" sldId="257"/>
+        </pc:sldMkLst>
+        <pc:spChg chg="add mod">
+          <ac:chgData name="RICHARD AVERY" userId="33041ff4-ef49-46cd-b021-6ff8b9862bb2" providerId="ADAL" clId="{6BAB4B05-1683-42F8-85CF-50B035D12F67}" dt="2025-05-29T06:37:46.437" v="11" actId="1076"/>
+          <ac:spMkLst>
+            <pc:docMk/>
+            <pc:sldMk cId="93593808" sldId="257"/>
+            <ac:spMk id="2" creationId="{7E4469B9-EA9E-6FA9-F54B-CBEB96B340FC}"/>
+          </ac:spMkLst>
+        </pc:spChg>
+        <pc:spChg chg="mod">
+          <ac:chgData name="RICHARD AVERY" userId="33041ff4-ef49-46cd-b021-6ff8b9862bb2" providerId="ADAL" clId="{6BAB4B05-1683-42F8-85CF-50B035D12F67}" dt="2025-05-29T06:41:40.784" v="35" actId="1076"/>
+          <ac:spMkLst>
+            <pc:docMk/>
+            <pc:sldMk cId="93593808" sldId="257"/>
+            <ac:spMk id="4" creationId="{864922C0-2345-5174-C78F-166145D40381}"/>
+          </ac:spMkLst>
+        </pc:spChg>
+        <pc:spChg chg="add mod">
+          <ac:chgData name="RICHARD AVERY" userId="33041ff4-ef49-46cd-b021-6ff8b9862bb2" providerId="ADAL" clId="{6BAB4B05-1683-42F8-85CF-50B035D12F67}" dt="2025-05-29T06:41:02.138" v="24" actId="1076"/>
+          <ac:spMkLst>
+            <pc:docMk/>
+            <pc:sldMk cId="93593808" sldId="257"/>
+            <ac:spMk id="13" creationId="{8B0AB1F4-ECFA-7EE6-ADF7-6FB2423D9CCD}"/>
+          </ac:spMkLst>
+        </pc:spChg>
+        <pc:spChg chg="add mod">
+          <ac:chgData name="RICHARD AVERY" userId="33041ff4-ef49-46cd-b021-6ff8b9862bb2" providerId="ADAL" clId="{6BAB4B05-1683-42F8-85CF-50B035D12F67}" dt="2025-05-29T06:41:18.271" v="29" actId="255"/>
+          <ac:spMkLst>
+            <pc:docMk/>
+            <pc:sldMk cId="93593808" sldId="257"/>
+            <ac:spMk id="15" creationId="{2EEDB996-6CB4-077E-DE7D-EF2FD56363A2}"/>
+          </ac:spMkLst>
+        </pc:spChg>
+        <pc:spChg chg="add mod">
+          <ac:chgData name="RICHARD AVERY" userId="33041ff4-ef49-46cd-b021-6ff8b9862bb2" providerId="ADAL" clId="{6BAB4B05-1683-42F8-85CF-50B035D12F67}" dt="2025-05-29T06:41:32.687" v="34" actId="255"/>
+          <ac:spMkLst>
+            <pc:docMk/>
+            <pc:sldMk cId="93593808" sldId="257"/>
+            <ac:spMk id="16" creationId="{A9B03B9D-81D4-EDFD-648D-8BF30CC6074F}"/>
+          </ac:spMkLst>
+        </pc:spChg>
+        <pc:spChg chg="add mod">
+          <ac:chgData name="RICHARD AVERY" userId="33041ff4-ef49-46cd-b021-6ff8b9862bb2" providerId="ADAL" clId="{6BAB4B05-1683-42F8-85CF-50B035D12F67}" dt="2025-05-29T11:03:10.671" v="2063" actId="1076"/>
+          <ac:spMkLst>
+            <pc:docMk/>
+            <pc:sldMk cId="93593808" sldId="257"/>
+            <ac:spMk id="18" creationId="{C84CA142-8740-88F1-D228-37B62DB33E67}"/>
+          </ac:spMkLst>
+        </pc:spChg>
+        <pc:spChg chg="add mod">
+          <ac:chgData name="RICHARD AVERY" userId="33041ff4-ef49-46cd-b021-6ff8b9862bb2" providerId="ADAL" clId="{6BAB4B05-1683-42F8-85CF-50B035D12F67}" dt="2025-05-29T11:05:04.516" v="2138" actId="1076"/>
+          <ac:spMkLst>
+            <pc:docMk/>
+            <pc:sldMk cId="93593808" sldId="257"/>
+            <ac:spMk id="21" creationId="{B8BFFCBF-6C54-E764-2F19-862D387B3E91}"/>
+          </ac:spMkLst>
+        </pc:spChg>
+        <pc:picChg chg="add del mod ord">
+          <ac:chgData name="RICHARD AVERY" userId="33041ff4-ef49-46cd-b021-6ff8b9862bb2" providerId="ADAL" clId="{6BAB4B05-1683-42F8-85CF-50B035D12F67}" dt="2025-05-31T23:56:07.712" v="2409" actId="478"/>
+          <ac:picMkLst>
+            <pc:docMk/>
+            <pc:sldMk cId="93593808" sldId="257"/>
+            <ac:picMk id="5" creationId="{98D7D938-1C00-4CB2-355C-213273A7E93A}"/>
+          </ac:picMkLst>
+        </pc:picChg>
+        <pc:picChg chg="add mod">
+          <ac:chgData name="RICHARD AVERY" userId="33041ff4-ef49-46cd-b021-6ff8b9862bb2" providerId="ADAL" clId="{6BAB4B05-1683-42F8-85CF-50B035D12F67}" dt="2025-06-01T00:02:10.517" v="2432"/>
+          <ac:picMkLst>
+            <pc:docMk/>
+            <pc:sldMk cId="93593808" sldId="257"/>
+            <ac:picMk id="8" creationId="{81A81082-381D-E69F-8B5A-4BFD5ECB9E93}"/>
+          </ac:picMkLst>
+        </pc:picChg>
+        <pc:picChg chg="add mod ord">
+          <ac:chgData name="RICHARD AVERY" userId="33041ff4-ef49-46cd-b021-6ff8b9862bb2" providerId="ADAL" clId="{6BAB4B05-1683-42F8-85CF-50B035D12F67}" dt="2025-06-01T00:02:47.497" v="2456"/>
+          <ac:picMkLst>
+            <pc:docMk/>
+            <pc:sldMk cId="93593808" sldId="257"/>
+            <ac:picMk id="10" creationId="{3CAEC022-BB52-B758-5120-B465240CC2CF}"/>
+          </ac:picMkLst>
+        </pc:picChg>
+        <pc:cxnChg chg="mod">
+          <ac:chgData name="RICHARD AVERY" userId="33041ff4-ef49-46cd-b021-6ff8b9862bb2" providerId="ADAL" clId="{6BAB4B05-1683-42F8-85CF-50B035D12F67}" dt="2025-05-29T06:38:11.434" v="17" actId="14100"/>
+          <ac:cxnSpMkLst>
+            <pc:docMk/>
+            <pc:sldMk cId="93593808" sldId="257"/>
+            <ac:cxnSpMk id="11" creationId="{972B5FC9-FFF0-7135-BEC3-BEE4CC15AAE7}"/>
+          </ac:cxnSpMkLst>
+        </pc:cxnChg>
+        <pc:cxnChg chg="mod">
+          <ac:chgData name="RICHARD AVERY" userId="33041ff4-ef49-46cd-b021-6ff8b9862bb2" providerId="ADAL" clId="{6BAB4B05-1683-42F8-85CF-50B035D12F67}" dt="2025-05-29T06:41:24.182" v="31" actId="478"/>
+          <ac:cxnSpMkLst>
+            <pc:docMk/>
+            <pc:sldMk cId="93593808" sldId="257"/>
+            <ac:cxnSpMk id="22" creationId="{F6636963-75A5-A5EA-545B-826B2B3DD0D0}"/>
+          </ac:cxnSpMkLst>
+        </pc:cxnChg>
+      </pc:sldChg>
+      <pc:sldChg chg="addSp delSp modSp new mod setBg modNotesTx">
+        <pc:chgData name="RICHARD AVERY" userId="33041ff4-ef49-46cd-b021-6ff8b9862bb2" providerId="ADAL" clId="{6BAB4B05-1683-42F8-85CF-50B035D12F67}" dt="2025-06-01T00:02:45.092" v="2451"/>
+        <pc:sldMkLst>
+          <pc:docMk/>
+          <pc:sldMk cId="3138381567" sldId="258"/>
+        </pc:sldMkLst>
+        <pc:spChg chg="add mod">
+          <ac:chgData name="RICHARD AVERY" userId="33041ff4-ef49-46cd-b021-6ff8b9862bb2" providerId="ADAL" clId="{6BAB4B05-1683-42F8-85CF-50B035D12F67}" dt="2025-05-29T10:20:53.969" v="1147" actId="14100"/>
+          <ac:spMkLst>
+            <pc:docMk/>
+            <pc:sldMk cId="3138381567" sldId="258"/>
+            <ac:spMk id="4" creationId="{D8ABC243-2E1A-11FD-5406-84704156FC59}"/>
+          </ac:spMkLst>
+        </pc:spChg>
+        <pc:spChg chg="add mod">
+          <ac:chgData name="RICHARD AVERY" userId="33041ff4-ef49-46cd-b021-6ff8b9862bb2" providerId="ADAL" clId="{6BAB4B05-1683-42F8-85CF-50B035D12F67}" dt="2025-05-29T10:21:34.738" v="1158" actId="1076"/>
+          <ac:spMkLst>
+            <pc:docMk/>
+            <pc:sldMk cId="3138381567" sldId="258"/>
+            <ac:spMk id="7" creationId="{5A7C9BE5-9AAC-E32E-52B9-3499BBCC7E30}"/>
+          </ac:spMkLst>
+        </pc:spChg>
+        <pc:spChg chg="add mod">
+          <ac:chgData name="RICHARD AVERY" userId="33041ff4-ef49-46cd-b021-6ff8b9862bb2" providerId="ADAL" clId="{6BAB4B05-1683-42F8-85CF-50B035D12F67}" dt="2025-05-29T10:21:23.837" v="1154" actId="1076"/>
+          <ac:spMkLst>
+            <pc:docMk/>
+            <pc:sldMk cId="3138381567" sldId="258"/>
+            <ac:spMk id="12" creationId="{4698CD77-0DA6-1DB0-CAFC-048D1556D1EC}"/>
+          </ac:spMkLst>
+        </pc:spChg>
+        <pc:spChg chg="add mod">
+          <ac:chgData name="RICHARD AVERY" userId="33041ff4-ef49-46cd-b021-6ff8b9862bb2" providerId="ADAL" clId="{6BAB4B05-1683-42F8-85CF-50B035D12F67}" dt="2025-05-29T10:10:02.575" v="782" actId="20577"/>
+          <ac:spMkLst>
+            <pc:docMk/>
+            <pc:sldMk cId="3138381567" sldId="258"/>
+            <ac:spMk id="13" creationId="{ADA359A3-9C59-A28F-84E5-7D9E2D34EA82}"/>
+          </ac:spMkLst>
+        </pc:spChg>
+        <pc:spChg chg="add mod">
+          <ac:chgData name="RICHARD AVERY" userId="33041ff4-ef49-46cd-b021-6ff8b9862bb2" providerId="ADAL" clId="{6BAB4B05-1683-42F8-85CF-50B035D12F67}" dt="2025-05-29T10:21:37.859" v="1159" actId="1076"/>
+          <ac:spMkLst>
+            <pc:docMk/>
+            <pc:sldMk cId="3138381567" sldId="258"/>
+            <ac:spMk id="16" creationId="{A4F08578-6968-287B-0E9A-99C03CF8EE5C}"/>
+          </ac:spMkLst>
+        </pc:spChg>
+        <pc:spChg chg="add mod">
+          <ac:chgData name="RICHARD AVERY" userId="33041ff4-ef49-46cd-b021-6ff8b9862bb2" providerId="ADAL" clId="{6BAB4B05-1683-42F8-85CF-50B035D12F67}" dt="2025-05-29T10:20:56.987" v="1148" actId="1076"/>
+          <ac:spMkLst>
+            <pc:docMk/>
+            <pc:sldMk cId="3138381567" sldId="258"/>
+            <ac:spMk id="21" creationId="{3C665B45-3848-FCBB-94C4-81BD28F11733}"/>
+          </ac:spMkLst>
+        </pc:spChg>
+        <pc:spChg chg="add mod">
+          <ac:chgData name="RICHARD AVERY" userId="33041ff4-ef49-46cd-b021-6ff8b9862bb2" providerId="ADAL" clId="{6BAB4B05-1683-42F8-85CF-50B035D12F67}" dt="2025-05-29T10:21:46.554" v="1162" actId="20577"/>
+          <ac:spMkLst>
+            <pc:docMk/>
+            <pc:sldMk cId="3138381567" sldId="258"/>
+            <ac:spMk id="24" creationId="{974CA2E3-C374-A285-31AD-D8BB246B81D8}"/>
+          </ac:spMkLst>
+        </pc:spChg>
+        <pc:spChg chg="add mod">
+          <ac:chgData name="RICHARD AVERY" userId="33041ff4-ef49-46cd-b021-6ff8b9862bb2" providerId="ADAL" clId="{6BAB4B05-1683-42F8-85CF-50B035D12F67}" dt="2025-05-29T10:22:53.736" v="1234" actId="1076"/>
+          <ac:spMkLst>
+            <pc:docMk/>
+            <pc:sldMk cId="3138381567" sldId="258"/>
+            <ac:spMk id="28" creationId="{7FDF2425-D0F5-8E83-9357-60E9BFA9613C}"/>
+          </ac:spMkLst>
+        </pc:spChg>
+        <pc:spChg chg="add mod">
+          <ac:chgData name="RICHARD AVERY" userId="33041ff4-ef49-46cd-b021-6ff8b9862bb2" providerId="ADAL" clId="{6BAB4B05-1683-42F8-85CF-50B035D12F67}" dt="2025-05-29T10:23:24.406" v="1284" actId="1076"/>
+          <ac:spMkLst>
+            <pc:docMk/>
+            <pc:sldMk cId="3138381567" sldId="258"/>
+            <ac:spMk id="31" creationId="{FE4E7FAC-1756-91DB-4BB0-C8F7887BFAE3}"/>
+          </ac:spMkLst>
+        </pc:spChg>
+        <pc:spChg chg="add mod">
+          <ac:chgData name="RICHARD AVERY" userId="33041ff4-ef49-46cd-b021-6ff8b9862bb2" providerId="ADAL" clId="{6BAB4B05-1683-42F8-85CF-50B035D12F67}" dt="2025-05-29T10:23:57.898" v="1341" actId="1076"/>
+          <ac:spMkLst>
+            <pc:docMk/>
+            <pc:sldMk cId="3138381567" sldId="258"/>
+            <ac:spMk id="36" creationId="{9DFBC1EC-F881-9481-04C3-4F83F87F9BA1}"/>
+          </ac:spMkLst>
+        </pc:spChg>
+        <pc:spChg chg="add mod">
+          <ac:chgData name="RICHARD AVERY" userId="33041ff4-ef49-46cd-b021-6ff8b9862bb2" providerId="ADAL" clId="{6BAB4B05-1683-42F8-85CF-50B035D12F67}" dt="2025-05-29T10:24:27.072" v="1391" actId="14100"/>
+          <ac:spMkLst>
+            <pc:docMk/>
+            <pc:sldMk cId="3138381567" sldId="258"/>
+            <ac:spMk id="40" creationId="{DC032CDB-AEF6-0A41-FB5C-3C63D8D880F9}"/>
+          </ac:spMkLst>
+        </pc:spChg>
+        <pc:spChg chg="add mod">
+          <ac:chgData name="RICHARD AVERY" userId="33041ff4-ef49-46cd-b021-6ff8b9862bb2" providerId="ADAL" clId="{6BAB4B05-1683-42F8-85CF-50B035D12F67}" dt="2025-05-29T10:28:10.799" v="1560" actId="20577"/>
+          <ac:spMkLst>
+            <pc:docMk/>
+            <pc:sldMk cId="3138381567" sldId="258"/>
+            <ac:spMk id="49" creationId="{F11C9D14-EC51-0A11-6014-7D3AD3D53F33}"/>
+          </ac:spMkLst>
+        </pc:spChg>
+        <pc:spChg chg="add mod">
+          <ac:chgData name="RICHARD AVERY" userId="33041ff4-ef49-46cd-b021-6ff8b9862bb2" providerId="ADAL" clId="{6BAB4B05-1683-42F8-85CF-50B035D12F67}" dt="2025-05-29T10:29:07.805" v="1639" actId="1076"/>
+          <ac:spMkLst>
+            <pc:docMk/>
+            <pc:sldMk cId="3138381567" sldId="258"/>
+            <ac:spMk id="54" creationId="{7923AF35-3A2C-0341-7A61-4330246E9C39}"/>
+          </ac:spMkLst>
+        </pc:spChg>
+        <pc:spChg chg="add mod">
+          <ac:chgData name="RICHARD AVERY" userId="33041ff4-ef49-46cd-b021-6ff8b9862bb2" providerId="ADAL" clId="{6BAB4B05-1683-42F8-85CF-50B035D12F67}" dt="2025-05-29T10:30:52.475" v="1847" actId="1076"/>
+          <ac:spMkLst>
+            <pc:docMk/>
+            <pc:sldMk cId="3138381567" sldId="258"/>
+            <ac:spMk id="58" creationId="{403E737F-F3EB-FDDB-3979-49D32914DDA3}"/>
+          </ac:spMkLst>
+        </pc:spChg>
+        <pc:spChg chg="add mod">
+          <ac:chgData name="RICHARD AVERY" userId="33041ff4-ef49-46cd-b021-6ff8b9862bb2" providerId="ADAL" clId="{6BAB4B05-1683-42F8-85CF-50B035D12F67}" dt="2025-05-29T11:05:09.195" v="2140" actId="1076"/>
+          <ac:spMkLst>
+            <pc:docMk/>
+            <pc:sldMk cId="3138381567" sldId="258"/>
+            <ac:spMk id="61" creationId="{3D179C27-D4D0-FC66-DBCC-8FD047C5515D}"/>
+          </ac:spMkLst>
+        </pc:spChg>
+        <pc:spChg chg="add mod">
+          <ac:chgData name="RICHARD AVERY" userId="33041ff4-ef49-46cd-b021-6ff8b9862bb2" providerId="ADAL" clId="{6BAB4B05-1683-42F8-85CF-50B035D12F67}" dt="2025-05-29T11:05:16.043" v="2142" actId="1076"/>
+          <ac:spMkLst>
+            <pc:docMk/>
+            <pc:sldMk cId="3138381567" sldId="258"/>
+            <ac:spMk id="62" creationId="{EC21A496-C588-FA05-E0B7-61F3742F9661}"/>
+          </ac:spMkLst>
+        </pc:spChg>
+        <pc:picChg chg="add del mod ord">
+          <ac:chgData name="RICHARD AVERY" userId="33041ff4-ef49-46cd-b021-6ff8b9862bb2" providerId="ADAL" clId="{6BAB4B05-1683-42F8-85CF-50B035D12F67}" dt="2025-05-31T23:56:03.856" v="2408" actId="478"/>
+          <ac:picMkLst>
+            <pc:docMk/>
+            <pc:sldMk cId="3138381567" sldId="258"/>
+            <ac:picMk id="3" creationId="{9215E226-C986-96AB-51CC-985FD6FB4AEC}"/>
+          </ac:picMkLst>
+        </pc:picChg>
+        <pc:picChg chg="add mod">
+          <ac:chgData name="RICHARD AVERY" userId="33041ff4-ef49-46cd-b021-6ff8b9862bb2" providerId="ADAL" clId="{6BAB4B05-1683-42F8-85CF-50B035D12F67}" dt="2025-05-29T10:21:29.450" v="1156" actId="1076"/>
+          <ac:picMkLst>
+            <pc:docMk/>
+            <pc:sldMk cId="3138381567" sldId="258"/>
+            <ac:picMk id="6" creationId="{488F2C0B-B6CF-FF9A-ABE9-9EE911A97EE9}"/>
+          </ac:picMkLst>
+        </pc:picChg>
+        <pc:picChg chg="add mod ord">
+          <ac:chgData name="RICHARD AVERY" userId="33041ff4-ef49-46cd-b021-6ff8b9862bb2" providerId="ADAL" clId="{6BAB4B05-1683-42F8-85CF-50B035D12F67}" dt="2025-06-01T00:02:45.092" v="2451"/>
+          <ac:picMkLst>
+            <pc:docMk/>
+            <pc:sldMk cId="3138381567" sldId="258"/>
+            <ac:picMk id="8" creationId="{28BE4F52-3996-DCE0-8348-3B31FBFA5602}"/>
+          </ac:picMkLst>
+        </pc:picChg>
+        <pc:picChg chg="add mod">
+          <ac:chgData name="RICHARD AVERY" userId="33041ff4-ef49-46cd-b021-6ff8b9862bb2" providerId="ADAL" clId="{6BAB4B05-1683-42F8-85CF-50B035D12F67}" dt="2025-05-29T10:21:27.479" v="1155" actId="1076"/>
+          <ac:picMkLst>
+            <pc:docMk/>
+            <pc:sldMk cId="3138381567" sldId="258"/>
+            <ac:picMk id="11" creationId="{C7097CAF-C8B6-BCC5-E59C-EBB85E5ED8BE}"/>
+          </ac:picMkLst>
+        </pc:picChg>
+        <pc:picChg chg="add mod">
+          <ac:chgData name="RICHARD AVERY" userId="33041ff4-ef49-46cd-b021-6ff8b9862bb2" providerId="ADAL" clId="{6BAB4B05-1683-42F8-85CF-50B035D12F67}" dt="2025-05-29T10:20:58.685" v="1149" actId="1076"/>
+          <ac:picMkLst>
+            <pc:docMk/>
+            <pc:sldMk cId="3138381567" sldId="258"/>
+            <ac:picMk id="20" creationId="{A3BA5E9F-1309-C8E7-A8C1-23EABB9DCF91}"/>
+          </ac:picMkLst>
+        </pc:picChg>
+        <pc:picChg chg="add mod">
+          <ac:chgData name="RICHARD AVERY" userId="33041ff4-ef49-46cd-b021-6ff8b9862bb2" providerId="ADAL" clId="{6BAB4B05-1683-42F8-85CF-50B035D12F67}" dt="2025-05-29T10:27:47.433" v="1453" actId="14100"/>
+          <ac:picMkLst>
+            <pc:docMk/>
+            <pc:sldMk cId="3138381567" sldId="258"/>
+            <ac:picMk id="48" creationId="{510D08DD-5034-2A85-1765-580E481A43D9}"/>
+          </ac:picMkLst>
+        </pc:picChg>
+        <pc:picChg chg="add mod">
+          <ac:chgData name="RICHARD AVERY" userId="33041ff4-ef49-46cd-b021-6ff8b9862bb2" providerId="ADAL" clId="{6BAB4B05-1683-42F8-85CF-50B035D12F67}" dt="2025-05-29T10:28:40.600" v="1567" actId="1076"/>
+          <ac:picMkLst>
+            <pc:docMk/>
+            <pc:sldMk cId="3138381567" sldId="258"/>
+            <ac:picMk id="53" creationId="{55B96C23-0D3D-4089-AF59-D4D1B8D4C08F}"/>
+          </ac:picMkLst>
+        </pc:picChg>
+        <pc:cxnChg chg="add mod">
+          <ac:chgData name="RICHARD AVERY" userId="33041ff4-ef49-46cd-b021-6ff8b9862bb2" providerId="ADAL" clId="{6BAB4B05-1683-42F8-85CF-50B035D12F67}" dt="2025-05-29T10:21:32.029" v="1157" actId="1076"/>
+          <ac:cxnSpMkLst>
+            <pc:docMk/>
+            <pc:sldMk cId="3138381567" sldId="258"/>
+            <ac:cxnSpMk id="9" creationId="{0782BCD0-5842-7CBB-41EF-C69675A5798D}"/>
+          </ac:cxnSpMkLst>
+        </pc:cxnChg>
+        <pc:cxnChg chg="add">
+          <ac:chgData name="RICHARD AVERY" userId="33041ff4-ef49-46cd-b021-6ff8b9862bb2" providerId="ADAL" clId="{6BAB4B05-1683-42F8-85CF-50B035D12F67}" dt="2025-05-29T10:09:38.549" v="729" actId="11529"/>
+          <ac:cxnSpMkLst>
+            <pc:docMk/>
+            <pc:sldMk cId="3138381567" sldId="258"/>
+            <ac:cxnSpMk id="15" creationId="{5F9A9F96-1721-2C9C-2B52-5FC2B21E81A3}"/>
+          </ac:cxnSpMkLst>
+        </pc:cxnChg>
+        <pc:cxnChg chg="add mod">
+          <ac:chgData name="RICHARD AVERY" userId="33041ff4-ef49-46cd-b021-6ff8b9862bb2" providerId="ADAL" clId="{6BAB4B05-1683-42F8-85CF-50B035D12F67}" dt="2025-05-29T10:21:40.015" v="1160" actId="1076"/>
+          <ac:cxnSpMkLst>
+            <pc:docMk/>
+            <pc:sldMk cId="3138381567" sldId="258"/>
+            <ac:cxnSpMk id="18" creationId="{EC9F5EE0-7C44-AE98-C0A6-98FDCB5A7B7C}"/>
+          </ac:cxnSpMkLst>
+        </pc:cxnChg>
+        <pc:cxnChg chg="add mod">
+          <ac:chgData name="RICHARD AVERY" userId="33041ff4-ef49-46cd-b021-6ff8b9862bb2" providerId="ADAL" clId="{6BAB4B05-1683-42F8-85CF-50B035D12F67}" dt="2025-05-29T10:21:16.291" v="1152" actId="571"/>
+          <ac:cxnSpMkLst>
+            <pc:docMk/>
+            <pc:sldMk cId="3138381567" sldId="258"/>
+            <ac:cxnSpMk id="25" creationId="{4F2455AC-CB34-0145-A315-19D32EB64EAF}"/>
+          </ac:cxnSpMkLst>
+        </pc:cxnChg>
+        <pc:cxnChg chg="add">
+          <ac:chgData name="RICHARD AVERY" userId="33041ff4-ef49-46cd-b021-6ff8b9862bb2" providerId="ADAL" clId="{6BAB4B05-1683-42F8-85CF-50B035D12F67}" dt="2025-05-29T10:21:51.142" v="1163" actId="11529"/>
+          <ac:cxnSpMkLst>
+            <pc:docMk/>
+            <pc:sldMk cId="3138381567" sldId="258"/>
+            <ac:cxnSpMk id="27" creationId="{C4EB50B7-2F75-7901-D71C-D37A76C7B724}"/>
+          </ac:cxnSpMkLst>
+        </pc:cxnChg>
+        <pc:cxnChg chg="add">
+          <ac:chgData name="RICHARD AVERY" userId="33041ff4-ef49-46cd-b021-6ff8b9862bb2" providerId="ADAL" clId="{6BAB4B05-1683-42F8-85CF-50B035D12F67}" dt="2025-05-29T10:22:59.469" v="1235" actId="11529"/>
+          <ac:cxnSpMkLst>
+            <pc:docMk/>
+            <pc:sldMk cId="3138381567" sldId="258"/>
+            <ac:cxnSpMk id="30" creationId="{EB0CCFE8-55EC-461E-EE54-CEB3A7E1EF5E}"/>
+          </ac:cxnSpMkLst>
+        </pc:cxnChg>
+        <pc:cxnChg chg="add mod">
+          <ac:chgData name="RICHARD AVERY" userId="33041ff4-ef49-46cd-b021-6ff8b9862bb2" providerId="ADAL" clId="{6BAB4B05-1683-42F8-85CF-50B035D12F67}" dt="2025-05-29T10:23:33.885" v="1288" actId="14100"/>
+          <ac:cxnSpMkLst>
+            <pc:docMk/>
+            <pc:sldMk cId="3138381567" sldId="258"/>
+            <ac:cxnSpMk id="33" creationId="{D7B4D4AD-CF09-5D5A-659B-C1CA1F09DA38}"/>
+          </ac:cxnSpMkLst>
+        </pc:cxnChg>
+        <pc:cxnChg chg="add mod">
+          <ac:chgData name="RICHARD AVERY" userId="33041ff4-ef49-46cd-b021-6ff8b9862bb2" providerId="ADAL" clId="{6BAB4B05-1683-42F8-85CF-50B035D12F67}" dt="2025-05-29T10:24:05.998" v="1343" actId="14100"/>
+          <ac:cxnSpMkLst>
+            <pc:docMk/>
+            <pc:sldMk cId="3138381567" sldId="258"/>
+            <ac:cxnSpMk id="38" creationId="{BB7EAFA3-B0AE-FC23-15CB-787C92DBCC82}"/>
+          </ac:cxnSpMkLst>
+        </pc:cxnChg>
+        <pc:cxnChg chg="add mod">
+          <ac:chgData name="RICHARD AVERY" userId="33041ff4-ef49-46cd-b021-6ff8b9862bb2" providerId="ADAL" clId="{6BAB4B05-1683-42F8-85CF-50B035D12F67}" dt="2025-05-29T10:24:32.914" v="1393" actId="14100"/>
+          <ac:cxnSpMkLst>
+            <pc:docMk/>
+            <pc:sldMk cId="3138381567" sldId="258"/>
+            <ac:cxnSpMk id="42" creationId="{0624A7F1-31E9-E196-A5E5-14733FB90C7D}"/>
+          </ac:cxnSpMkLst>
+        </pc:cxnChg>
+        <pc:cxnChg chg="add">
+          <ac:chgData name="RICHARD AVERY" userId="33041ff4-ef49-46cd-b021-6ff8b9862bb2" providerId="ADAL" clId="{6BAB4B05-1683-42F8-85CF-50B035D12F67}" dt="2025-05-29T10:28:17.734" v="1561" actId="11529"/>
+          <ac:cxnSpMkLst>
+            <pc:docMk/>
+            <pc:sldMk cId="3138381567" sldId="258"/>
+            <ac:cxnSpMk id="51" creationId="{2D705919-B75C-865C-B7A0-0B86B3942053}"/>
+          </ac:cxnSpMkLst>
+        </pc:cxnChg>
+        <pc:cxnChg chg="add">
+          <ac:chgData name="RICHARD AVERY" userId="33041ff4-ef49-46cd-b021-6ff8b9862bb2" providerId="ADAL" clId="{6BAB4B05-1683-42F8-85CF-50B035D12F67}" dt="2025-05-29T10:29:11.314" v="1640" actId="11529"/>
+          <ac:cxnSpMkLst>
+            <pc:docMk/>
+            <pc:sldMk cId="3138381567" sldId="258"/>
+            <ac:cxnSpMk id="56" creationId="{9ACA32C1-38BA-F4EA-218C-930EA87A38B6}"/>
+          </ac:cxnSpMkLst>
+        </pc:cxnChg>
+        <pc:cxnChg chg="add">
+          <ac:chgData name="RICHARD AVERY" userId="33041ff4-ef49-46cd-b021-6ff8b9862bb2" providerId="ADAL" clId="{6BAB4B05-1683-42F8-85CF-50B035D12F67}" dt="2025-05-29T10:30:31.533" v="1841" actId="11529"/>
+          <ac:cxnSpMkLst>
+            <pc:docMk/>
+            <pc:sldMk cId="3138381567" sldId="258"/>
+            <ac:cxnSpMk id="60" creationId="{3196D11B-63A5-9517-4E79-3AE42861D009}"/>
+          </ac:cxnSpMkLst>
+        </pc:cxnChg>
+      </pc:sldChg>
+    </pc:docChg>
+  </pc:docChgLst>
+</pc:chgInfo>
+</file>
+
+<file path=ppt/notesMasters/notesMaster1.xml><?xml version="1.0" encoding="utf-8"?>
+<p:notesMaster xmlns:a="http://schemas.openxmlformats.org/drawingml/2006/main" xmlns:r="http://schemas.openxmlformats.org/officeDocument/2006/relationships" xmlns:p="http://schemas.openxmlformats.org/presentationml/2006/main">
+  <p:cSld>
+    <p:bg>
+      <p:bgRef idx="1001">
+        <a:schemeClr val="bg1"/>
+      </p:bgRef>
+    </p:bg>
+    <p:spTree>
+      <p:nvGrpSpPr>
+        <p:cNvPr id="1" name=""/>
+        <p:cNvGrpSpPr/>
+        <p:nvPr/>
+      </p:nvGrpSpPr>
+      <p:grpSpPr>
+        <a:xfrm>
+          <a:off x="0" y="0"/>
+          <a:ext cx="0" cy="0"/>
+          <a:chOff x="0" y="0"/>
+          <a:chExt cx="0" cy="0"/>
+        </a:xfrm>
+      </p:grpSpPr>
+      <p:sp>
+        <p:nvSpPr>
+          <p:cNvPr id="2" name="Header Placeholder 1"/>
+          <p:cNvSpPr>
+            <a:spLocks noGrp="1"/>
+          </p:cNvSpPr>
+          <p:nvPr>
+            <p:ph type="hdr" sz="quarter"/>
+          </p:nvPr>
+        </p:nvSpPr>
+        <p:spPr>
+          <a:xfrm>
+            <a:off x="0" y="0"/>
+            <a:ext cx="2971800" cy="458788"/>
+          </a:xfrm>
+          <a:prstGeom prst="rect">
+            <a:avLst/>
+          </a:prstGeom>
+        </p:spPr>
+        <p:txBody>
+          <a:bodyPr vert="horz" lIns="91440" tIns="45720" rIns="91440" bIns="45720" rtlCol="0"/>
+          <a:lstStyle>
+            <a:lvl1pPr algn="l">
+              <a:defRPr sz="1200"/>
+            </a:lvl1pPr>
+          </a:lstStyle>
+          <a:p>
+            <a:endParaRPr lang="en-AU"/>
+          </a:p>
+        </p:txBody>
+      </p:sp>
+      <p:sp>
+        <p:nvSpPr>
+          <p:cNvPr id="3" name="Date Placeholder 2"/>
+          <p:cNvSpPr>
+            <a:spLocks noGrp="1"/>
+          </p:cNvSpPr>
+          <p:nvPr>
+            <p:ph type="dt" idx="1"/>
+          </p:nvPr>
+        </p:nvSpPr>
+        <p:spPr>
+          <a:xfrm>
+            <a:off x="3884613" y="0"/>
+            <a:ext cx="2971800" cy="458788"/>
+          </a:xfrm>
+          <a:prstGeom prst="rect">
+            <a:avLst/>
+          </a:prstGeom>
+        </p:spPr>
+        <p:txBody>
+          <a:bodyPr vert="horz" lIns="91440" tIns="45720" rIns="91440" bIns="45720" rtlCol="0"/>
+          <a:lstStyle>
+            <a:lvl1pPr algn="r">
+              <a:defRPr sz="1200"/>
+            </a:lvl1pPr>
+          </a:lstStyle>
+          <a:p>
+            <a:fld id="{89A0F238-010B-48F2-988D-16A54452A1E1}" type="datetimeFigureOut">
+              <a:rPr lang="en-AU" smtClean="0"/>
+              <a:t>1/06/2025</a:t>
+            </a:fld>
+            <a:endParaRPr lang="en-AU"/>
+          </a:p>
+        </p:txBody>
+      </p:sp>
+      <p:sp>
+        <p:nvSpPr>
+          <p:cNvPr id="4" name="Slide Image Placeholder 3"/>
+          <p:cNvSpPr>
+            <a:spLocks noGrp="1" noRot="1" noChangeAspect="1"/>
+          </p:cNvSpPr>
+          <p:nvPr>
+            <p:ph type="sldImg" idx="2"/>
+          </p:nvPr>
+        </p:nvSpPr>
+        <p:spPr>
+          <a:xfrm>
+            <a:off x="685800" y="1143000"/>
+            <a:ext cx="5486400" cy="3086100"/>
+          </a:xfrm>
+          <a:prstGeom prst="rect">
+            <a:avLst/>
+          </a:prstGeom>
+          <a:noFill/>
+          <a:ln w="12700">
+            <a:solidFill>
+              <a:prstClr val="black"/>
+            </a:solidFill>
+          </a:ln>
+        </p:spPr>
+        <p:txBody>
+          <a:bodyPr vert="horz" lIns="91440" tIns="45720" rIns="91440" bIns="45720" rtlCol="0" anchor="ctr"/>
+          <a:lstStyle/>
+          <a:p>
+            <a:endParaRPr lang="en-AU"/>
+          </a:p>
+        </p:txBody>
+      </p:sp>
+      <p:sp>
+        <p:nvSpPr>
+          <p:cNvPr id="5" name="Notes Placeholder 4"/>
+          <p:cNvSpPr>
+            <a:spLocks noGrp="1"/>
+          </p:cNvSpPr>
+          <p:nvPr>
+            <p:ph type="body" sz="quarter" idx="3"/>
+          </p:nvPr>
+        </p:nvSpPr>
+        <p:spPr>
+          <a:xfrm>
+            <a:off x="685800" y="4400550"/>
+            <a:ext cx="5486400" cy="3600450"/>
+          </a:xfrm>
+          <a:prstGeom prst="rect">
+            <a:avLst/>
+          </a:prstGeom>
+        </p:spPr>
+        <p:txBody>
+          <a:bodyPr vert="horz" lIns="91440" tIns="45720" rIns="91440" bIns="45720" rtlCol="0"/>
+          <a:lstStyle/>
+          <a:p>
+            <a:pPr lvl="0"/>
+            <a:r>
+              <a:rPr lang="en-US"/>
+              <a:t>Click to edit Master text styles</a:t>
+            </a:r>
+          </a:p>
+          <a:p>
+            <a:pPr lvl="1"/>
+            <a:r>
+              <a:rPr lang="en-US"/>
+              <a:t>Second level</a:t>
+            </a:r>
+          </a:p>
+          <a:p>
+            <a:pPr lvl="2"/>
+            <a:r>
+              <a:rPr lang="en-US"/>
+              <a:t>Third level</a:t>
+            </a:r>
+          </a:p>
+          <a:p>
+            <a:pPr lvl="3"/>
+            <a:r>
+              <a:rPr lang="en-US"/>
+              <a:t>Fourth level</a:t>
+            </a:r>
+          </a:p>
+          <a:p>
+            <a:pPr lvl="4"/>
+            <a:r>
+              <a:rPr lang="en-US"/>
+              <a:t>Fifth level</a:t>
+            </a:r>
+            <a:endParaRPr lang="en-AU"/>
+          </a:p>
+        </p:txBody>
+      </p:sp>
+      <p:sp>
+        <p:nvSpPr>
+          <p:cNvPr id="6" name="Footer Placeholder 5"/>
+          <p:cNvSpPr>
+            <a:spLocks noGrp="1"/>
+          </p:cNvSpPr>
+          <p:nvPr>
+            <p:ph type="ftr" sz="quarter" idx="4"/>
+          </p:nvPr>
+        </p:nvSpPr>
+        <p:spPr>
+          <a:xfrm>
+            <a:off x="0" y="8685213"/>
+            <a:ext cx="2971800" cy="458787"/>
+          </a:xfrm>
+          <a:prstGeom prst="rect">
+            <a:avLst/>
+          </a:prstGeom>
+        </p:spPr>
+        <p:txBody>
+          <a:bodyPr vert="horz" lIns="91440" tIns="45720" rIns="91440" bIns="45720" rtlCol="0" anchor="b"/>
+          <a:lstStyle>
+            <a:lvl1pPr algn="l">
+              <a:defRPr sz="1200"/>
+            </a:lvl1pPr>
+          </a:lstStyle>
+          <a:p>
+            <a:endParaRPr lang="en-AU"/>
+          </a:p>
+        </p:txBody>
+      </p:sp>
+      <p:sp>
+        <p:nvSpPr>
+          <p:cNvPr id="7" name="Slide Number Placeholder 6"/>
+          <p:cNvSpPr>
+            <a:spLocks noGrp="1"/>
+          </p:cNvSpPr>
+          <p:nvPr>
+            <p:ph type="sldNum" sz="quarter" idx="5"/>
+          </p:nvPr>
+        </p:nvSpPr>
+        <p:spPr>
+          <a:xfrm>
+            <a:off x="3884613" y="8685213"/>
+            <a:ext cx="2971800" cy="458787"/>
+          </a:xfrm>
+          <a:prstGeom prst="rect">
+            <a:avLst/>
+          </a:prstGeom>
+        </p:spPr>
+        <p:txBody>
+          <a:bodyPr vert="horz" lIns="91440" tIns="45720" rIns="91440" bIns="45720" rtlCol="0" anchor="b"/>
+          <a:lstStyle>
+            <a:lvl1pPr algn="r">
+              <a:defRPr sz="1200"/>
+            </a:lvl1pPr>
+          </a:lstStyle>
+          <a:p>
+            <a:fld id="{BD6A8A3A-C051-4EC5-84FD-FFF9823CD921}" type="slidenum">
+              <a:rPr lang="en-AU" smtClean="0"/>
+              <a:t>‹#›</a:t>
+            </a:fld>
+            <a:endParaRPr lang="en-AU"/>
+          </a:p>
+        </p:txBody>
+      </p:sp>
+    </p:spTree>
+    <p:extLst>
+      <p:ext uri="{BB962C8B-B14F-4D97-AF65-F5344CB8AC3E}">
+        <p14:creationId xmlns:p14="http://schemas.microsoft.com/office/powerpoint/2010/main" val="460685739"/>
+      </p:ext>
+    </p:extLst>
+  </p:cSld>
+  <p:clrMap bg1="lt1" tx1="dk1" bg2="lt2" tx2="dk2" accent1="accent1" accent2="accent2" accent3="accent3" accent4="accent4" accent5="accent5" accent6="accent6" hlink="hlink" folHlink="folHlink"/>
+  <p:notesStyle>
+    <a:lvl1pPr marL="0" algn="l" defTabSz="914400" rtl="0" eaLnBrk="1" latinLnBrk="0" hangingPunct="1">
+      <a:defRPr sz="1200" kern="1200">
+        <a:solidFill>
+          <a:schemeClr val="tx1"/>
+        </a:solidFill>
+        <a:latin typeface="+mn-lt"/>
+        <a:ea typeface="+mn-ea"/>
+        <a:cs typeface="+mn-cs"/>
+      </a:defRPr>
+    </a:lvl1pPr>
+    <a:lvl2pPr marL="457200" algn="l" defTabSz="914400" rtl="0" eaLnBrk="1" latinLnBrk="0" hangingPunct="1">
+      <a:defRPr sz="1200" kern="1200">
+        <a:solidFill>
+          <a:schemeClr val="tx1"/>
+        </a:solidFill>
+        <a:latin typeface="+mn-lt"/>
+        <a:ea typeface="+mn-ea"/>
+        <a:cs typeface="+mn-cs"/>
+      </a:defRPr>
+    </a:lvl2pPr>
+    <a:lvl3pPr marL="914400" algn="l" defTabSz="914400" rtl="0" eaLnBrk="1" latinLnBrk="0" hangingPunct="1">
+      <a:defRPr sz="1200" kern="1200">
+        <a:solidFill>
+          <a:schemeClr val="tx1"/>
+        </a:solidFill>
+        <a:latin typeface="+mn-lt"/>
+        <a:ea typeface="+mn-ea"/>
+        <a:cs typeface="+mn-cs"/>
+      </a:defRPr>
+    </a:lvl3pPr>
+    <a:lvl4pPr marL="1371600" algn="l" defTabSz="914400" rtl="0" eaLnBrk="1" latinLnBrk="0" hangingPunct="1">
+      <a:defRPr sz="1200" kern="1200">
+        <a:solidFill>
+          <a:schemeClr val="tx1"/>
+        </a:solidFill>
+        <a:latin typeface="+mn-lt"/>
+        <a:ea typeface="+mn-ea"/>
+        <a:cs typeface="+mn-cs"/>
+      </a:defRPr>
+    </a:lvl4pPr>
+    <a:lvl5pPr marL="1828800" algn="l" defTabSz="914400" rtl="0" eaLnBrk="1" latinLnBrk="0" hangingPunct="1">
+      <a:defRPr sz="1200" kern="1200">
+        <a:solidFill>
+          <a:schemeClr val="tx1"/>
+        </a:solidFill>
+        <a:latin typeface="+mn-lt"/>
+        <a:ea typeface="+mn-ea"/>
+        <a:cs typeface="+mn-cs"/>
+      </a:defRPr>
+    </a:lvl5pPr>
+    <a:lvl6pPr marL="2286000" algn="l" defTabSz="914400" rtl="0" eaLnBrk="1" latinLnBrk="0" hangingPunct="1">
+      <a:defRPr sz="1200" kern="1200">
+        <a:solidFill>
+          <a:schemeClr val="tx1"/>
+        </a:solidFill>
+        <a:latin typeface="+mn-lt"/>
+        <a:ea typeface="+mn-ea"/>
+        <a:cs typeface="+mn-cs"/>
+      </a:defRPr>
+    </a:lvl6pPr>
+    <a:lvl7pPr marL="2743200" algn="l" defTabSz="914400" rtl="0" eaLnBrk="1" latinLnBrk="0" hangingPunct="1">
+      <a:defRPr sz="1200" kern="1200">
+        <a:solidFill>
+          <a:schemeClr val="tx1"/>
+        </a:solidFill>
+        <a:latin typeface="+mn-lt"/>
+        <a:ea typeface="+mn-ea"/>
+        <a:cs typeface="+mn-cs"/>
+      </a:defRPr>
+    </a:lvl7pPr>
+    <a:lvl8pPr marL="3200400" algn="l" defTabSz="914400" rtl="0" eaLnBrk="1" latinLnBrk="0" hangingPunct="1">
+      <a:defRPr sz="1200" kern="1200">
+        <a:solidFill>
+          <a:schemeClr val="tx1"/>
+        </a:solidFill>
+        <a:latin typeface="+mn-lt"/>
+        <a:ea typeface="+mn-ea"/>
+        <a:cs typeface="+mn-cs"/>
+      </a:defRPr>
+    </a:lvl8pPr>
+    <a:lvl9pPr marL="3657600" algn="l" defTabSz="914400" rtl="0" eaLnBrk="1" latinLnBrk="0" hangingPunct="1">
+      <a:defRPr sz="1200" kern="1200">
+        <a:solidFill>
+          <a:schemeClr val="tx1"/>
+        </a:solidFill>
+        <a:latin typeface="+mn-lt"/>
+        <a:ea typeface="+mn-ea"/>
+        <a:cs typeface="+mn-cs"/>
+      </a:defRPr>
+    </a:lvl9pPr>
+  </p:notesStyle>
+</p:notesMaster>
+</file>
+
+<file path=ppt/notesSlides/notesSlide1.xml><?xml version="1.0" encoding="utf-8"?>
+<p:notes xmlns:a="http://schemas.openxmlformats.org/drawingml/2006/main" xmlns:r="http://schemas.openxmlformats.org/officeDocument/2006/relationships" xmlns:p="http://schemas.openxmlformats.org/presentationml/2006/main">
+  <p:cSld>
+    <p:spTree>
+      <p:nvGrpSpPr>
+        <p:cNvPr id="1" name=""/>
+        <p:cNvGrpSpPr/>
+        <p:nvPr/>
+      </p:nvGrpSpPr>
+      <p:grpSpPr>
+        <a:xfrm>
+          <a:off x="0" y="0"/>
+          <a:ext cx="0" cy="0"/>
+          <a:chOff x="0" y="0"/>
+          <a:chExt cx="0" cy="0"/>
+        </a:xfrm>
+      </p:grpSpPr>
+      <p:sp>
+        <p:nvSpPr>
+          <p:cNvPr id="2" name="Slide Image Placeholder 1"/>
+          <p:cNvSpPr>
+            <a:spLocks noGrp="1" noRot="1" noChangeAspect="1"/>
+          </p:cNvSpPr>
+          <p:nvPr>
+            <p:ph type="sldImg"/>
+          </p:nvPr>
+        </p:nvSpPr>
+        <p:spPr/>
+      </p:sp>
+      <p:sp>
+        <p:nvSpPr>
+          <p:cNvPr id="3" name="Notes Placeholder 2"/>
+          <p:cNvSpPr>
+            <a:spLocks noGrp="1"/>
+          </p:cNvSpPr>
+          <p:nvPr>
+            <p:ph type="body" idx="1"/>
+          </p:nvPr>
+        </p:nvSpPr>
+        <p:spPr/>
+        <p:txBody>
+          <a:bodyPr/>
+          <a:lstStyle/>
+          <a:p>
+            <a:endParaRPr lang="en-AU" dirty="0"/>
+          </a:p>
+        </p:txBody>
+      </p:sp>
+      <p:sp>
+        <p:nvSpPr>
+          <p:cNvPr id="4" name="Slide Number Placeholder 3"/>
+          <p:cNvSpPr>
+            <a:spLocks noGrp="1"/>
+          </p:cNvSpPr>
+          <p:nvPr>
+            <p:ph type="sldNum" sz="quarter" idx="5"/>
+          </p:nvPr>
+        </p:nvSpPr>
+        <p:spPr/>
+        <p:txBody>
+          <a:bodyPr/>
+          <a:lstStyle/>
+          <a:p>
+            <a:fld id="{BD6A8A3A-C051-4EC5-84FD-FFF9823CD921}" type="slidenum">
+              <a:rPr lang="en-AU" smtClean="0"/>
+              <a:t>1</a:t>
+            </a:fld>
+            <a:endParaRPr lang="en-AU"/>
+          </a:p>
+        </p:txBody>
+      </p:sp>
+    </p:spTree>
+    <p:extLst>
+      <p:ext uri="{BB962C8B-B14F-4D97-AF65-F5344CB8AC3E}">
+        <p14:creationId xmlns:p14="http://schemas.microsoft.com/office/powerpoint/2010/main" val="615644691"/>
+      </p:ext>
+    </p:extLst>
+  </p:cSld>
+  <p:clrMapOvr>
+    <a:masterClrMapping/>
+  </p:clrMapOvr>
+</p:notes>
+</file>
+
+<file path=ppt/notesSlides/notesSlide2.xml><?xml version="1.0" encoding="utf-8"?>
+<p:notes xmlns:a="http://schemas.openxmlformats.org/drawingml/2006/main" xmlns:r="http://schemas.openxmlformats.org/officeDocument/2006/relationships" xmlns:p="http://schemas.openxmlformats.org/presentationml/2006/main">
+  <p:cSld>
+    <p:spTree>
+      <p:nvGrpSpPr>
+        <p:cNvPr id="1" name=""/>
+        <p:cNvGrpSpPr/>
+        <p:nvPr/>
+      </p:nvGrpSpPr>
+      <p:grpSpPr>
+        <a:xfrm>
+          <a:off x="0" y="0"/>
+          <a:ext cx="0" cy="0"/>
+          <a:chOff x="0" y="0"/>
+          <a:chExt cx="0" cy="0"/>
+        </a:xfrm>
+      </p:grpSpPr>
+      <p:sp>
+        <p:nvSpPr>
+          <p:cNvPr id="2" name="Slide Image Placeholder 1"/>
+          <p:cNvSpPr>
+            <a:spLocks noGrp="1" noRot="1" noChangeAspect="1"/>
+          </p:cNvSpPr>
+          <p:nvPr>
+            <p:ph type="sldImg"/>
+          </p:nvPr>
+        </p:nvSpPr>
+        <p:spPr/>
+      </p:sp>
+      <p:sp>
+        <p:nvSpPr>
+          <p:cNvPr id="3" name="Notes Placeholder 2"/>
+          <p:cNvSpPr>
+            <a:spLocks noGrp="1"/>
+          </p:cNvSpPr>
+          <p:nvPr>
+            <p:ph type="body" idx="1"/>
+          </p:nvPr>
+        </p:nvSpPr>
+        <p:spPr/>
+        <p:txBody>
+          <a:bodyPr/>
+          <a:lstStyle/>
+          <a:p>
+            <a:r>
+              <a:rPr lang="en-AU" dirty="0"/>
+              <a:t>Talk about the use of the global standards for hazard colours on the icons. </a:t>
+            </a:r>
+          </a:p>
+        </p:txBody>
+      </p:sp>
+      <p:sp>
+        <p:nvSpPr>
+          <p:cNvPr id="4" name="Slide Number Placeholder 3"/>
+          <p:cNvSpPr>
+            <a:spLocks noGrp="1"/>
+          </p:cNvSpPr>
+          <p:nvPr>
+            <p:ph type="sldNum" sz="quarter" idx="5"/>
+          </p:nvPr>
+        </p:nvSpPr>
+        <p:spPr/>
+        <p:txBody>
+          <a:bodyPr/>
+          <a:lstStyle/>
+          <a:p>
+            <a:fld id="{BD6A8A3A-C051-4EC5-84FD-FFF9823CD921}" type="slidenum">
+              <a:rPr lang="en-AU" smtClean="0"/>
+              <a:t>2</a:t>
+            </a:fld>
+            <a:endParaRPr lang="en-AU"/>
+          </a:p>
+        </p:txBody>
+      </p:sp>
+    </p:spTree>
+    <p:extLst>
+      <p:ext uri="{BB962C8B-B14F-4D97-AF65-F5344CB8AC3E}">
+        <p14:creationId xmlns:p14="http://schemas.microsoft.com/office/powerpoint/2010/main" val="1534483914"/>
+      </p:ext>
+    </p:extLst>
+  </p:cSld>
+  <p:clrMapOvr>
+    <a:masterClrMapping/>
+  </p:clrMapOvr>
+</p:notes>
+</file>
+
+<file path=ppt/notesSlides/notesSlide3.xml><?xml version="1.0" encoding="utf-8"?>
+<p:notes xmlns:a="http://schemas.openxmlformats.org/drawingml/2006/main" xmlns:r="http://schemas.openxmlformats.org/officeDocument/2006/relationships" xmlns:p="http://schemas.openxmlformats.org/presentationml/2006/main">
+  <p:cSld>
+    <p:spTree>
+      <p:nvGrpSpPr>
+        <p:cNvPr id="1" name=""/>
+        <p:cNvGrpSpPr/>
+        <p:nvPr/>
+      </p:nvGrpSpPr>
+      <p:grpSpPr>
+        <a:xfrm>
+          <a:off x="0" y="0"/>
+          <a:ext cx="0" cy="0"/>
+          <a:chOff x="0" y="0"/>
+          <a:chExt cx="0" cy="0"/>
+        </a:xfrm>
+      </p:grpSpPr>
+      <p:sp>
+        <p:nvSpPr>
+          <p:cNvPr id="2" name="Slide Image Placeholder 1"/>
+          <p:cNvSpPr>
+            <a:spLocks noGrp="1" noRot="1" noChangeAspect="1"/>
+          </p:cNvSpPr>
+          <p:nvPr>
+            <p:ph type="sldImg"/>
+          </p:nvPr>
+        </p:nvSpPr>
+        <p:spPr/>
+      </p:sp>
+      <p:sp>
+        <p:nvSpPr>
+          <p:cNvPr id="3" name="Notes Placeholder 2"/>
+          <p:cNvSpPr>
+            <a:spLocks noGrp="1"/>
+          </p:cNvSpPr>
+          <p:nvPr>
+            <p:ph type="body" idx="1"/>
+          </p:nvPr>
+        </p:nvSpPr>
+        <p:spPr/>
+        <p:txBody>
+          <a:bodyPr/>
+          <a:lstStyle/>
+          <a:p>
+            <a:pPr marL="0" marR="0" lvl="0" indent="0" algn="l" defTabSz="914400" rtl="0" eaLnBrk="1" fontAlgn="auto" latinLnBrk="0" hangingPunct="1">
+              <a:lnSpc>
+                <a:spcPct val="100000"/>
+              </a:lnSpc>
+              <a:spcBef>
+                <a:spcPts val="0"/>
+              </a:spcBef>
+              <a:spcAft>
+                <a:spcPts val="0"/>
+              </a:spcAft>
+              <a:buClrTx/>
+              <a:buSzTx/>
+              <a:buFontTx/>
+              <a:buNone/>
+              <a:tabLst/>
+              <a:defRPr/>
+            </a:pPr>
+            <a:r>
+              <a:rPr lang="en-AU" dirty="0"/>
+              <a:t>Briefly touch on the admin page functionality as an extra piece.</a:t>
+            </a:r>
+          </a:p>
+        </p:txBody>
+      </p:sp>
+      <p:sp>
+        <p:nvSpPr>
+          <p:cNvPr id="4" name="Slide Number Placeholder 3"/>
+          <p:cNvSpPr>
+            <a:spLocks noGrp="1"/>
+          </p:cNvSpPr>
+          <p:nvPr>
+            <p:ph type="sldNum" sz="quarter" idx="5"/>
+          </p:nvPr>
+        </p:nvSpPr>
+        <p:spPr/>
+        <p:txBody>
+          <a:bodyPr/>
+          <a:lstStyle/>
+          <a:p>
+            <a:fld id="{BD6A8A3A-C051-4EC5-84FD-FFF9823CD921}" type="slidenum">
+              <a:rPr lang="en-AU" smtClean="0"/>
+              <a:t>3</a:t>
+            </a:fld>
+            <a:endParaRPr lang="en-AU"/>
+          </a:p>
+        </p:txBody>
+      </p:sp>
+    </p:spTree>
+    <p:extLst>
+      <p:ext uri="{BB962C8B-B14F-4D97-AF65-F5344CB8AC3E}">
+        <p14:creationId xmlns:p14="http://schemas.microsoft.com/office/powerpoint/2010/main" val="3405632673"/>
+      </p:ext>
+    </p:extLst>
+  </p:cSld>
+  <p:clrMapOvr>
+    <a:masterClrMapping/>
+  </p:clrMapOvr>
+</p:notes>
 </file>
 
 <file path=ppt/slideLayouts/slideLayout1.xml><?xml version="1.0" encoding="utf-8"?>
@@ -257,7 +1406,7 @@
           <a:p>
             <a:fld id="{FA94A02A-306A-42E7-B38C-2A6E79E1D15A}" type="datetimeFigureOut">
               <a:rPr lang="en-AU" smtClean="0"/>
-              <a:t>29/05/2025</a:t>
+              <a:t>1/06/2025</a:t>
             </a:fld>
             <a:endParaRPr lang="en-AU"/>
           </a:p>
@@ -457,7 +1606,7 @@
           <a:p>
             <a:fld id="{FA94A02A-306A-42E7-B38C-2A6E79E1D15A}" type="datetimeFigureOut">
               <a:rPr lang="en-AU" smtClean="0"/>
-              <a:t>29/05/2025</a:t>
+              <a:t>1/06/2025</a:t>
             </a:fld>
             <a:endParaRPr lang="en-AU"/>
           </a:p>
@@ -667,7 +1816,7 @@
           <a:p>
             <a:fld id="{FA94A02A-306A-42E7-B38C-2A6E79E1D15A}" type="datetimeFigureOut">
               <a:rPr lang="en-AU" smtClean="0"/>
-              <a:t>29/05/2025</a:t>
+              <a:t>1/06/2025</a:t>
             </a:fld>
             <a:endParaRPr lang="en-AU"/>
           </a:p>
@@ -867,7 +2016,7 @@
           <a:p>
             <a:fld id="{FA94A02A-306A-42E7-B38C-2A6E79E1D15A}" type="datetimeFigureOut">
               <a:rPr lang="en-AU" smtClean="0"/>
-              <a:t>29/05/2025</a:t>
+              <a:t>1/06/2025</a:t>
             </a:fld>
             <a:endParaRPr lang="en-AU"/>
           </a:p>
@@ -1143,7 +2292,7 @@
           <a:p>
             <a:fld id="{FA94A02A-306A-42E7-B38C-2A6E79E1D15A}" type="datetimeFigureOut">
               <a:rPr lang="en-AU" smtClean="0"/>
-              <a:t>29/05/2025</a:t>
+              <a:t>1/06/2025</a:t>
             </a:fld>
             <a:endParaRPr lang="en-AU"/>
           </a:p>
@@ -1411,7 +2560,7 @@
           <a:p>
             <a:fld id="{FA94A02A-306A-42E7-B38C-2A6E79E1D15A}" type="datetimeFigureOut">
               <a:rPr lang="en-AU" smtClean="0"/>
-              <a:t>29/05/2025</a:t>
+              <a:t>1/06/2025</a:t>
             </a:fld>
             <a:endParaRPr lang="en-AU"/>
           </a:p>
@@ -1826,7 +2975,7 @@
           <a:p>
             <a:fld id="{FA94A02A-306A-42E7-B38C-2A6E79E1D15A}" type="datetimeFigureOut">
               <a:rPr lang="en-AU" smtClean="0"/>
-              <a:t>29/05/2025</a:t>
+              <a:t>1/06/2025</a:t>
             </a:fld>
             <a:endParaRPr lang="en-AU"/>
           </a:p>
@@ -1968,7 +3117,7 @@
           <a:p>
             <a:fld id="{FA94A02A-306A-42E7-B38C-2A6E79E1D15A}" type="datetimeFigureOut">
               <a:rPr lang="en-AU" smtClean="0"/>
-              <a:t>29/05/2025</a:t>
+              <a:t>1/06/2025</a:t>
             </a:fld>
             <a:endParaRPr lang="en-AU"/>
           </a:p>
@@ -2081,7 +3230,7 @@
           <a:p>
             <a:fld id="{FA94A02A-306A-42E7-B38C-2A6E79E1D15A}" type="datetimeFigureOut">
               <a:rPr lang="en-AU" smtClean="0"/>
-              <a:t>29/05/2025</a:t>
+              <a:t>1/06/2025</a:t>
             </a:fld>
             <a:endParaRPr lang="en-AU"/>
           </a:p>
@@ -2394,7 +3543,7 @@
           <a:p>
             <a:fld id="{FA94A02A-306A-42E7-B38C-2A6E79E1D15A}" type="datetimeFigureOut">
               <a:rPr lang="en-AU" smtClean="0"/>
-              <a:t>29/05/2025</a:t>
+              <a:t>1/06/2025</a:t>
             </a:fld>
             <a:endParaRPr lang="en-AU"/>
           </a:p>
@@ -2683,7 +3832,7 @@
           <a:p>
             <a:fld id="{FA94A02A-306A-42E7-B38C-2A6E79E1D15A}" type="datetimeFigureOut">
               <a:rPr lang="en-AU" smtClean="0"/>
-              <a:t>29/05/2025</a:t>
+              <a:t>1/06/2025</a:t>
             </a:fld>
             <a:endParaRPr lang="en-AU"/>
           </a:p>
@@ -2926,7 +4075,7 @@
           <a:p>
             <a:fld id="{FA94A02A-306A-42E7-B38C-2A6E79E1D15A}" type="datetimeFigureOut">
               <a:rPr lang="en-AU" smtClean="0"/>
-              <a:t>29/05/2025</a:t>
+              <a:t>1/06/2025</a:t>
             </a:fld>
             <a:endParaRPr lang="en-AU"/>
           </a:p>
@@ -3329,6 +4478,16 @@
 <file path=ppt/slides/slide1.xml><?xml version="1.0" encoding="utf-8"?>
 <p:sld xmlns:a="http://schemas.openxmlformats.org/drawingml/2006/main" xmlns:r="http://schemas.openxmlformats.org/officeDocument/2006/relationships" xmlns:p="http://schemas.openxmlformats.org/presentationml/2006/main">
   <p:cSld>
+    <p:bg>
+      <p:bgPr>
+        <a:solidFill>
+          <a:schemeClr val="bg1">
+            <a:lumMod val="95000"/>
+          </a:schemeClr>
+        </a:solidFill>
+        <a:effectLst/>
+      </p:bgPr>
+    </p:bg>
     <p:spTree>
       <p:nvGrpSpPr>
         <p:cNvPr id="1" name=""/>
@@ -3358,7 +4517,7 @@
           <p:nvPr/>
         </p:nvPicPr>
         <p:blipFill>
-          <a:blip r:embed="rId2">
+          <a:blip r:embed="rId3">
             <a:extLst>
               <a:ext uri="{28A0092B-C50C-407E-A947-70E740481C1C}">
                 <a14:useLocalDpi xmlns:a14="http://schemas.microsoft.com/office/drawing/2010/main" val="0"/>
@@ -3372,7 +4531,7 @@
         </p:blipFill>
         <p:spPr bwMode="auto">
           <a:xfrm>
-            <a:off x="565996" y="453239"/>
+            <a:off x="691939" y="453238"/>
             <a:ext cx="2173220" cy="2713822"/>
           </a:xfrm>
           <a:prstGeom prst="rect">
@@ -3405,7 +4564,7 @@
           <p:nvPr/>
         </p:nvPicPr>
         <p:blipFill>
-          <a:blip r:embed="rId3">
+          <a:blip r:embed="rId4">
             <a:extLst>
               <a:ext uri="{28A0092B-C50C-407E-A947-70E740481C1C}">
                 <a14:useLocalDpi xmlns:a14="http://schemas.microsoft.com/office/drawing/2010/main" val="0"/>
@@ -3419,7 +4578,7 @@
         </p:blipFill>
         <p:spPr bwMode="auto">
           <a:xfrm>
-            <a:off x="161925" y="3690939"/>
+            <a:off x="494434" y="3690940"/>
             <a:ext cx="5053296" cy="2843212"/>
           </a:xfrm>
           <a:prstGeom prst="rect">
@@ -3451,7 +4610,7 @@
         </p:nvSpPr>
         <p:spPr>
           <a:xfrm>
-            <a:off x="0" y="2752915"/>
+            <a:off x="116172" y="2727515"/>
             <a:ext cx="2593063" cy="1445442"/>
           </a:xfrm>
           <a:prstGeom prst="cloud">
@@ -3500,7 +4659,7 @@
         </p:nvSpPr>
         <p:spPr>
           <a:xfrm>
-            <a:off x="2801089" y="1736613"/>
+            <a:off x="3021082" y="1904634"/>
             <a:ext cx="2414132" cy="1430448"/>
           </a:xfrm>
           <a:prstGeom prst="wedgeRectCallout">
@@ -3537,10 +4696,10 @@
       </p:sp>
       <p:sp>
         <p:nvSpPr>
-          <p:cNvPr id="6" name="Rectangle 5">
-            <a:extLst>
-              <a:ext uri="{FF2B5EF4-FFF2-40B4-BE49-F238E27FC236}">
-                <a16:creationId xmlns:a16="http://schemas.microsoft.com/office/drawing/2014/main" id="{E353CE8A-AB30-5564-F2BD-EECE9DC351D1}"/>
+          <p:cNvPr id="7" name="Rectangle: Rounded Corners 6">
+            <a:extLst>
+              <a:ext uri="{FF2B5EF4-FFF2-40B4-BE49-F238E27FC236}">
+                <a16:creationId xmlns:a16="http://schemas.microsoft.com/office/drawing/2014/main" id="{A952360B-AA0A-B99E-A742-05502A9FBCB4}"/>
               </a:ext>
             </a:extLst>
           </p:cNvPr>
@@ -3549,10 +4708,10 @@
         </p:nvSpPr>
         <p:spPr>
           <a:xfrm>
-            <a:off x="3708775" y="323849"/>
-            <a:ext cx="4019739" cy="807834"/>
-          </a:xfrm>
-          <a:prstGeom prst="rect">
+            <a:off x="6219506" y="2540686"/>
+            <a:ext cx="5053295" cy="1588792"/>
+          </a:xfrm>
+          <a:prstGeom prst="roundRect">
             <a:avLst/>
           </a:prstGeom>
         </p:spPr>
@@ -3578,18 +4737,22 @@
           <a:p>
             <a:pPr algn="ctr"/>
             <a:r>
-              <a:rPr lang="en-AU" sz="3000" dirty="0"/>
-              <a:t>Disaster Map</a:t>
-            </a:r>
-          </a:p>
-        </p:txBody>
-      </p:sp>
-      <p:sp>
-        <p:nvSpPr>
-          <p:cNvPr id="7" name="Rectangle: Rounded Corners 6">
-            <a:extLst>
-              <a:ext uri="{FF2B5EF4-FFF2-40B4-BE49-F238E27FC236}">
-                <a16:creationId xmlns:a16="http://schemas.microsoft.com/office/drawing/2014/main" id="{A952360B-AA0A-B99E-A742-05502A9FBCB4}"/>
+              <a:rPr lang="en-AU" sz="1600" b="1" u="sng" dirty="0"/>
+              <a:t>Concept:</a:t>
+            </a:r>
+            <a:r>
+              <a:rPr lang="en-AU" sz="1400" dirty="0"/>
+              <a:t> During major weather events, users can view, and report hazards they have witnessed including exact locations, descriptions and images.</a:t>
+            </a:r>
+          </a:p>
+        </p:txBody>
+      </p:sp>
+      <p:sp>
+        <p:nvSpPr>
+          <p:cNvPr id="8" name="Rectangle: Rounded Corners 7">
+            <a:extLst>
+              <a:ext uri="{FF2B5EF4-FFF2-40B4-BE49-F238E27FC236}">
+                <a16:creationId xmlns:a16="http://schemas.microsoft.com/office/drawing/2014/main" id="{52C01278-3E2A-2FA0-8E59-305F6A29AAF0}"/>
               </a:ext>
             </a:extLst>
           </p:cNvPr>
@@ -3598,8 +4761,8 @@
         </p:nvSpPr>
         <p:spPr>
           <a:xfrm>
-            <a:off x="8030425" y="1159505"/>
-            <a:ext cx="3595580" cy="1593410"/>
+            <a:off x="8958518" y="323849"/>
+            <a:ext cx="2266201" cy="1815879"/>
           </a:xfrm>
           <a:prstGeom prst="roundRect">
             <a:avLst/>
@@ -3625,24 +4788,69 @@
           <a:bodyPr rtlCol="0" anchor="ctr"/>
           <a:lstStyle/>
           <a:p>
-            <a:pPr algn="ctr"/>
             <a:r>
               <a:rPr lang="en-AU" sz="1600" b="1" u="sng" dirty="0"/>
-              <a:t>Concept:</a:t>
-            </a:r>
+              <a:t>Target Customers:</a:t>
+            </a:r>
+          </a:p>
+          <a:p>
+            <a:pPr marL="285750" indent="-285750">
+              <a:buFontTx/>
+              <a:buChar char="-"/>
+            </a:pPr>
             <a:r>
               <a:rPr lang="en-AU" sz="1400" dirty="0"/>
-              <a:t> During major weather events, users can view, and report hazards they have witnessed including exact locations, descriptions and images to go with it. </a:t>
-            </a:r>
-          </a:p>
-        </p:txBody>
-      </p:sp>
-      <p:sp>
-        <p:nvSpPr>
-          <p:cNvPr id="8" name="Rectangle: Rounded Corners 7">
-            <a:extLst>
-              <a:ext uri="{FF2B5EF4-FFF2-40B4-BE49-F238E27FC236}">
-                <a16:creationId xmlns:a16="http://schemas.microsoft.com/office/drawing/2014/main" id="{52C01278-3E2A-2FA0-8E59-305F6A29AAF0}"/>
+              <a:t>Commuters</a:t>
+            </a:r>
+          </a:p>
+          <a:p>
+            <a:pPr marL="285750" indent="-285750">
+              <a:buFontTx/>
+              <a:buChar char="-"/>
+            </a:pPr>
+            <a:r>
+              <a:rPr lang="en-AU" sz="1400" dirty="0"/>
+              <a:t>Travellers</a:t>
+            </a:r>
+          </a:p>
+          <a:p>
+            <a:pPr marL="285750" indent="-285750">
+              <a:buFontTx/>
+              <a:buChar char="-"/>
+            </a:pPr>
+            <a:r>
+              <a:rPr lang="en-AU" sz="1400" dirty="0"/>
+              <a:t>Logistics Companies</a:t>
+            </a:r>
+          </a:p>
+          <a:p>
+            <a:pPr marL="285750" indent="-285750">
+              <a:buFontTx/>
+              <a:buChar char="-"/>
+            </a:pPr>
+            <a:r>
+              <a:rPr lang="en-AU" sz="1400" dirty="0"/>
+              <a:t>Government Agencies</a:t>
+            </a:r>
+          </a:p>
+          <a:p>
+            <a:pPr marL="285750" indent="-285750">
+              <a:buFontTx/>
+              <a:buChar char="-"/>
+            </a:pPr>
+            <a:r>
+              <a:rPr lang="en-AU" sz="1400" dirty="0"/>
+              <a:t>SES</a:t>
+            </a:r>
+          </a:p>
+        </p:txBody>
+      </p:sp>
+      <p:sp>
+        <p:nvSpPr>
+          <p:cNvPr id="9" name="Rectangle: Rounded Corners 8">
+            <a:extLst>
+              <a:ext uri="{FF2B5EF4-FFF2-40B4-BE49-F238E27FC236}">
+                <a16:creationId xmlns:a16="http://schemas.microsoft.com/office/drawing/2014/main" id="{ED847631-9825-C933-5C77-A1E25AE5A169}"/>
               </a:ext>
             </a:extLst>
           </p:cNvPr>
@@ -3651,8 +4859,8 @@
         </p:nvSpPr>
         <p:spPr>
           <a:xfrm>
-            <a:off x="9334124" y="4105086"/>
-            <a:ext cx="2390114" cy="1815880"/>
+            <a:off x="5832193" y="4516948"/>
+            <a:ext cx="5865373" cy="1923123"/>
           </a:xfrm>
           <a:prstGeom prst="roundRect">
             <a:avLst/>
@@ -3681,117 +4889,54 @@
             <a:pPr algn="ctr"/>
             <a:r>
               <a:rPr lang="en-AU" sz="1600" b="1" u="sng" dirty="0"/>
-              <a:t>Target Customers:</a:t>
-            </a:r>
-          </a:p>
-          <a:p>
-            <a:pPr marL="285750" indent="-285750" algn="ctr">
-              <a:buFontTx/>
-              <a:buChar char="-"/>
-            </a:pPr>
+              <a:t>Solving the issue</a:t>
+            </a:r>
+          </a:p>
+          <a:p>
+            <a:pPr algn="ctr"/>
             <a:r>
               <a:rPr lang="en-AU" sz="1400" dirty="0"/>
-              <a:t>Commuters</a:t>
-            </a:r>
-          </a:p>
-          <a:p>
-            <a:pPr marL="285750" indent="-285750" algn="ctr">
-              <a:buFontTx/>
-              <a:buChar char="-"/>
-            </a:pPr>
-            <a:r>
-              <a:rPr lang="en-AU" sz="1400" dirty="0"/>
-              <a:t>Travellers</a:t>
-            </a:r>
-          </a:p>
-          <a:p>
-            <a:pPr marL="285750" indent="-285750" algn="ctr">
-              <a:buFontTx/>
-              <a:buChar char="-"/>
-            </a:pPr>
-            <a:r>
-              <a:rPr lang="en-AU" sz="1400" dirty="0"/>
-              <a:t>Logistics Companies</a:t>
-            </a:r>
-          </a:p>
-          <a:p>
-            <a:pPr marL="285750" indent="-285750" algn="ctr">
-              <a:buFontTx/>
-              <a:buChar char="-"/>
-            </a:pPr>
-            <a:r>
-              <a:rPr lang="en-AU" sz="1400" dirty="0"/>
-              <a:t>Government Agencies</a:t>
-            </a:r>
-          </a:p>
-          <a:p>
-            <a:pPr marL="285750" indent="-285750" algn="ctr">
-              <a:buFontTx/>
-              <a:buChar char="-"/>
-            </a:pPr>
-            <a:r>
-              <a:rPr lang="en-AU" sz="1400" dirty="0"/>
-              <a:t>SES</a:t>
-            </a:r>
-          </a:p>
-        </p:txBody>
-      </p:sp>
-      <p:sp>
-        <p:nvSpPr>
-          <p:cNvPr id="9" name="Rectangle: Rounded Corners 8">
-            <a:extLst>
-              <a:ext uri="{FF2B5EF4-FFF2-40B4-BE49-F238E27FC236}">
-                <a16:creationId xmlns:a16="http://schemas.microsoft.com/office/drawing/2014/main" id="{ED847631-9825-C933-5C77-A1E25AE5A169}"/>
-              </a:ext>
-            </a:extLst>
-          </p:cNvPr>
-          <p:cNvSpPr/>
+              <a:t>The Disaster Map can provide users of the road with vital information before starting their commute. Unlike navigational apps, users can identify the roads that are blocked due to flooding, fallen trees etc.</a:t>
+            </a:r>
+          </a:p>
+        </p:txBody>
+      </p:sp>
+      <p:pic>
+        <p:nvPicPr>
+          <p:cNvPr id="15" name="Picture 14" descr="A black and blue logo&#10;&#10;AI-generated content may be incorrect.">
+            <a:extLst>
+              <a:ext uri="{FF2B5EF4-FFF2-40B4-BE49-F238E27FC236}">
+                <a16:creationId xmlns:a16="http://schemas.microsoft.com/office/drawing/2014/main" id="{0177F9A6-E538-34A4-A8F0-3CC5D09B1C16}"/>
+              </a:ext>
+            </a:extLst>
+          </p:cNvPr>
+          <p:cNvPicPr>
+            <a:picLocks noChangeAspect="1"/>
+          </p:cNvPicPr>
           <p:nvPr/>
-        </p:nvSpPr>
+        </p:nvPicPr>
+        <p:blipFill>
+          <a:blip r:embed="rId5">
+            <a:extLst>
+              <a:ext uri="{28A0092B-C50C-407E-A947-70E740481C1C}">
+                <a14:useLocalDpi xmlns:a14="http://schemas.microsoft.com/office/drawing/2010/main" val="0"/>
+              </a:ext>
+            </a:extLst>
+          </a:blip>
+          <a:stretch>
+            <a:fillRect/>
+          </a:stretch>
+        </p:blipFill>
         <p:spPr>
           <a:xfrm>
-            <a:off x="5377146" y="4105086"/>
-            <a:ext cx="3595580" cy="2257188"/>
-          </a:xfrm>
-          <a:prstGeom prst="roundRect">
+            <a:off x="3177006" y="-33723"/>
+            <a:ext cx="5622882" cy="1938357"/>
+          </a:xfrm>
+          <a:prstGeom prst="rect">
             <a:avLst/>
           </a:prstGeom>
         </p:spPr>
-        <p:style>
-          <a:lnRef idx="2">
-            <a:schemeClr val="accent1">
-              <a:shade val="15000"/>
-            </a:schemeClr>
-          </a:lnRef>
-          <a:fillRef idx="1">
-            <a:schemeClr val="accent1"/>
-          </a:fillRef>
-          <a:effectRef idx="0">
-            <a:schemeClr val="accent1"/>
-          </a:effectRef>
-          <a:fontRef idx="minor">
-            <a:schemeClr val="lt1"/>
-          </a:fontRef>
-        </p:style>
-        <p:txBody>
-          <a:bodyPr rtlCol="0" anchor="ctr"/>
-          <a:lstStyle/>
-          <a:p>
-            <a:pPr algn="ctr"/>
-            <a:r>
-              <a:rPr lang="en-AU" sz="1600" b="1" u="sng" dirty="0"/>
-              <a:t>Solving the issue</a:t>
-            </a:r>
-          </a:p>
-          <a:p>
-            <a:pPr algn="ctr"/>
-            <a:r>
-              <a:rPr lang="en-AU" sz="1400" dirty="0"/>
-              <a:t>The Disaster Map can provide users of the road with vital information before starting their commute. Unlike navigational apps, users can identify the roads that are blocked due to flooding, fallen trees etc.</a:t>
-            </a:r>
-          </a:p>
-        </p:txBody>
-      </p:sp>
+      </p:pic>
     </p:spTree>
     <p:extLst>
       <p:ext uri="{BB962C8B-B14F-4D97-AF65-F5344CB8AC3E}">
@@ -3808,6 +4953,16 @@
 <file path=ppt/slides/slide2.xml><?xml version="1.0" encoding="utf-8"?>
 <p:sld xmlns:a="http://schemas.openxmlformats.org/drawingml/2006/main" xmlns:r="http://schemas.openxmlformats.org/officeDocument/2006/relationships" xmlns:p="http://schemas.openxmlformats.org/presentationml/2006/main">
   <p:cSld>
+    <p:bg>
+      <p:bgPr>
+        <a:solidFill>
+          <a:schemeClr val="bg1">
+            <a:lumMod val="95000"/>
+          </a:schemeClr>
+        </a:solidFill>
+        <a:effectLst/>
+      </p:bgPr>
+    </p:bg>
     <p:spTree>
       <p:nvGrpSpPr>
         <p:cNvPr id="1" name=""/>
@@ -3836,7 +4991,7 @@
         </p:nvSpPr>
         <p:spPr>
           <a:xfrm>
-            <a:off x="3490685" y="355657"/>
+            <a:off x="3418257" y="292418"/>
             <a:ext cx="4590107" cy="814812"/>
           </a:xfrm>
           <a:prstGeom prst="rect">
@@ -3877,214 +5032,6 @@
             <a:extLst>
               <a:ext uri="{FF2B5EF4-FFF2-40B4-BE49-F238E27FC236}">
                 <a16:creationId xmlns:a16="http://schemas.microsoft.com/office/drawing/2014/main" id="{7D409BFA-6F38-0236-87C8-A8B54208C332}"/>
-              </a:ext>
-            </a:extLst>
-          </p:cNvPr>
-          <p:cNvPicPr>
-            <a:picLocks noChangeAspect="1"/>
-          </p:cNvPicPr>
-          <p:nvPr/>
-        </p:nvPicPr>
-        <p:blipFill>
-          <a:blip r:embed="rId2"/>
-          <a:stretch>
-            <a:fillRect/>
-          </a:stretch>
-        </p:blipFill>
-        <p:spPr>
-          <a:xfrm>
-            <a:off x="344031" y="1978282"/>
-            <a:ext cx="2027976" cy="4226849"/>
-          </a:xfrm>
-          <a:prstGeom prst="rect">
-            <a:avLst/>
-          </a:prstGeom>
-        </p:spPr>
-      </p:pic>
-      <p:sp>
-        <p:nvSpPr>
-          <p:cNvPr id="7" name="Rectangle 6">
-            <a:extLst>
-              <a:ext uri="{FF2B5EF4-FFF2-40B4-BE49-F238E27FC236}">
-                <a16:creationId xmlns:a16="http://schemas.microsoft.com/office/drawing/2014/main" id="{6E346245-FB71-119F-9C82-D307D6D10966}"/>
-              </a:ext>
-            </a:extLst>
-          </p:cNvPr>
-          <p:cNvSpPr/>
-          <p:nvPr/>
-        </p:nvSpPr>
-        <p:spPr>
-          <a:xfrm>
-            <a:off x="344032" y="1403287"/>
-            <a:ext cx="1665743" cy="530288"/>
-          </a:xfrm>
-          <a:prstGeom prst="rect">
-            <a:avLst/>
-          </a:prstGeom>
-        </p:spPr>
-        <p:style>
-          <a:lnRef idx="2">
-            <a:schemeClr val="accent1">
-              <a:shade val="15000"/>
-            </a:schemeClr>
-          </a:lnRef>
-          <a:fillRef idx="1">
-            <a:schemeClr val="accent1"/>
-          </a:fillRef>
-          <a:effectRef idx="0">
-            <a:schemeClr val="accent1"/>
-          </a:effectRef>
-          <a:fontRef idx="minor">
-            <a:schemeClr val="lt1"/>
-          </a:fontRef>
-        </p:style>
-        <p:txBody>
-          <a:bodyPr rtlCol="0" anchor="ctr"/>
-          <a:lstStyle/>
-          <a:p>
-            <a:pPr algn="ctr"/>
-            <a:r>
-              <a:rPr lang="en-AU" sz="1000" dirty="0"/>
-              <a:t>Upon loading the app, a hazard appears within 50km radius of my location</a:t>
-            </a:r>
-          </a:p>
-        </p:txBody>
-      </p:sp>
-      <p:cxnSp>
-        <p:nvCxnSpPr>
-          <p:cNvPr id="11" name="Straight Arrow Connector 10">
-            <a:extLst>
-              <a:ext uri="{FF2B5EF4-FFF2-40B4-BE49-F238E27FC236}">
-                <a16:creationId xmlns:a16="http://schemas.microsoft.com/office/drawing/2014/main" id="{972B5FC9-FFF0-7135-BEC3-BEE4CC15AAE7}"/>
-              </a:ext>
-            </a:extLst>
-          </p:cNvPr>
-          <p:cNvCxnSpPr>
-            <a:cxnSpLocks/>
-          </p:cNvCxnSpPr>
-          <p:nvPr/>
-        </p:nvCxnSpPr>
-        <p:spPr>
-          <a:xfrm>
-            <a:off x="672786" y="1933575"/>
-            <a:ext cx="685233" cy="2057400"/>
-          </a:xfrm>
-          <a:prstGeom prst="straightConnector1">
-            <a:avLst/>
-          </a:prstGeom>
-          <a:ln w="28575">
-            <a:tailEnd type="triangle"/>
-          </a:ln>
-        </p:spPr>
-        <p:style>
-          <a:lnRef idx="2">
-            <a:schemeClr val="accent1"/>
-          </a:lnRef>
-          <a:fillRef idx="0">
-            <a:schemeClr val="accent1"/>
-          </a:fillRef>
-          <a:effectRef idx="1">
-            <a:schemeClr val="accent1"/>
-          </a:effectRef>
-          <a:fontRef idx="minor">
-            <a:schemeClr val="tx1"/>
-          </a:fontRef>
-        </p:style>
-      </p:cxnSp>
-      <p:sp>
-        <p:nvSpPr>
-          <p:cNvPr id="14" name="Rectangle 13">
-            <a:extLst>
-              <a:ext uri="{FF2B5EF4-FFF2-40B4-BE49-F238E27FC236}">
-                <a16:creationId xmlns:a16="http://schemas.microsoft.com/office/drawing/2014/main" id="{47385EFE-D98F-56D8-016B-A56D3A1A1B55}"/>
-              </a:ext>
-            </a:extLst>
-          </p:cNvPr>
-          <p:cNvSpPr/>
-          <p:nvPr/>
-        </p:nvSpPr>
-        <p:spPr>
-          <a:xfrm>
-            <a:off x="344031" y="6274370"/>
-            <a:ext cx="1781175" cy="476250"/>
-          </a:xfrm>
-          <a:prstGeom prst="rect">
-            <a:avLst/>
-          </a:prstGeom>
-        </p:spPr>
-        <p:style>
-          <a:lnRef idx="2">
-            <a:schemeClr val="accent1">
-              <a:shade val="15000"/>
-            </a:schemeClr>
-          </a:lnRef>
-          <a:fillRef idx="1">
-            <a:schemeClr val="accent1"/>
-          </a:fillRef>
-          <a:effectRef idx="0">
-            <a:schemeClr val="accent1"/>
-          </a:effectRef>
-          <a:fontRef idx="minor">
-            <a:schemeClr val="lt1"/>
-          </a:fontRef>
-        </p:style>
-        <p:txBody>
-          <a:bodyPr rtlCol="0" anchor="ctr"/>
-          <a:lstStyle/>
-          <a:p>
-            <a:pPr algn="ctr"/>
-            <a:r>
-              <a:rPr lang="en-AU" sz="1000" dirty="0"/>
-              <a:t>User can click the hazard icon to see the hazard details</a:t>
-            </a:r>
-          </a:p>
-        </p:txBody>
-      </p:sp>
-      <p:cxnSp>
-        <p:nvCxnSpPr>
-          <p:cNvPr id="17" name="Straight Arrow Connector 16">
-            <a:extLst>
-              <a:ext uri="{FF2B5EF4-FFF2-40B4-BE49-F238E27FC236}">
-                <a16:creationId xmlns:a16="http://schemas.microsoft.com/office/drawing/2014/main" id="{B596E924-03AE-EB2E-CEE0-24CCD0CA5418}"/>
-              </a:ext>
-            </a:extLst>
-          </p:cNvPr>
-          <p:cNvCxnSpPr/>
-          <p:nvPr/>
-        </p:nvCxnSpPr>
-        <p:spPr>
-          <a:xfrm flipV="1">
-            <a:off x="1358019" y="4091706"/>
-            <a:ext cx="80256" cy="2182664"/>
-          </a:xfrm>
-          <a:prstGeom prst="straightConnector1">
-            <a:avLst/>
-          </a:prstGeom>
-          <a:ln>
-            <a:tailEnd type="triangle"/>
-          </a:ln>
-        </p:spPr>
-        <p:style>
-          <a:lnRef idx="2">
-            <a:schemeClr val="accent1"/>
-          </a:lnRef>
-          <a:fillRef idx="0">
-            <a:schemeClr val="accent1"/>
-          </a:fillRef>
-          <a:effectRef idx="1">
-            <a:schemeClr val="accent1"/>
-          </a:effectRef>
-          <a:fontRef idx="minor">
-            <a:schemeClr val="tx1"/>
-          </a:fontRef>
-        </p:style>
-      </p:cxnSp>
-      <p:pic>
-        <p:nvPicPr>
-          <p:cNvPr id="19" name="Picture 18">
-            <a:extLst>
-              <a:ext uri="{FF2B5EF4-FFF2-40B4-BE49-F238E27FC236}">
-                <a16:creationId xmlns:a16="http://schemas.microsoft.com/office/drawing/2014/main" id="{6E813A37-78F6-0F99-DBCC-27DA19E671DF}"/>
               </a:ext>
             </a:extLst>
           </p:cNvPr>
@@ -4101,87 +5048,37 @@
         </p:blipFill>
         <p:spPr>
           <a:xfrm>
-            <a:off x="2707705" y="1962150"/>
-            <a:ext cx="2027975" cy="4226849"/>
+            <a:off x="344031" y="1978282"/>
+            <a:ext cx="2027976" cy="4226849"/>
           </a:xfrm>
           <a:prstGeom prst="rect">
             <a:avLst/>
           </a:prstGeom>
         </p:spPr>
       </p:pic>
-      <p:sp>
-        <p:nvSpPr>
-          <p:cNvPr id="20" name="Rectangle 19">
-            <a:extLst>
-              <a:ext uri="{FF2B5EF4-FFF2-40B4-BE49-F238E27FC236}">
-                <a16:creationId xmlns:a16="http://schemas.microsoft.com/office/drawing/2014/main" id="{185B9085-6782-2FD9-653B-90F3FAFD2D10}"/>
-              </a:ext>
-            </a:extLst>
-          </p:cNvPr>
-          <p:cNvSpPr/>
-          <p:nvPr/>
-        </p:nvSpPr>
-        <p:spPr>
-          <a:xfrm>
-            <a:off x="2935808" y="6235496"/>
-            <a:ext cx="1425474" cy="476250"/>
-          </a:xfrm>
-          <a:prstGeom prst="rect">
-            <a:avLst/>
-          </a:prstGeom>
-        </p:spPr>
-        <p:style>
-          <a:lnRef idx="2">
-            <a:schemeClr val="accent1">
-              <a:shade val="15000"/>
-            </a:schemeClr>
-          </a:lnRef>
-          <a:fillRef idx="1">
-            <a:schemeClr val="accent1"/>
-          </a:fillRef>
-          <a:effectRef idx="0">
-            <a:schemeClr val="accent1"/>
-          </a:effectRef>
-          <a:fontRef idx="minor">
-            <a:schemeClr val="lt1"/>
-          </a:fontRef>
-        </p:style>
-        <p:txBody>
-          <a:bodyPr rtlCol="0" anchor="ctr"/>
-          <a:lstStyle/>
-          <a:p>
-            <a:pPr algn="ctr"/>
-            <a:r>
-              <a:rPr lang="en-AU" sz="1000" dirty="0"/>
-              <a:t>User can mark the hazard if it’s still there </a:t>
-            </a:r>
-          </a:p>
-        </p:txBody>
-      </p:sp>
       <p:cxnSp>
         <p:nvCxnSpPr>
-          <p:cNvPr id="22" name="Straight Arrow Connector 21">
-            <a:extLst>
-              <a:ext uri="{FF2B5EF4-FFF2-40B4-BE49-F238E27FC236}">
-                <a16:creationId xmlns:a16="http://schemas.microsoft.com/office/drawing/2014/main" id="{F6636963-75A5-A5EA-545B-826B2B3DD0D0}"/>
+          <p:cNvPr id="11" name="Straight Arrow Connector 10">
+            <a:extLst>
+              <a:ext uri="{FF2B5EF4-FFF2-40B4-BE49-F238E27FC236}">
+                <a16:creationId xmlns:a16="http://schemas.microsoft.com/office/drawing/2014/main" id="{972B5FC9-FFF0-7135-BEC3-BEE4CC15AAE7}"/>
               </a:ext>
             </a:extLst>
           </p:cNvPr>
           <p:cNvCxnSpPr>
             <a:cxnSpLocks/>
-            <a:stCxn id="20" idx="0"/>
           </p:cNvCxnSpPr>
           <p:nvPr/>
         </p:nvCxnSpPr>
         <p:spPr>
-          <a:xfrm flipV="1">
-            <a:off x="3648545" y="5514201"/>
-            <a:ext cx="70731" cy="721295"/>
+          <a:xfrm>
+            <a:off x="1208344" y="1906556"/>
+            <a:ext cx="149675" cy="2049808"/>
           </a:xfrm>
           <a:prstGeom prst="straightConnector1">
             <a:avLst/>
           </a:prstGeom>
-          <a:ln>
+          <a:ln w="28575">
             <a:tailEnd type="triangle"/>
           </a:ln>
         </p:spPr>
@@ -4200,61 +5097,12 @@
           </a:fontRef>
         </p:style>
       </p:cxnSp>
-      <p:sp>
-        <p:nvSpPr>
-          <p:cNvPr id="23" name="Rectangle 22">
-            <a:extLst>
-              <a:ext uri="{FF2B5EF4-FFF2-40B4-BE49-F238E27FC236}">
-                <a16:creationId xmlns:a16="http://schemas.microsoft.com/office/drawing/2014/main" id="{AF54027E-CCD4-F16B-2FC0-F9A357C61A92}"/>
-              </a:ext>
-            </a:extLst>
-          </p:cNvPr>
-          <p:cNvSpPr/>
-          <p:nvPr/>
-        </p:nvSpPr>
-        <p:spPr>
-          <a:xfrm>
-            <a:off x="2974544" y="1430306"/>
-            <a:ext cx="1438275" cy="476250"/>
-          </a:xfrm>
-          <a:prstGeom prst="rect">
-            <a:avLst/>
-          </a:prstGeom>
-        </p:spPr>
-        <p:style>
-          <a:lnRef idx="2">
-            <a:schemeClr val="accent1">
-              <a:shade val="15000"/>
-            </a:schemeClr>
-          </a:lnRef>
-          <a:fillRef idx="1">
-            <a:schemeClr val="accent1"/>
-          </a:fillRef>
-          <a:effectRef idx="0">
-            <a:schemeClr val="accent1"/>
-          </a:effectRef>
-          <a:fontRef idx="minor">
-            <a:schemeClr val="lt1"/>
-          </a:fontRef>
-        </p:style>
-        <p:txBody>
-          <a:bodyPr rtlCol="0" anchor="ctr"/>
-          <a:lstStyle/>
-          <a:p>
-            <a:pPr algn="ctr"/>
-            <a:r>
-              <a:rPr lang="en-AU" sz="1000" dirty="0"/>
-              <a:t>Data is retrieved from the Firestore table</a:t>
-            </a:r>
-          </a:p>
-        </p:txBody>
-      </p:sp>
       <p:cxnSp>
         <p:nvCxnSpPr>
-          <p:cNvPr id="25" name="Straight Arrow Connector 24">
-            <a:extLst>
-              <a:ext uri="{FF2B5EF4-FFF2-40B4-BE49-F238E27FC236}">
-                <a16:creationId xmlns:a16="http://schemas.microsoft.com/office/drawing/2014/main" id="{2E5D435C-F49E-B040-DA73-B90A0C8DAB18}"/>
+          <p:cNvPr id="17" name="Straight Arrow Connector 16">
+            <a:extLst>
+              <a:ext uri="{FF2B5EF4-FFF2-40B4-BE49-F238E27FC236}">
+                <a16:creationId xmlns:a16="http://schemas.microsoft.com/office/drawing/2014/main" id="{B596E924-03AE-EB2E-CEE0-24CCD0CA5418}"/>
               </a:ext>
             </a:extLst>
           </p:cNvPr>
@@ -4262,9 +5110,9 @@
           <p:nvPr/>
         </p:nvCxnSpPr>
         <p:spPr>
-          <a:xfrm flipH="1">
-            <a:off x="3552825" y="1909041"/>
-            <a:ext cx="66675" cy="1405659"/>
+          <a:xfrm flipV="1">
+            <a:off x="1358019" y="4091706"/>
+            <a:ext cx="80256" cy="2182664"/>
           </a:xfrm>
           <a:prstGeom prst="straightConnector1">
             <a:avLst/>
@@ -4290,114 +5138,10 @@
       </p:cxnSp>
       <p:pic>
         <p:nvPicPr>
-          <p:cNvPr id="28" name="Picture 27">
-            <a:extLst>
-              <a:ext uri="{FF2B5EF4-FFF2-40B4-BE49-F238E27FC236}">
-                <a16:creationId xmlns:a16="http://schemas.microsoft.com/office/drawing/2014/main" id="{1440923B-7E02-2D4D-61B3-F7108ADEA5AB}"/>
-              </a:ext>
-            </a:extLst>
-          </p:cNvPr>
-          <p:cNvPicPr>
-            <a:picLocks noChangeAspect="1"/>
-          </p:cNvPicPr>
-          <p:nvPr/>
-        </p:nvPicPr>
-        <p:blipFill>
-          <a:blip r:embed="rId2"/>
-          <a:stretch>
-            <a:fillRect/>
-          </a:stretch>
-        </p:blipFill>
-        <p:spPr>
-          <a:xfrm>
-            <a:off x="5071378" y="1952624"/>
-            <a:ext cx="2027976" cy="4226849"/>
-          </a:xfrm>
-          <a:prstGeom prst="rect">
-            <a:avLst/>
-          </a:prstGeom>
-        </p:spPr>
-      </p:pic>
-      <p:sp>
-        <p:nvSpPr>
-          <p:cNvPr id="29" name="TextBox 28">
-            <a:extLst>
-              <a:ext uri="{FF2B5EF4-FFF2-40B4-BE49-F238E27FC236}">
-                <a16:creationId xmlns:a16="http://schemas.microsoft.com/office/drawing/2014/main" id="{4C03EE37-2287-4C96-C293-E16296FEDF50}"/>
-              </a:ext>
-            </a:extLst>
-          </p:cNvPr>
-          <p:cNvSpPr txBox="1"/>
-          <p:nvPr/>
-        </p:nvSpPr>
-        <p:spPr>
-          <a:xfrm>
-            <a:off x="5333280" y="6196622"/>
-            <a:ext cx="1552575" cy="553998"/>
-          </a:xfrm>
-          <a:prstGeom prst="rect">
-            <a:avLst/>
-          </a:prstGeom>
-          <a:noFill/>
-        </p:spPr>
-        <p:txBody>
-          <a:bodyPr wrap="square" rtlCol="0">
-            <a:spAutoFit/>
-          </a:bodyPr>
-          <a:lstStyle/>
-          <a:p>
-            <a:r>
-              <a:rPr lang="en-AU" sz="1000" dirty="0"/>
-              <a:t>A user can navigate to the Search page to find hazards in other areas</a:t>
-            </a:r>
-          </a:p>
-        </p:txBody>
-      </p:sp>
-      <p:cxnSp>
-        <p:nvCxnSpPr>
-          <p:cNvPr id="31" name="Straight Arrow Connector 30">
-            <a:extLst>
-              <a:ext uri="{FF2B5EF4-FFF2-40B4-BE49-F238E27FC236}">
-                <a16:creationId xmlns:a16="http://schemas.microsoft.com/office/drawing/2014/main" id="{196770D0-BAD2-B2B4-E5AD-BC8CCF70BA15}"/>
-              </a:ext>
-            </a:extLst>
-          </p:cNvPr>
-          <p:cNvCxnSpPr/>
-          <p:nvPr/>
-        </p:nvCxnSpPr>
-        <p:spPr>
-          <a:xfrm flipV="1">
-            <a:off x="5857875" y="5961876"/>
-            <a:ext cx="0" cy="273620"/>
-          </a:xfrm>
-          <a:prstGeom prst="straightConnector1">
-            <a:avLst/>
-          </a:prstGeom>
-          <a:ln w="38100">
-            <a:tailEnd type="triangle"/>
-          </a:ln>
-        </p:spPr>
-        <p:style>
-          <a:lnRef idx="2">
-            <a:schemeClr val="accent1"/>
-          </a:lnRef>
-          <a:fillRef idx="0">
-            <a:schemeClr val="accent1"/>
-          </a:fillRef>
-          <a:effectRef idx="1">
-            <a:schemeClr val="accent1"/>
-          </a:effectRef>
-          <a:fontRef idx="minor">
-            <a:schemeClr val="tx1"/>
-          </a:fontRef>
-        </p:style>
-      </p:cxnSp>
-      <p:pic>
-        <p:nvPicPr>
-          <p:cNvPr id="34" name="Picture 33">
-            <a:extLst>
-              <a:ext uri="{FF2B5EF4-FFF2-40B4-BE49-F238E27FC236}">
-                <a16:creationId xmlns:a16="http://schemas.microsoft.com/office/drawing/2014/main" id="{733BC382-83CB-BFFF-7882-98EC68DAFBB2}"/>
+          <p:cNvPr id="19" name="Picture 18">
+            <a:extLst>
+              <a:ext uri="{FF2B5EF4-FFF2-40B4-BE49-F238E27FC236}">
+                <a16:creationId xmlns:a16="http://schemas.microsoft.com/office/drawing/2014/main" id="{6E813A37-78F6-0F99-DBCC-27DA19E671DF}"/>
               </a:ext>
             </a:extLst>
           </p:cNvPr>
@@ -4414,65 +5158,32 @@
         </p:blipFill>
         <p:spPr>
           <a:xfrm>
-            <a:off x="7442254" y="1964424"/>
-            <a:ext cx="2027976" cy="4226089"/>
+            <a:off x="2707705" y="1962150"/>
+            <a:ext cx="2027975" cy="4226849"/>
           </a:xfrm>
           <a:prstGeom prst="rect">
             <a:avLst/>
           </a:prstGeom>
         </p:spPr>
       </p:pic>
-      <p:sp>
-        <p:nvSpPr>
-          <p:cNvPr id="35" name="TextBox 34">
-            <a:extLst>
-              <a:ext uri="{FF2B5EF4-FFF2-40B4-BE49-F238E27FC236}">
-                <a16:creationId xmlns:a16="http://schemas.microsoft.com/office/drawing/2014/main" id="{A58FE050-540F-1FA4-5FBF-D7A2BAE38526}"/>
-              </a:ext>
-            </a:extLst>
-          </p:cNvPr>
-          <p:cNvSpPr txBox="1"/>
-          <p:nvPr/>
-        </p:nvSpPr>
-        <p:spPr>
-          <a:xfrm>
-            <a:off x="7623229" y="1424284"/>
-            <a:ext cx="1617410" cy="553998"/>
-          </a:xfrm>
-          <a:prstGeom prst="rect">
-            <a:avLst/>
-          </a:prstGeom>
-          <a:noFill/>
-        </p:spPr>
-        <p:txBody>
-          <a:bodyPr wrap="square" rtlCol="0">
-            <a:spAutoFit/>
-          </a:bodyPr>
-          <a:lstStyle/>
-          <a:p>
-            <a:r>
-              <a:rPr lang="en-AU" sz="1000" dirty="0"/>
-              <a:t>A user can search any area they like to see if any hazards are in the area</a:t>
-            </a:r>
-          </a:p>
-        </p:txBody>
-      </p:sp>
       <p:cxnSp>
         <p:nvCxnSpPr>
-          <p:cNvPr id="37" name="Straight Arrow Connector 36">
-            <a:extLst>
-              <a:ext uri="{FF2B5EF4-FFF2-40B4-BE49-F238E27FC236}">
-                <a16:creationId xmlns:a16="http://schemas.microsoft.com/office/drawing/2014/main" id="{0D0A890C-A775-4CCC-598C-6F79A40F9135}"/>
-              </a:ext>
-            </a:extLst>
-          </p:cNvPr>
-          <p:cNvCxnSpPr/>
+          <p:cNvPr id="22" name="Straight Arrow Connector 21">
+            <a:extLst>
+              <a:ext uri="{FF2B5EF4-FFF2-40B4-BE49-F238E27FC236}">
+                <a16:creationId xmlns:a16="http://schemas.microsoft.com/office/drawing/2014/main" id="{F6636963-75A5-A5EA-545B-826B2B3DD0D0}"/>
+              </a:ext>
+            </a:extLst>
+          </p:cNvPr>
+          <p:cNvCxnSpPr>
+            <a:cxnSpLocks/>
+          </p:cNvCxnSpPr>
           <p:nvPr/>
         </p:nvCxnSpPr>
         <p:spPr>
-          <a:xfrm flipH="1">
-            <a:off x="8284296" y="1906556"/>
-            <a:ext cx="180975" cy="705314"/>
+          <a:xfrm flipV="1">
+            <a:off x="3648545" y="5514201"/>
+            <a:ext cx="70731" cy="721295"/>
           </a:xfrm>
           <a:prstGeom prst="straightConnector1">
             <a:avLst/>
@@ -4496,111 +5207,22 @@
           </a:fontRef>
         </p:style>
       </p:cxnSp>
-      <p:sp>
-        <p:nvSpPr>
-          <p:cNvPr id="38" name="Oval 37">
-            <a:extLst>
-              <a:ext uri="{FF2B5EF4-FFF2-40B4-BE49-F238E27FC236}">
-                <a16:creationId xmlns:a16="http://schemas.microsoft.com/office/drawing/2014/main" id="{744F198B-C3AC-257F-B8B9-268D987849F5}"/>
-              </a:ext>
-            </a:extLst>
-          </p:cNvPr>
-          <p:cNvSpPr/>
-          <p:nvPr/>
-        </p:nvSpPr>
-        <p:spPr>
-          <a:xfrm>
-            <a:off x="8080792" y="4903827"/>
-            <a:ext cx="395288" cy="361950"/>
-          </a:xfrm>
-          <a:prstGeom prst="ellipse">
-            <a:avLst/>
-          </a:prstGeom>
-          <a:noFill/>
-          <a:ln>
-            <a:solidFill>
-              <a:srgbClr val="FF0000"/>
-            </a:solidFill>
-          </a:ln>
-        </p:spPr>
-        <p:style>
-          <a:lnRef idx="2">
-            <a:schemeClr val="accent1">
-              <a:shade val="15000"/>
-            </a:schemeClr>
-          </a:lnRef>
-          <a:fillRef idx="1">
-            <a:schemeClr val="accent1"/>
-          </a:fillRef>
-          <a:effectRef idx="0">
-            <a:schemeClr val="accent1"/>
-          </a:effectRef>
-          <a:fontRef idx="minor">
-            <a:schemeClr val="lt1"/>
-          </a:fontRef>
-        </p:style>
-        <p:txBody>
-          <a:bodyPr rtlCol="0" anchor="ctr"/>
-          <a:lstStyle/>
-          <a:p>
-            <a:pPr algn="ctr"/>
-            <a:endParaRPr lang="en-AU"/>
-          </a:p>
-        </p:txBody>
-      </p:sp>
-      <p:sp>
-        <p:nvSpPr>
-          <p:cNvPr id="39" name="TextBox 38">
-            <a:extLst>
-              <a:ext uri="{FF2B5EF4-FFF2-40B4-BE49-F238E27FC236}">
-                <a16:creationId xmlns:a16="http://schemas.microsoft.com/office/drawing/2014/main" id="{6F499D87-2B5E-993E-C4EE-711A0D485B3F}"/>
-              </a:ext>
-            </a:extLst>
-          </p:cNvPr>
-          <p:cNvSpPr txBox="1"/>
-          <p:nvPr/>
-        </p:nvSpPr>
-        <p:spPr>
-          <a:xfrm>
-            <a:off x="7569356" y="6205131"/>
-            <a:ext cx="1822693" cy="553998"/>
-          </a:xfrm>
-          <a:prstGeom prst="rect">
-            <a:avLst/>
-          </a:prstGeom>
-          <a:noFill/>
-        </p:spPr>
-        <p:txBody>
-          <a:bodyPr wrap="square" rtlCol="0">
-            <a:spAutoFit/>
-          </a:bodyPr>
-          <a:lstStyle/>
-          <a:p>
-            <a:r>
-              <a:rPr lang="en-AU" sz="1000" dirty="0"/>
-              <a:t>A user can identify a hazard on the map indicated by the droplet “flood”</a:t>
-            </a:r>
-          </a:p>
-        </p:txBody>
-      </p:sp>
       <p:cxnSp>
         <p:nvCxnSpPr>
-          <p:cNvPr id="41" name="Straight Arrow Connector 40">
-            <a:extLst>
-              <a:ext uri="{FF2B5EF4-FFF2-40B4-BE49-F238E27FC236}">
-                <a16:creationId xmlns:a16="http://schemas.microsoft.com/office/drawing/2014/main" id="{71E7E364-F612-0CEE-8942-C58F9654B2D2}"/>
-              </a:ext>
-            </a:extLst>
-          </p:cNvPr>
-          <p:cNvCxnSpPr>
-            <a:endCxn id="38" idx="4"/>
-          </p:cNvCxnSpPr>
+          <p:cNvPr id="25" name="Straight Arrow Connector 24">
+            <a:extLst>
+              <a:ext uri="{FF2B5EF4-FFF2-40B4-BE49-F238E27FC236}">
+                <a16:creationId xmlns:a16="http://schemas.microsoft.com/office/drawing/2014/main" id="{2E5D435C-F49E-B040-DA73-B90A0C8DAB18}"/>
+              </a:ext>
+            </a:extLst>
+          </p:cNvPr>
+          <p:cNvCxnSpPr/>
           <p:nvPr/>
         </p:nvCxnSpPr>
         <p:spPr>
-          <a:xfrm flipV="1">
-            <a:off x="8247480" y="5265777"/>
-            <a:ext cx="30956" cy="978470"/>
+          <a:xfrm flipH="1">
+            <a:off x="3552825" y="1909041"/>
+            <a:ext cx="66675" cy="1405659"/>
           </a:xfrm>
           <a:prstGeom prst="straightConnector1">
             <a:avLst/>
@@ -4626,10 +5248,114 @@
       </p:cxnSp>
       <p:pic>
         <p:nvPicPr>
-          <p:cNvPr id="43" name="Picture 42">
-            <a:extLst>
-              <a:ext uri="{FF2B5EF4-FFF2-40B4-BE49-F238E27FC236}">
-                <a16:creationId xmlns:a16="http://schemas.microsoft.com/office/drawing/2014/main" id="{D1560A5B-77E5-677F-4C25-7AC9CC5A78AE}"/>
+          <p:cNvPr id="28" name="Picture 27">
+            <a:extLst>
+              <a:ext uri="{FF2B5EF4-FFF2-40B4-BE49-F238E27FC236}">
+                <a16:creationId xmlns:a16="http://schemas.microsoft.com/office/drawing/2014/main" id="{1440923B-7E02-2D4D-61B3-F7108ADEA5AB}"/>
+              </a:ext>
+            </a:extLst>
+          </p:cNvPr>
+          <p:cNvPicPr>
+            <a:picLocks noChangeAspect="1"/>
+          </p:cNvPicPr>
+          <p:nvPr/>
+        </p:nvPicPr>
+        <p:blipFill>
+          <a:blip r:embed="rId3"/>
+          <a:stretch>
+            <a:fillRect/>
+          </a:stretch>
+        </p:blipFill>
+        <p:spPr>
+          <a:xfrm>
+            <a:off x="5071378" y="1952624"/>
+            <a:ext cx="2027976" cy="4226849"/>
+          </a:xfrm>
+          <a:prstGeom prst="rect">
+            <a:avLst/>
+          </a:prstGeom>
+        </p:spPr>
+      </p:pic>
+      <p:sp>
+        <p:nvSpPr>
+          <p:cNvPr id="29" name="TextBox 28">
+            <a:extLst>
+              <a:ext uri="{FF2B5EF4-FFF2-40B4-BE49-F238E27FC236}">
+                <a16:creationId xmlns:a16="http://schemas.microsoft.com/office/drawing/2014/main" id="{4C03EE37-2287-4C96-C293-E16296FEDF50}"/>
+              </a:ext>
+            </a:extLst>
+          </p:cNvPr>
+          <p:cNvSpPr txBox="1"/>
+          <p:nvPr/>
+        </p:nvSpPr>
+        <p:spPr>
+          <a:xfrm>
+            <a:off x="5333280" y="6196622"/>
+            <a:ext cx="1552575" cy="553998"/>
+          </a:xfrm>
+          <a:prstGeom prst="rect">
+            <a:avLst/>
+          </a:prstGeom>
+          <a:noFill/>
+        </p:spPr>
+        <p:txBody>
+          <a:bodyPr wrap="square" rtlCol="0">
+            <a:spAutoFit/>
+          </a:bodyPr>
+          <a:lstStyle/>
+          <a:p>
+            <a:r>
+              <a:rPr lang="en-AU" sz="1000" dirty="0"/>
+              <a:t>A user can navigate to the Search page to find hazards in other areas</a:t>
+            </a:r>
+          </a:p>
+        </p:txBody>
+      </p:sp>
+      <p:cxnSp>
+        <p:nvCxnSpPr>
+          <p:cNvPr id="31" name="Straight Arrow Connector 30">
+            <a:extLst>
+              <a:ext uri="{FF2B5EF4-FFF2-40B4-BE49-F238E27FC236}">
+                <a16:creationId xmlns:a16="http://schemas.microsoft.com/office/drawing/2014/main" id="{196770D0-BAD2-B2B4-E5AD-BC8CCF70BA15}"/>
+              </a:ext>
+            </a:extLst>
+          </p:cNvPr>
+          <p:cNvCxnSpPr/>
+          <p:nvPr/>
+        </p:nvCxnSpPr>
+        <p:spPr>
+          <a:xfrm flipV="1">
+            <a:off x="5857875" y="5961876"/>
+            <a:ext cx="0" cy="273620"/>
+          </a:xfrm>
+          <a:prstGeom prst="straightConnector1">
+            <a:avLst/>
+          </a:prstGeom>
+          <a:ln w="38100">
+            <a:tailEnd type="triangle"/>
+          </a:ln>
+        </p:spPr>
+        <p:style>
+          <a:lnRef idx="2">
+            <a:schemeClr val="accent1"/>
+          </a:lnRef>
+          <a:fillRef idx="0">
+            <a:schemeClr val="accent1"/>
+          </a:fillRef>
+          <a:effectRef idx="1">
+            <a:schemeClr val="accent1"/>
+          </a:effectRef>
+          <a:fontRef idx="minor">
+            <a:schemeClr val="tx1"/>
+          </a:fontRef>
+        </p:style>
+      </p:cxnSp>
+      <p:pic>
+        <p:nvPicPr>
+          <p:cNvPr id="34" name="Picture 33">
+            <a:extLst>
+              <a:ext uri="{FF2B5EF4-FFF2-40B4-BE49-F238E27FC236}">
+                <a16:creationId xmlns:a16="http://schemas.microsoft.com/office/drawing/2014/main" id="{733BC382-83CB-BFFF-7882-98EC68DAFBB2}"/>
               </a:ext>
             </a:extLst>
           </p:cNvPr>
@@ -4646,8 +5372,8 @@
         </p:blipFill>
         <p:spPr>
           <a:xfrm>
-            <a:off x="9775030" y="1962150"/>
-            <a:ext cx="2009980" cy="4230638"/>
+            <a:off x="7442254" y="1964424"/>
+            <a:ext cx="2027976" cy="4226089"/>
           </a:xfrm>
           <a:prstGeom prst="rect">
             <a:avLst/>
@@ -4656,10 +5382,10 @@
       </p:pic>
       <p:sp>
         <p:nvSpPr>
-          <p:cNvPr id="44" name="TextBox 43">
-            <a:extLst>
-              <a:ext uri="{FF2B5EF4-FFF2-40B4-BE49-F238E27FC236}">
-                <a16:creationId xmlns:a16="http://schemas.microsoft.com/office/drawing/2014/main" id="{B024EE8A-4D89-BC6E-2932-9A9BDBCCA3B9}"/>
+          <p:cNvPr id="35" name="TextBox 34">
+            <a:extLst>
+              <a:ext uri="{FF2B5EF4-FFF2-40B4-BE49-F238E27FC236}">
+                <a16:creationId xmlns:a16="http://schemas.microsoft.com/office/drawing/2014/main" id="{A58FE050-540F-1FA4-5FBF-D7A2BAE38526}"/>
               </a:ext>
             </a:extLst>
           </p:cNvPr>
@@ -4668,8 +5394,8 @@
         </p:nvSpPr>
         <p:spPr>
           <a:xfrm>
-            <a:off x="9764514" y="1352558"/>
-            <a:ext cx="2124075" cy="553998"/>
+            <a:off x="7623229" y="1424284"/>
+            <a:ext cx="1617410" cy="553998"/>
           </a:xfrm>
           <a:prstGeom prst="rect">
             <a:avLst/>
@@ -4684,17 +5410,17 @@
           <a:p>
             <a:r>
               <a:rPr lang="en-AU" sz="1000" dirty="0"/>
-              <a:t>A user can see the details attached to this hazard by selecting the droplet icon on the map</a:t>
+              <a:t>A user can search any area they like to see if any hazards are in the area</a:t>
             </a:r>
           </a:p>
         </p:txBody>
       </p:sp>
       <p:cxnSp>
         <p:nvCxnSpPr>
-          <p:cNvPr id="46" name="Straight Arrow Connector 45">
-            <a:extLst>
-              <a:ext uri="{FF2B5EF4-FFF2-40B4-BE49-F238E27FC236}">
-                <a16:creationId xmlns:a16="http://schemas.microsoft.com/office/drawing/2014/main" id="{1E0934C5-E86E-2A76-072C-2A75D56B892D}"/>
+          <p:cNvPr id="37" name="Straight Arrow Connector 36">
+            <a:extLst>
+              <a:ext uri="{FF2B5EF4-FFF2-40B4-BE49-F238E27FC236}">
+                <a16:creationId xmlns:a16="http://schemas.microsoft.com/office/drawing/2014/main" id="{0D0A890C-A775-4CCC-598C-6F79A40F9135}"/>
               </a:ext>
             </a:extLst>
           </p:cNvPr>
@@ -4702,9 +5428,9 @@
           <p:nvPr/>
         </p:nvCxnSpPr>
         <p:spPr>
-          <a:xfrm>
-            <a:off x="10629900" y="1906556"/>
-            <a:ext cx="0" cy="1465294"/>
+          <a:xfrm flipH="1">
+            <a:off x="8284296" y="1906556"/>
+            <a:ext cx="180975" cy="705314"/>
           </a:xfrm>
           <a:prstGeom prst="straightConnector1">
             <a:avLst/>
@@ -4730,10 +5456,62 @@
       </p:cxnSp>
       <p:sp>
         <p:nvSpPr>
-          <p:cNvPr id="47" name="TextBox 46">
-            <a:extLst>
-              <a:ext uri="{FF2B5EF4-FFF2-40B4-BE49-F238E27FC236}">
-                <a16:creationId xmlns:a16="http://schemas.microsoft.com/office/drawing/2014/main" id="{A62D59F5-749A-F38E-BF5B-6299087C07A5}"/>
+          <p:cNvPr id="38" name="Oval 37">
+            <a:extLst>
+              <a:ext uri="{FF2B5EF4-FFF2-40B4-BE49-F238E27FC236}">
+                <a16:creationId xmlns:a16="http://schemas.microsoft.com/office/drawing/2014/main" id="{744F198B-C3AC-257F-B8B9-268D987849F5}"/>
+              </a:ext>
+            </a:extLst>
+          </p:cNvPr>
+          <p:cNvSpPr/>
+          <p:nvPr/>
+        </p:nvSpPr>
+        <p:spPr>
+          <a:xfrm>
+            <a:off x="8080792" y="4903827"/>
+            <a:ext cx="395288" cy="361950"/>
+          </a:xfrm>
+          <a:prstGeom prst="ellipse">
+            <a:avLst/>
+          </a:prstGeom>
+          <a:noFill/>
+          <a:ln>
+            <a:solidFill>
+              <a:srgbClr val="FF0000"/>
+            </a:solidFill>
+          </a:ln>
+        </p:spPr>
+        <p:style>
+          <a:lnRef idx="2">
+            <a:schemeClr val="accent1">
+              <a:shade val="15000"/>
+            </a:schemeClr>
+          </a:lnRef>
+          <a:fillRef idx="1">
+            <a:schemeClr val="accent1"/>
+          </a:fillRef>
+          <a:effectRef idx="0">
+            <a:schemeClr val="accent1"/>
+          </a:effectRef>
+          <a:fontRef idx="minor">
+            <a:schemeClr val="lt1"/>
+          </a:fontRef>
+        </p:style>
+        <p:txBody>
+          <a:bodyPr rtlCol="0" anchor="ctr"/>
+          <a:lstStyle/>
+          <a:p>
+            <a:pPr algn="ctr"/>
+            <a:endParaRPr lang="en-AU"/>
+          </a:p>
+        </p:txBody>
+      </p:sp>
+      <p:sp>
+        <p:nvSpPr>
+          <p:cNvPr id="39" name="TextBox 38">
+            <a:extLst>
+              <a:ext uri="{FF2B5EF4-FFF2-40B4-BE49-F238E27FC236}">
+                <a16:creationId xmlns:a16="http://schemas.microsoft.com/office/drawing/2014/main" id="{6F499D87-2B5E-993E-C4EE-711A0D485B3F}"/>
               </a:ext>
             </a:extLst>
           </p:cNvPr>
@@ -4742,8 +5520,8 @@
         </p:nvSpPr>
         <p:spPr>
           <a:xfrm>
-            <a:off x="9619490" y="6244247"/>
-            <a:ext cx="2572510" cy="553998"/>
+            <a:off x="7569356" y="6205131"/>
+            <a:ext cx="1822693" cy="553998"/>
           </a:xfrm>
           <a:prstGeom prst="rect">
             <a:avLst/>
@@ -4758,27 +5536,29 @@
           <a:p>
             <a:r>
               <a:rPr lang="en-AU" sz="1000" dirty="0"/>
-              <a:t>A user can identify that “The Lakes Way is closed” based on the description and can find an alternative route before leaving</a:t>
+              <a:t>A user can identify a hazard on the map indicated by the droplet “flood”</a:t>
             </a:r>
           </a:p>
         </p:txBody>
       </p:sp>
       <p:cxnSp>
         <p:nvCxnSpPr>
-          <p:cNvPr id="49" name="Straight Arrow Connector 48">
-            <a:extLst>
-              <a:ext uri="{FF2B5EF4-FFF2-40B4-BE49-F238E27FC236}">
-                <a16:creationId xmlns:a16="http://schemas.microsoft.com/office/drawing/2014/main" id="{9674AA0B-0329-8175-93CD-591AE0C9E0D9}"/>
-              </a:ext>
-            </a:extLst>
-          </p:cNvPr>
-          <p:cNvCxnSpPr/>
+          <p:cNvPr id="41" name="Straight Arrow Connector 40">
+            <a:extLst>
+              <a:ext uri="{FF2B5EF4-FFF2-40B4-BE49-F238E27FC236}">
+                <a16:creationId xmlns:a16="http://schemas.microsoft.com/office/drawing/2014/main" id="{71E7E364-F612-0CEE-8942-C58F9654B2D2}"/>
+              </a:ext>
+            </a:extLst>
+          </p:cNvPr>
+          <p:cNvCxnSpPr>
+            <a:endCxn id="38" idx="4"/>
+          </p:cNvCxnSpPr>
           <p:nvPr/>
         </p:nvCxnSpPr>
         <p:spPr>
-          <a:xfrm flipH="1" flipV="1">
-            <a:off x="10277475" y="4400550"/>
-            <a:ext cx="352425" cy="1843697"/>
+          <a:xfrm flipV="1">
+            <a:off x="8247480" y="5265777"/>
+            <a:ext cx="30956" cy="978470"/>
           </a:xfrm>
           <a:prstGeom prst="straightConnector1">
             <a:avLst/>
@@ -4802,10 +5582,1738 @@
           </a:fontRef>
         </p:style>
       </p:cxnSp>
+      <p:pic>
+        <p:nvPicPr>
+          <p:cNvPr id="43" name="Picture 42">
+            <a:extLst>
+              <a:ext uri="{FF2B5EF4-FFF2-40B4-BE49-F238E27FC236}">
+                <a16:creationId xmlns:a16="http://schemas.microsoft.com/office/drawing/2014/main" id="{D1560A5B-77E5-677F-4C25-7AC9CC5A78AE}"/>
+              </a:ext>
+            </a:extLst>
+          </p:cNvPr>
+          <p:cNvPicPr>
+            <a:picLocks noChangeAspect="1"/>
+          </p:cNvPicPr>
+          <p:nvPr/>
+        </p:nvPicPr>
+        <p:blipFill>
+          <a:blip r:embed="rId6"/>
+          <a:stretch>
+            <a:fillRect/>
+          </a:stretch>
+        </p:blipFill>
+        <p:spPr>
+          <a:xfrm>
+            <a:off x="9775030" y="1962150"/>
+            <a:ext cx="2009980" cy="4230638"/>
+          </a:xfrm>
+          <a:prstGeom prst="rect">
+            <a:avLst/>
+          </a:prstGeom>
+        </p:spPr>
+      </p:pic>
+      <p:sp>
+        <p:nvSpPr>
+          <p:cNvPr id="44" name="TextBox 43">
+            <a:extLst>
+              <a:ext uri="{FF2B5EF4-FFF2-40B4-BE49-F238E27FC236}">
+                <a16:creationId xmlns:a16="http://schemas.microsoft.com/office/drawing/2014/main" id="{B024EE8A-4D89-BC6E-2932-9A9BDBCCA3B9}"/>
+              </a:ext>
+            </a:extLst>
+          </p:cNvPr>
+          <p:cNvSpPr txBox="1"/>
+          <p:nvPr/>
+        </p:nvSpPr>
+        <p:spPr>
+          <a:xfrm>
+            <a:off x="9764514" y="1352558"/>
+            <a:ext cx="2124075" cy="553998"/>
+          </a:xfrm>
+          <a:prstGeom prst="rect">
+            <a:avLst/>
+          </a:prstGeom>
+          <a:noFill/>
+        </p:spPr>
+        <p:txBody>
+          <a:bodyPr wrap="square" rtlCol="0">
+            <a:spAutoFit/>
+          </a:bodyPr>
+          <a:lstStyle/>
+          <a:p>
+            <a:r>
+              <a:rPr lang="en-AU" sz="1000" dirty="0"/>
+              <a:t>A user can see the details attached to this hazard by selecting the droplet icon on the map</a:t>
+            </a:r>
+          </a:p>
+        </p:txBody>
+      </p:sp>
+      <p:cxnSp>
+        <p:nvCxnSpPr>
+          <p:cNvPr id="46" name="Straight Arrow Connector 45">
+            <a:extLst>
+              <a:ext uri="{FF2B5EF4-FFF2-40B4-BE49-F238E27FC236}">
+                <a16:creationId xmlns:a16="http://schemas.microsoft.com/office/drawing/2014/main" id="{1E0934C5-E86E-2A76-072C-2A75D56B892D}"/>
+              </a:ext>
+            </a:extLst>
+          </p:cNvPr>
+          <p:cNvCxnSpPr/>
+          <p:nvPr/>
+        </p:nvCxnSpPr>
+        <p:spPr>
+          <a:xfrm>
+            <a:off x="10629900" y="1906556"/>
+            <a:ext cx="0" cy="1465294"/>
+          </a:xfrm>
+          <a:prstGeom prst="straightConnector1">
+            <a:avLst/>
+          </a:prstGeom>
+          <a:ln>
+            <a:tailEnd type="triangle"/>
+          </a:ln>
+        </p:spPr>
+        <p:style>
+          <a:lnRef idx="2">
+            <a:schemeClr val="accent1"/>
+          </a:lnRef>
+          <a:fillRef idx="0">
+            <a:schemeClr val="accent1"/>
+          </a:fillRef>
+          <a:effectRef idx="1">
+            <a:schemeClr val="accent1"/>
+          </a:effectRef>
+          <a:fontRef idx="minor">
+            <a:schemeClr val="tx1"/>
+          </a:fontRef>
+        </p:style>
+      </p:cxnSp>
+      <p:sp>
+        <p:nvSpPr>
+          <p:cNvPr id="47" name="TextBox 46">
+            <a:extLst>
+              <a:ext uri="{FF2B5EF4-FFF2-40B4-BE49-F238E27FC236}">
+                <a16:creationId xmlns:a16="http://schemas.microsoft.com/office/drawing/2014/main" id="{A62D59F5-749A-F38E-BF5B-6299087C07A5}"/>
+              </a:ext>
+            </a:extLst>
+          </p:cNvPr>
+          <p:cNvSpPr txBox="1"/>
+          <p:nvPr/>
+        </p:nvSpPr>
+        <p:spPr>
+          <a:xfrm>
+            <a:off x="9619490" y="6244247"/>
+            <a:ext cx="2572510" cy="553998"/>
+          </a:xfrm>
+          <a:prstGeom prst="rect">
+            <a:avLst/>
+          </a:prstGeom>
+          <a:noFill/>
+        </p:spPr>
+        <p:txBody>
+          <a:bodyPr wrap="square" rtlCol="0">
+            <a:spAutoFit/>
+          </a:bodyPr>
+          <a:lstStyle/>
+          <a:p>
+            <a:r>
+              <a:rPr lang="en-AU" sz="1000" dirty="0"/>
+              <a:t>A user can identify that “The Lakes Way is closed” based on the description and can find an alternative route before leaving</a:t>
+            </a:r>
+          </a:p>
+        </p:txBody>
+      </p:sp>
+      <p:cxnSp>
+        <p:nvCxnSpPr>
+          <p:cNvPr id="49" name="Straight Arrow Connector 48">
+            <a:extLst>
+              <a:ext uri="{FF2B5EF4-FFF2-40B4-BE49-F238E27FC236}">
+                <a16:creationId xmlns:a16="http://schemas.microsoft.com/office/drawing/2014/main" id="{9674AA0B-0329-8175-93CD-591AE0C9E0D9}"/>
+              </a:ext>
+            </a:extLst>
+          </p:cNvPr>
+          <p:cNvCxnSpPr/>
+          <p:nvPr/>
+        </p:nvCxnSpPr>
+        <p:spPr>
+          <a:xfrm flipH="1" flipV="1">
+            <a:off x="10277475" y="4400550"/>
+            <a:ext cx="352425" cy="1843697"/>
+          </a:xfrm>
+          <a:prstGeom prst="straightConnector1">
+            <a:avLst/>
+          </a:prstGeom>
+          <a:ln>
+            <a:tailEnd type="triangle"/>
+          </a:ln>
+        </p:spPr>
+        <p:style>
+          <a:lnRef idx="2">
+            <a:schemeClr val="accent1"/>
+          </a:lnRef>
+          <a:fillRef idx="0">
+            <a:schemeClr val="accent1"/>
+          </a:fillRef>
+          <a:effectRef idx="1">
+            <a:schemeClr val="accent1"/>
+          </a:effectRef>
+          <a:fontRef idx="minor">
+            <a:schemeClr val="tx1"/>
+          </a:fontRef>
+        </p:style>
+      </p:cxnSp>
+      <p:sp>
+        <p:nvSpPr>
+          <p:cNvPr id="2" name="TextBox 1">
+            <a:extLst>
+              <a:ext uri="{FF2B5EF4-FFF2-40B4-BE49-F238E27FC236}">
+                <a16:creationId xmlns:a16="http://schemas.microsoft.com/office/drawing/2014/main" id="{7E4469B9-EA9E-6FA9-F54B-CBEB96B340FC}"/>
+              </a:ext>
+            </a:extLst>
+          </p:cNvPr>
+          <p:cNvSpPr txBox="1"/>
+          <p:nvPr/>
+        </p:nvSpPr>
+        <p:spPr>
+          <a:xfrm>
+            <a:off x="552137" y="1424284"/>
+            <a:ext cx="1692019" cy="707886"/>
+          </a:xfrm>
+          <a:prstGeom prst="rect">
+            <a:avLst/>
+          </a:prstGeom>
+          <a:noFill/>
+        </p:spPr>
+        <p:txBody>
+          <a:bodyPr wrap="square" rtlCol="0">
+            <a:spAutoFit/>
+          </a:bodyPr>
+          <a:lstStyle/>
+          <a:p>
+            <a:r>
+              <a:rPr lang="en-AU" sz="1000" dirty="0"/>
+              <a:t>Upon loading the app, a hazard appears within 50km radius of my location</a:t>
+            </a:r>
+          </a:p>
+          <a:p>
+            <a:endParaRPr lang="en-AU" sz="1000" dirty="0"/>
+          </a:p>
+        </p:txBody>
+      </p:sp>
+      <p:sp>
+        <p:nvSpPr>
+          <p:cNvPr id="13" name="TextBox 12">
+            <a:extLst>
+              <a:ext uri="{FF2B5EF4-FFF2-40B4-BE49-F238E27FC236}">
+                <a16:creationId xmlns:a16="http://schemas.microsoft.com/office/drawing/2014/main" id="{8B0AB1F4-ECFA-7EE6-ADF7-6FB2423D9CCD}"/>
+              </a:ext>
+            </a:extLst>
+          </p:cNvPr>
+          <p:cNvSpPr txBox="1"/>
+          <p:nvPr/>
+        </p:nvSpPr>
+        <p:spPr>
+          <a:xfrm>
+            <a:off x="3050914" y="1501228"/>
+            <a:ext cx="1523551" cy="553998"/>
+          </a:xfrm>
+          <a:prstGeom prst="rect">
+            <a:avLst/>
+          </a:prstGeom>
+          <a:noFill/>
+        </p:spPr>
+        <p:txBody>
+          <a:bodyPr wrap="square" rtlCol="0">
+            <a:spAutoFit/>
+          </a:bodyPr>
+          <a:lstStyle/>
+          <a:p>
+            <a:r>
+              <a:rPr lang="en-AU" sz="1000" dirty="0"/>
+              <a:t>Data is retrieved from the Firestore table</a:t>
+            </a:r>
+          </a:p>
+          <a:p>
+            <a:endParaRPr lang="en-AU" sz="1000" dirty="0"/>
+          </a:p>
+        </p:txBody>
+      </p:sp>
+      <p:sp>
+        <p:nvSpPr>
+          <p:cNvPr id="15" name="TextBox 14">
+            <a:extLst>
+              <a:ext uri="{FF2B5EF4-FFF2-40B4-BE49-F238E27FC236}">
+                <a16:creationId xmlns:a16="http://schemas.microsoft.com/office/drawing/2014/main" id="{2EEDB996-6CB4-077E-DE7D-EF2FD56363A2}"/>
+              </a:ext>
+            </a:extLst>
+          </p:cNvPr>
+          <p:cNvSpPr txBox="1"/>
+          <p:nvPr/>
+        </p:nvSpPr>
+        <p:spPr>
+          <a:xfrm>
+            <a:off x="443620" y="6274370"/>
+            <a:ext cx="1800536" cy="553998"/>
+          </a:xfrm>
+          <a:prstGeom prst="rect">
+            <a:avLst/>
+          </a:prstGeom>
+          <a:noFill/>
+        </p:spPr>
+        <p:txBody>
+          <a:bodyPr wrap="square" rtlCol="0">
+            <a:spAutoFit/>
+          </a:bodyPr>
+          <a:lstStyle/>
+          <a:p>
+            <a:r>
+              <a:rPr lang="en-AU" sz="1000" dirty="0"/>
+              <a:t>User can click the hazard icon to see the hazard details</a:t>
+            </a:r>
+          </a:p>
+          <a:p>
+            <a:endParaRPr lang="en-AU" sz="1000" dirty="0"/>
+          </a:p>
+        </p:txBody>
+      </p:sp>
+      <p:sp>
+        <p:nvSpPr>
+          <p:cNvPr id="16" name="TextBox 15">
+            <a:extLst>
+              <a:ext uri="{FF2B5EF4-FFF2-40B4-BE49-F238E27FC236}">
+                <a16:creationId xmlns:a16="http://schemas.microsoft.com/office/drawing/2014/main" id="{A9B03B9D-81D4-EDFD-648D-8BF30CC6074F}"/>
+              </a:ext>
+            </a:extLst>
+          </p:cNvPr>
+          <p:cNvSpPr txBox="1"/>
+          <p:nvPr/>
+        </p:nvSpPr>
+        <p:spPr>
+          <a:xfrm>
+            <a:off x="2860895" y="6274370"/>
+            <a:ext cx="1666504" cy="553998"/>
+          </a:xfrm>
+          <a:prstGeom prst="rect">
+            <a:avLst/>
+          </a:prstGeom>
+          <a:noFill/>
+        </p:spPr>
+        <p:txBody>
+          <a:bodyPr wrap="square" rtlCol="0">
+            <a:spAutoFit/>
+          </a:bodyPr>
+          <a:lstStyle/>
+          <a:p>
+            <a:r>
+              <a:rPr lang="en-AU" sz="1000" dirty="0"/>
+              <a:t>User can mark the hazard if it’s still there </a:t>
+            </a:r>
+          </a:p>
+          <a:p>
+            <a:endParaRPr lang="en-AU" sz="1000" dirty="0"/>
+          </a:p>
+        </p:txBody>
+      </p:sp>
+      <p:sp>
+        <p:nvSpPr>
+          <p:cNvPr id="18" name="TextBox 17">
+            <a:extLst>
+              <a:ext uri="{FF2B5EF4-FFF2-40B4-BE49-F238E27FC236}">
+                <a16:creationId xmlns:a16="http://schemas.microsoft.com/office/drawing/2014/main" id="{C84CA142-8740-88F1-D228-37B62DB33E67}"/>
+              </a:ext>
+            </a:extLst>
+          </p:cNvPr>
+          <p:cNvSpPr txBox="1"/>
+          <p:nvPr/>
+        </p:nvSpPr>
+        <p:spPr>
+          <a:xfrm>
+            <a:off x="8680665" y="292418"/>
+            <a:ext cx="2680063" cy="553998"/>
+          </a:xfrm>
+          <a:prstGeom prst="rect">
+            <a:avLst/>
+          </a:prstGeom>
+          <a:noFill/>
+        </p:spPr>
+        <p:txBody>
+          <a:bodyPr wrap="square" rtlCol="0">
+            <a:spAutoFit/>
+          </a:bodyPr>
+          <a:lstStyle/>
+          <a:p>
+            <a:r>
+              <a:rPr lang="en-AU" sz="1000" dirty="0"/>
+              <a:t>Hazards older than 3 days will be filtered out. If a hazard receives more than 5 “No” votes, the hazard will be filtered out.</a:t>
+            </a:r>
+          </a:p>
+        </p:txBody>
+      </p:sp>
+      <p:sp>
+        <p:nvSpPr>
+          <p:cNvPr id="21" name="Rectangle: Rounded Corners 20">
+            <a:extLst>
+              <a:ext uri="{FF2B5EF4-FFF2-40B4-BE49-F238E27FC236}">
+                <a16:creationId xmlns:a16="http://schemas.microsoft.com/office/drawing/2014/main" id="{B8BFFCBF-6C54-E764-2F19-862D387B3E91}"/>
+              </a:ext>
+            </a:extLst>
+          </p:cNvPr>
+          <p:cNvSpPr/>
+          <p:nvPr/>
+        </p:nvSpPr>
+        <p:spPr>
+          <a:xfrm>
+            <a:off x="552137" y="318824"/>
+            <a:ext cx="2429164" cy="762000"/>
+          </a:xfrm>
+          <a:prstGeom prst="roundRect">
+            <a:avLst/>
+          </a:prstGeom>
+        </p:spPr>
+        <p:style>
+          <a:lnRef idx="2">
+            <a:schemeClr val="accent1">
+              <a:shade val="15000"/>
+            </a:schemeClr>
+          </a:lnRef>
+          <a:fillRef idx="1">
+            <a:schemeClr val="accent1"/>
+          </a:fillRef>
+          <a:effectRef idx="0">
+            <a:schemeClr val="accent1"/>
+          </a:effectRef>
+          <a:fontRef idx="minor">
+            <a:schemeClr val="lt1"/>
+          </a:fontRef>
+        </p:style>
+        <p:txBody>
+          <a:bodyPr rtlCol="0" anchor="ctr"/>
+          <a:lstStyle/>
+          <a:p>
+            <a:pPr algn="ctr"/>
+            <a:r>
+              <a:rPr lang="en-AU" sz="1200" dirty="0"/>
+              <a:t>Firebase Technologies</a:t>
+            </a:r>
+          </a:p>
+          <a:p>
+            <a:pPr marL="228600" indent="-228600" algn="ctr">
+              <a:buAutoNum type="arabicPeriod"/>
+            </a:pPr>
+            <a:r>
+              <a:rPr lang="en-AU" sz="1200" dirty="0"/>
+              <a:t>Authentication</a:t>
+            </a:r>
+          </a:p>
+          <a:p>
+            <a:pPr marL="228600" indent="-228600" algn="ctr">
+              <a:buAutoNum type="arabicPeriod"/>
+            </a:pPr>
+            <a:r>
+              <a:rPr lang="en-AU" sz="1200" dirty="0"/>
+              <a:t>Firestore</a:t>
+            </a:r>
+          </a:p>
+          <a:p>
+            <a:pPr marL="228600" indent="-228600" algn="ctr">
+              <a:buAutoNum type="arabicPeriod"/>
+            </a:pPr>
+            <a:r>
+              <a:rPr lang="en-AU" sz="1200" dirty="0"/>
+              <a:t>Test Lab</a:t>
+            </a:r>
+          </a:p>
+        </p:txBody>
+      </p:sp>
     </p:spTree>
     <p:extLst>
       <p:ext uri="{BB962C8B-B14F-4D97-AF65-F5344CB8AC3E}">
         <p14:creationId xmlns:p14="http://schemas.microsoft.com/office/powerpoint/2010/main" val="93593808"/>
+      </p:ext>
+    </p:extLst>
+  </p:cSld>
+  <p:clrMapOvr>
+    <a:masterClrMapping/>
+  </p:clrMapOvr>
+</p:sld>
+</file>
+
+<file path=ppt/slides/slide3.xml><?xml version="1.0" encoding="utf-8"?>
+<p:sld xmlns:a="http://schemas.openxmlformats.org/drawingml/2006/main" xmlns:r="http://schemas.openxmlformats.org/officeDocument/2006/relationships" xmlns:p="http://schemas.openxmlformats.org/presentationml/2006/main">
+  <p:cSld>
+    <p:bg>
+      <p:bgPr>
+        <a:solidFill>
+          <a:schemeClr val="bg1">
+            <a:lumMod val="95000"/>
+          </a:schemeClr>
+        </a:solidFill>
+        <a:effectLst/>
+      </p:bgPr>
+    </p:bg>
+    <p:spTree>
+      <p:nvGrpSpPr>
+        <p:cNvPr id="1" name=""/>
+        <p:cNvGrpSpPr/>
+        <p:nvPr/>
+      </p:nvGrpSpPr>
+      <p:grpSpPr>
+        <a:xfrm>
+          <a:off x="0" y="0"/>
+          <a:ext cx="0" cy="0"/>
+          <a:chOff x="0" y="0"/>
+          <a:chExt cx="0" cy="0"/>
+        </a:xfrm>
+      </p:grpSpPr>
+      <p:sp>
+        <p:nvSpPr>
+          <p:cNvPr id="4" name="Rectangle 3">
+            <a:extLst>
+              <a:ext uri="{FF2B5EF4-FFF2-40B4-BE49-F238E27FC236}">
+                <a16:creationId xmlns:a16="http://schemas.microsoft.com/office/drawing/2014/main" id="{D8ABC243-2E1A-11FD-5406-84704156FC59}"/>
+              </a:ext>
+            </a:extLst>
+          </p:cNvPr>
+          <p:cNvSpPr/>
+          <p:nvPr/>
+        </p:nvSpPr>
+        <p:spPr>
+          <a:xfrm>
+            <a:off x="3322622" y="126749"/>
+            <a:ext cx="5033727" cy="914400"/>
+          </a:xfrm>
+          <a:prstGeom prst="rect">
+            <a:avLst/>
+          </a:prstGeom>
+        </p:spPr>
+        <p:style>
+          <a:lnRef idx="2">
+            <a:schemeClr val="accent1">
+              <a:shade val="15000"/>
+            </a:schemeClr>
+          </a:lnRef>
+          <a:fillRef idx="1">
+            <a:schemeClr val="accent1"/>
+          </a:fillRef>
+          <a:effectRef idx="0">
+            <a:schemeClr val="accent1"/>
+          </a:effectRef>
+          <a:fontRef idx="minor">
+            <a:schemeClr val="lt1"/>
+          </a:fontRef>
+        </p:style>
+        <p:txBody>
+          <a:bodyPr rtlCol="0" anchor="ctr"/>
+          <a:lstStyle/>
+          <a:p>
+            <a:pPr algn="ctr"/>
+            <a:r>
+              <a:rPr lang="en-AU" sz="1400" dirty="0"/>
+              <a:t>User Story: As a user, while travelling, I noticed a hazard I would like to report. I would also like to “Subscribe” to track the status of this hazard as it’s along my regular commute route.</a:t>
+            </a:r>
+          </a:p>
+        </p:txBody>
+      </p:sp>
+      <p:pic>
+        <p:nvPicPr>
+          <p:cNvPr id="6" name="Picture 5">
+            <a:extLst>
+              <a:ext uri="{FF2B5EF4-FFF2-40B4-BE49-F238E27FC236}">
+                <a16:creationId xmlns:a16="http://schemas.microsoft.com/office/drawing/2014/main" id="{488F2C0B-B6CF-FF9A-ABE9-9EE911A97EE9}"/>
+              </a:ext>
+            </a:extLst>
+          </p:cNvPr>
+          <p:cNvPicPr>
+            <a:picLocks noChangeAspect="1"/>
+          </p:cNvPicPr>
+          <p:nvPr/>
+        </p:nvPicPr>
+        <p:blipFill>
+          <a:blip r:embed="rId3"/>
+          <a:stretch>
+            <a:fillRect/>
+          </a:stretch>
+        </p:blipFill>
+        <p:spPr>
+          <a:xfrm>
+            <a:off x="152742" y="1693865"/>
+            <a:ext cx="2060594" cy="4386121"/>
+          </a:xfrm>
+          <a:prstGeom prst="rect">
+            <a:avLst/>
+          </a:prstGeom>
+        </p:spPr>
+      </p:pic>
+      <p:sp>
+        <p:nvSpPr>
+          <p:cNvPr id="7" name="TextBox 6">
+            <a:extLst>
+              <a:ext uri="{FF2B5EF4-FFF2-40B4-BE49-F238E27FC236}">
+                <a16:creationId xmlns:a16="http://schemas.microsoft.com/office/drawing/2014/main" id="{5A7C9BE5-9AAC-E32E-52B9-3499BBCC7E30}"/>
+              </a:ext>
+            </a:extLst>
+          </p:cNvPr>
+          <p:cNvSpPr txBox="1"/>
+          <p:nvPr/>
+        </p:nvSpPr>
+        <p:spPr>
+          <a:xfrm>
+            <a:off x="440540" y="6191994"/>
+            <a:ext cx="1510131" cy="553998"/>
+          </a:xfrm>
+          <a:prstGeom prst="rect">
+            <a:avLst/>
+          </a:prstGeom>
+          <a:noFill/>
+        </p:spPr>
+        <p:txBody>
+          <a:bodyPr wrap="square" rtlCol="0">
+            <a:spAutoFit/>
+          </a:bodyPr>
+          <a:lstStyle/>
+          <a:p>
+            <a:r>
+              <a:rPr lang="en-AU" sz="1000" dirty="0"/>
+              <a:t>A user can navigate to the login page to report a hazard.</a:t>
+            </a:r>
+          </a:p>
+        </p:txBody>
+      </p:sp>
+      <p:cxnSp>
+        <p:nvCxnSpPr>
+          <p:cNvPr id="9" name="Straight Arrow Connector 8">
+            <a:extLst>
+              <a:ext uri="{FF2B5EF4-FFF2-40B4-BE49-F238E27FC236}">
+                <a16:creationId xmlns:a16="http://schemas.microsoft.com/office/drawing/2014/main" id="{0782BCD0-5842-7CBB-41EF-C69675A5798D}"/>
+              </a:ext>
+            </a:extLst>
+          </p:cNvPr>
+          <p:cNvCxnSpPr>
+            <a:cxnSpLocks/>
+          </p:cNvCxnSpPr>
+          <p:nvPr/>
+        </p:nvCxnSpPr>
+        <p:spPr>
+          <a:xfrm flipV="1">
+            <a:off x="1211563" y="5845172"/>
+            <a:ext cx="555889" cy="346822"/>
+          </a:xfrm>
+          <a:prstGeom prst="straightConnector1">
+            <a:avLst/>
+          </a:prstGeom>
+          <a:ln>
+            <a:tailEnd type="triangle"/>
+          </a:ln>
+        </p:spPr>
+        <p:style>
+          <a:lnRef idx="2">
+            <a:schemeClr val="accent1"/>
+          </a:lnRef>
+          <a:fillRef idx="0">
+            <a:schemeClr val="accent1"/>
+          </a:fillRef>
+          <a:effectRef idx="1">
+            <a:schemeClr val="accent1"/>
+          </a:effectRef>
+          <a:fontRef idx="minor">
+            <a:schemeClr val="tx1"/>
+          </a:fontRef>
+        </p:style>
+      </p:cxnSp>
+      <p:pic>
+        <p:nvPicPr>
+          <p:cNvPr id="11" name="Picture 10">
+            <a:extLst>
+              <a:ext uri="{FF2B5EF4-FFF2-40B4-BE49-F238E27FC236}">
+                <a16:creationId xmlns:a16="http://schemas.microsoft.com/office/drawing/2014/main" id="{C7097CAF-C8B6-BCC5-E59C-EBB85E5ED8BE}"/>
+              </a:ext>
+            </a:extLst>
+          </p:cNvPr>
+          <p:cNvPicPr>
+            <a:picLocks noChangeAspect="1"/>
+          </p:cNvPicPr>
+          <p:nvPr/>
+        </p:nvPicPr>
+        <p:blipFill>
+          <a:blip r:embed="rId4"/>
+          <a:stretch>
+            <a:fillRect/>
+          </a:stretch>
+        </p:blipFill>
+        <p:spPr>
+          <a:xfrm>
+            <a:off x="2315187" y="1693866"/>
+            <a:ext cx="2092298" cy="4386121"/>
+          </a:xfrm>
+          <a:prstGeom prst="rect">
+            <a:avLst/>
+          </a:prstGeom>
+        </p:spPr>
+      </p:pic>
+      <p:sp>
+        <p:nvSpPr>
+          <p:cNvPr id="12" name="TextBox 11">
+            <a:extLst>
+              <a:ext uri="{FF2B5EF4-FFF2-40B4-BE49-F238E27FC236}">
+                <a16:creationId xmlns:a16="http://schemas.microsoft.com/office/drawing/2014/main" id="{4698CD77-0DA6-1DB0-CAFC-048D1556D1EC}"/>
+              </a:ext>
+            </a:extLst>
+          </p:cNvPr>
+          <p:cNvSpPr txBox="1"/>
+          <p:nvPr/>
+        </p:nvSpPr>
+        <p:spPr>
+          <a:xfrm>
+            <a:off x="2353901" y="1139868"/>
+            <a:ext cx="2014870" cy="553998"/>
+          </a:xfrm>
+          <a:prstGeom prst="rect">
+            <a:avLst/>
+          </a:prstGeom>
+          <a:noFill/>
+        </p:spPr>
+        <p:txBody>
+          <a:bodyPr wrap="square" rtlCol="0">
+            <a:spAutoFit/>
+          </a:bodyPr>
+          <a:lstStyle/>
+          <a:p>
+            <a:r>
+              <a:rPr lang="en-AU" sz="1000" dirty="0"/>
+              <a:t>Utilising Firebase Authentication, if the email does not exist, you will need to sign up first</a:t>
+            </a:r>
+          </a:p>
+        </p:txBody>
+      </p:sp>
+      <p:sp>
+        <p:nvSpPr>
+          <p:cNvPr id="13" name="TextBox 12">
+            <a:extLst>
+              <a:ext uri="{FF2B5EF4-FFF2-40B4-BE49-F238E27FC236}">
+                <a16:creationId xmlns:a16="http://schemas.microsoft.com/office/drawing/2014/main" id="{ADA359A3-9C59-A28F-84E5-7D9E2D34EA82}"/>
+              </a:ext>
+            </a:extLst>
+          </p:cNvPr>
+          <p:cNvSpPr txBox="1"/>
+          <p:nvPr/>
+        </p:nvSpPr>
+        <p:spPr>
+          <a:xfrm>
+            <a:off x="2430855" y="4173648"/>
+            <a:ext cx="1783533" cy="707886"/>
+          </a:xfrm>
+          <a:prstGeom prst="rect">
+            <a:avLst/>
+          </a:prstGeom>
+          <a:noFill/>
+        </p:spPr>
+        <p:txBody>
+          <a:bodyPr wrap="square" rtlCol="0">
+            <a:spAutoFit/>
+          </a:bodyPr>
+          <a:lstStyle/>
+          <a:p>
+            <a:r>
+              <a:rPr lang="en-AU" sz="1000" dirty="0"/>
+              <a:t>A user can enter their email address and a password. They can Login or Signup depending on their status.</a:t>
+            </a:r>
+          </a:p>
+        </p:txBody>
+      </p:sp>
+      <p:cxnSp>
+        <p:nvCxnSpPr>
+          <p:cNvPr id="15" name="Straight Arrow Connector 14">
+            <a:extLst>
+              <a:ext uri="{FF2B5EF4-FFF2-40B4-BE49-F238E27FC236}">
+                <a16:creationId xmlns:a16="http://schemas.microsoft.com/office/drawing/2014/main" id="{5F9A9F96-1721-2C9C-2B52-5FC2B21E81A3}"/>
+              </a:ext>
+            </a:extLst>
+          </p:cNvPr>
+          <p:cNvCxnSpPr/>
+          <p:nvPr/>
+        </p:nvCxnSpPr>
+        <p:spPr>
+          <a:xfrm flipV="1">
+            <a:off x="2634558" y="3223034"/>
+            <a:ext cx="380246" cy="950614"/>
+          </a:xfrm>
+          <a:prstGeom prst="straightConnector1">
+            <a:avLst/>
+          </a:prstGeom>
+          <a:ln>
+            <a:tailEnd type="triangle"/>
+          </a:ln>
+        </p:spPr>
+        <p:style>
+          <a:lnRef idx="2">
+            <a:schemeClr val="accent1"/>
+          </a:lnRef>
+          <a:fillRef idx="0">
+            <a:schemeClr val="accent1"/>
+          </a:fillRef>
+          <a:effectRef idx="1">
+            <a:schemeClr val="accent1"/>
+          </a:effectRef>
+          <a:fontRef idx="minor">
+            <a:schemeClr val="tx1"/>
+          </a:fontRef>
+        </p:style>
+      </p:cxnSp>
+      <p:sp>
+        <p:nvSpPr>
+          <p:cNvPr id="16" name="TextBox 15">
+            <a:extLst>
+              <a:ext uri="{FF2B5EF4-FFF2-40B4-BE49-F238E27FC236}">
+                <a16:creationId xmlns:a16="http://schemas.microsoft.com/office/drawing/2014/main" id="{A4F08578-6968-287B-0E9A-99C03CF8EE5C}"/>
+              </a:ext>
+            </a:extLst>
+          </p:cNvPr>
+          <p:cNvSpPr txBox="1"/>
+          <p:nvPr/>
+        </p:nvSpPr>
+        <p:spPr>
+          <a:xfrm>
+            <a:off x="2353901" y="6177253"/>
+            <a:ext cx="1783533" cy="553998"/>
+          </a:xfrm>
+          <a:prstGeom prst="rect">
+            <a:avLst/>
+          </a:prstGeom>
+          <a:noFill/>
+        </p:spPr>
+        <p:txBody>
+          <a:bodyPr wrap="square" rtlCol="0">
+            <a:spAutoFit/>
+          </a:bodyPr>
+          <a:lstStyle/>
+          <a:p>
+            <a:r>
+              <a:rPr lang="en-AU" sz="1000" dirty="0"/>
+              <a:t>When a user has logged in, they can navigate to the report page</a:t>
+            </a:r>
+          </a:p>
+        </p:txBody>
+      </p:sp>
+      <p:cxnSp>
+        <p:nvCxnSpPr>
+          <p:cNvPr id="18" name="Straight Arrow Connector 17">
+            <a:extLst>
+              <a:ext uri="{FF2B5EF4-FFF2-40B4-BE49-F238E27FC236}">
+                <a16:creationId xmlns:a16="http://schemas.microsoft.com/office/drawing/2014/main" id="{EC9F5EE0-7C44-AE98-C0A6-98FDCB5A7B7C}"/>
+              </a:ext>
+            </a:extLst>
+          </p:cNvPr>
+          <p:cNvCxnSpPr/>
+          <p:nvPr/>
+        </p:nvCxnSpPr>
+        <p:spPr>
+          <a:xfrm flipV="1">
+            <a:off x="3127971" y="5830431"/>
+            <a:ext cx="389299" cy="346822"/>
+          </a:xfrm>
+          <a:prstGeom prst="straightConnector1">
+            <a:avLst/>
+          </a:prstGeom>
+          <a:ln>
+            <a:tailEnd type="triangle"/>
+          </a:ln>
+        </p:spPr>
+        <p:style>
+          <a:lnRef idx="2">
+            <a:schemeClr val="accent1"/>
+          </a:lnRef>
+          <a:fillRef idx="0">
+            <a:schemeClr val="accent1"/>
+          </a:fillRef>
+          <a:effectRef idx="1">
+            <a:schemeClr val="accent1"/>
+          </a:effectRef>
+          <a:fontRef idx="minor">
+            <a:schemeClr val="tx1"/>
+          </a:fontRef>
+        </p:style>
+      </p:cxnSp>
+      <p:pic>
+        <p:nvPicPr>
+          <p:cNvPr id="20" name="Picture 19">
+            <a:extLst>
+              <a:ext uri="{FF2B5EF4-FFF2-40B4-BE49-F238E27FC236}">
+                <a16:creationId xmlns:a16="http://schemas.microsoft.com/office/drawing/2014/main" id="{A3BA5E9F-1309-C8E7-A8C1-23EABB9DCF91}"/>
+              </a:ext>
+            </a:extLst>
+          </p:cNvPr>
+          <p:cNvPicPr>
+            <a:picLocks noChangeAspect="1"/>
+          </p:cNvPicPr>
+          <p:nvPr/>
+        </p:nvPicPr>
+        <p:blipFill>
+          <a:blip r:embed="rId5"/>
+          <a:stretch>
+            <a:fillRect/>
+          </a:stretch>
+        </p:blipFill>
+        <p:spPr>
+          <a:xfrm>
+            <a:off x="4522679" y="1693866"/>
+            <a:ext cx="2113366" cy="4386121"/>
+          </a:xfrm>
+          <a:prstGeom prst="rect">
+            <a:avLst/>
+          </a:prstGeom>
+        </p:spPr>
+      </p:pic>
+      <p:sp>
+        <p:nvSpPr>
+          <p:cNvPr id="21" name="TextBox 20">
+            <a:extLst>
+              <a:ext uri="{FF2B5EF4-FFF2-40B4-BE49-F238E27FC236}">
+                <a16:creationId xmlns:a16="http://schemas.microsoft.com/office/drawing/2014/main" id="{3C665B45-3848-FCBB-94C4-81BD28F11733}"/>
+              </a:ext>
+            </a:extLst>
+          </p:cNvPr>
+          <p:cNvSpPr txBox="1"/>
+          <p:nvPr/>
+        </p:nvSpPr>
+        <p:spPr>
+          <a:xfrm>
+            <a:off x="4608214" y="1139868"/>
+            <a:ext cx="1783532" cy="553998"/>
+          </a:xfrm>
+          <a:prstGeom prst="rect">
+            <a:avLst/>
+          </a:prstGeom>
+          <a:noFill/>
+        </p:spPr>
+        <p:txBody>
+          <a:bodyPr wrap="square" rtlCol="0">
+            <a:spAutoFit/>
+          </a:bodyPr>
+          <a:lstStyle/>
+          <a:p>
+            <a:r>
+              <a:rPr lang="en-AU" sz="1000" dirty="0"/>
+              <a:t>The user can enter the street or address where the hazard has taken place.</a:t>
+            </a:r>
+          </a:p>
+        </p:txBody>
+      </p:sp>
+      <p:sp>
+        <p:nvSpPr>
+          <p:cNvPr id="24" name="TextBox 23">
+            <a:extLst>
+              <a:ext uri="{FF2B5EF4-FFF2-40B4-BE49-F238E27FC236}">
+                <a16:creationId xmlns:a16="http://schemas.microsoft.com/office/drawing/2014/main" id="{974CA2E3-C374-A285-31AD-D8BB246B81D8}"/>
+              </a:ext>
+            </a:extLst>
+          </p:cNvPr>
+          <p:cNvSpPr txBox="1"/>
+          <p:nvPr/>
+        </p:nvSpPr>
+        <p:spPr>
+          <a:xfrm>
+            <a:off x="4330054" y="6125111"/>
+            <a:ext cx="2734146" cy="707886"/>
+          </a:xfrm>
+          <a:prstGeom prst="rect">
+            <a:avLst/>
+          </a:prstGeom>
+          <a:noFill/>
+        </p:spPr>
+        <p:txBody>
+          <a:bodyPr wrap="square" rtlCol="0">
+            <a:spAutoFit/>
+          </a:bodyPr>
+          <a:lstStyle/>
+          <a:p>
+            <a:r>
+              <a:rPr lang="en-AU" sz="1000" dirty="0"/>
+              <a:t>When a user has completed filling out all fields (If not all fields completed, a message will appear upon submission to do so) they can submit the hazard to the Firestore database.</a:t>
+            </a:r>
+          </a:p>
+        </p:txBody>
+      </p:sp>
+      <p:cxnSp>
+        <p:nvCxnSpPr>
+          <p:cNvPr id="25" name="Straight Arrow Connector 24">
+            <a:extLst>
+              <a:ext uri="{FF2B5EF4-FFF2-40B4-BE49-F238E27FC236}">
+                <a16:creationId xmlns:a16="http://schemas.microsoft.com/office/drawing/2014/main" id="{4F2455AC-CB34-0145-A315-19D32EB64EAF}"/>
+              </a:ext>
+            </a:extLst>
+          </p:cNvPr>
+          <p:cNvCxnSpPr/>
+          <p:nvPr/>
+        </p:nvCxnSpPr>
+        <p:spPr>
+          <a:xfrm flipH="1">
+            <a:off x="5170001" y="1644507"/>
+            <a:ext cx="81481" cy="1013988"/>
+          </a:xfrm>
+          <a:prstGeom prst="straightConnector1">
+            <a:avLst/>
+          </a:prstGeom>
+          <a:ln>
+            <a:tailEnd type="triangle"/>
+          </a:ln>
+        </p:spPr>
+        <p:style>
+          <a:lnRef idx="2">
+            <a:schemeClr val="accent1"/>
+          </a:lnRef>
+          <a:fillRef idx="0">
+            <a:schemeClr val="accent1"/>
+          </a:fillRef>
+          <a:effectRef idx="1">
+            <a:schemeClr val="accent1"/>
+          </a:effectRef>
+          <a:fontRef idx="minor">
+            <a:schemeClr val="tx1"/>
+          </a:fontRef>
+        </p:style>
+      </p:cxnSp>
+      <p:cxnSp>
+        <p:nvCxnSpPr>
+          <p:cNvPr id="27" name="Straight Arrow Connector 26">
+            <a:extLst>
+              <a:ext uri="{FF2B5EF4-FFF2-40B4-BE49-F238E27FC236}">
+                <a16:creationId xmlns:a16="http://schemas.microsoft.com/office/drawing/2014/main" id="{C4EB50B7-2F75-7901-D71C-D37A76C7B724}"/>
+              </a:ext>
+            </a:extLst>
+          </p:cNvPr>
+          <p:cNvCxnSpPr/>
+          <p:nvPr/>
+        </p:nvCxnSpPr>
+        <p:spPr>
+          <a:xfrm flipV="1">
+            <a:off x="5341545" y="5223850"/>
+            <a:ext cx="158435" cy="953403"/>
+          </a:xfrm>
+          <a:prstGeom prst="straightConnector1">
+            <a:avLst/>
+          </a:prstGeom>
+          <a:ln>
+            <a:tailEnd type="triangle"/>
+          </a:ln>
+        </p:spPr>
+        <p:style>
+          <a:lnRef idx="2">
+            <a:schemeClr val="accent1"/>
+          </a:lnRef>
+          <a:fillRef idx="0">
+            <a:schemeClr val="accent1"/>
+          </a:fillRef>
+          <a:effectRef idx="1">
+            <a:schemeClr val="accent1"/>
+          </a:effectRef>
+          <a:fontRef idx="minor">
+            <a:schemeClr val="tx1"/>
+          </a:fontRef>
+        </p:style>
+      </p:cxnSp>
+      <p:sp>
+        <p:nvSpPr>
+          <p:cNvPr id="28" name="TextBox 27">
+            <a:extLst>
+              <a:ext uri="{FF2B5EF4-FFF2-40B4-BE49-F238E27FC236}">
+                <a16:creationId xmlns:a16="http://schemas.microsoft.com/office/drawing/2014/main" id="{7FDF2425-D0F5-8E83-9357-60E9BFA9613C}"/>
+              </a:ext>
+            </a:extLst>
+          </p:cNvPr>
+          <p:cNvSpPr txBox="1"/>
+          <p:nvPr/>
+        </p:nvSpPr>
+        <p:spPr>
+          <a:xfrm>
+            <a:off x="6636045" y="4328954"/>
+            <a:ext cx="1131828" cy="707886"/>
+          </a:xfrm>
+          <a:prstGeom prst="rect">
+            <a:avLst/>
+          </a:prstGeom>
+          <a:noFill/>
+        </p:spPr>
+        <p:txBody>
+          <a:bodyPr wrap="square" rtlCol="0">
+            <a:spAutoFit/>
+          </a:bodyPr>
+          <a:lstStyle/>
+          <a:p>
+            <a:r>
+              <a:rPr lang="en-AU" sz="1000" dirty="0"/>
+              <a:t>A user can take photos and submit them for a better visual</a:t>
+            </a:r>
+          </a:p>
+        </p:txBody>
+      </p:sp>
+      <p:cxnSp>
+        <p:nvCxnSpPr>
+          <p:cNvPr id="30" name="Straight Arrow Connector 29">
+            <a:extLst>
+              <a:ext uri="{FF2B5EF4-FFF2-40B4-BE49-F238E27FC236}">
+                <a16:creationId xmlns:a16="http://schemas.microsoft.com/office/drawing/2014/main" id="{EB0CCFE8-55EC-461E-EE54-CEB3A7E1EF5E}"/>
+              </a:ext>
+            </a:extLst>
+          </p:cNvPr>
+          <p:cNvCxnSpPr>
+            <a:stCxn id="28" idx="1"/>
+          </p:cNvCxnSpPr>
+          <p:nvPr/>
+        </p:nvCxnSpPr>
+        <p:spPr>
+          <a:xfrm flipH="1">
+            <a:off x="6310265" y="4682897"/>
+            <a:ext cx="325780" cy="0"/>
+          </a:xfrm>
+          <a:prstGeom prst="straightConnector1">
+            <a:avLst/>
+          </a:prstGeom>
+          <a:ln>
+            <a:tailEnd type="triangle"/>
+          </a:ln>
+        </p:spPr>
+        <p:style>
+          <a:lnRef idx="2">
+            <a:schemeClr val="accent1"/>
+          </a:lnRef>
+          <a:fillRef idx="0">
+            <a:schemeClr val="accent1"/>
+          </a:fillRef>
+          <a:effectRef idx="1">
+            <a:schemeClr val="accent1"/>
+          </a:effectRef>
+          <a:fontRef idx="minor">
+            <a:schemeClr val="tx1"/>
+          </a:fontRef>
+        </p:style>
+      </p:cxnSp>
+      <p:sp>
+        <p:nvSpPr>
+          <p:cNvPr id="31" name="TextBox 30">
+            <a:extLst>
+              <a:ext uri="{FF2B5EF4-FFF2-40B4-BE49-F238E27FC236}">
+                <a16:creationId xmlns:a16="http://schemas.microsoft.com/office/drawing/2014/main" id="{FE4E7FAC-1756-91DB-4BB0-C8F7887BFAE3}"/>
+              </a:ext>
+            </a:extLst>
+          </p:cNvPr>
+          <p:cNvSpPr txBox="1"/>
+          <p:nvPr/>
+        </p:nvSpPr>
+        <p:spPr>
+          <a:xfrm>
+            <a:off x="6636045" y="3619650"/>
+            <a:ext cx="1041294" cy="553998"/>
+          </a:xfrm>
+          <a:prstGeom prst="rect">
+            <a:avLst/>
+          </a:prstGeom>
+          <a:noFill/>
+        </p:spPr>
+        <p:txBody>
+          <a:bodyPr wrap="square" rtlCol="0">
+            <a:spAutoFit/>
+          </a:bodyPr>
+          <a:lstStyle/>
+          <a:p>
+            <a:r>
+              <a:rPr lang="en-AU" sz="1000" dirty="0"/>
+              <a:t>A user can add a description of the hazard.</a:t>
+            </a:r>
+          </a:p>
+        </p:txBody>
+      </p:sp>
+      <p:cxnSp>
+        <p:nvCxnSpPr>
+          <p:cNvPr id="33" name="Straight Arrow Connector 32">
+            <a:extLst>
+              <a:ext uri="{FF2B5EF4-FFF2-40B4-BE49-F238E27FC236}">
+                <a16:creationId xmlns:a16="http://schemas.microsoft.com/office/drawing/2014/main" id="{D7B4D4AD-CF09-5D5A-659B-C1CA1F09DA38}"/>
+              </a:ext>
+            </a:extLst>
+          </p:cNvPr>
+          <p:cNvCxnSpPr>
+            <a:cxnSpLocks/>
+          </p:cNvCxnSpPr>
+          <p:nvPr/>
+        </p:nvCxnSpPr>
+        <p:spPr>
+          <a:xfrm flipH="1" flipV="1">
+            <a:off x="6096000" y="3939221"/>
+            <a:ext cx="567205" cy="84177"/>
+          </a:xfrm>
+          <a:prstGeom prst="straightConnector1">
+            <a:avLst/>
+          </a:prstGeom>
+          <a:ln>
+            <a:tailEnd type="triangle"/>
+          </a:ln>
+        </p:spPr>
+        <p:style>
+          <a:lnRef idx="2">
+            <a:schemeClr val="accent1"/>
+          </a:lnRef>
+          <a:fillRef idx="0">
+            <a:schemeClr val="accent1"/>
+          </a:fillRef>
+          <a:effectRef idx="1">
+            <a:schemeClr val="accent1"/>
+          </a:effectRef>
+          <a:fontRef idx="minor">
+            <a:schemeClr val="tx1"/>
+          </a:fontRef>
+        </p:style>
+      </p:cxnSp>
+      <p:sp>
+        <p:nvSpPr>
+          <p:cNvPr id="36" name="TextBox 35">
+            <a:extLst>
+              <a:ext uri="{FF2B5EF4-FFF2-40B4-BE49-F238E27FC236}">
+                <a16:creationId xmlns:a16="http://schemas.microsoft.com/office/drawing/2014/main" id="{9DFBC1EC-F881-9481-04C3-4F83F87F9BA1}"/>
+              </a:ext>
+            </a:extLst>
+          </p:cNvPr>
+          <p:cNvSpPr txBox="1"/>
+          <p:nvPr/>
+        </p:nvSpPr>
+        <p:spPr>
+          <a:xfrm>
+            <a:off x="6636045" y="3037095"/>
+            <a:ext cx="1041294" cy="553998"/>
+          </a:xfrm>
+          <a:prstGeom prst="rect">
+            <a:avLst/>
+          </a:prstGeom>
+          <a:noFill/>
+        </p:spPr>
+        <p:txBody>
+          <a:bodyPr wrap="square" rtlCol="0">
+            <a:spAutoFit/>
+          </a:bodyPr>
+          <a:lstStyle/>
+          <a:p>
+            <a:r>
+              <a:rPr lang="en-AU" sz="1000" dirty="0"/>
+              <a:t>A user can add in the hazard </a:t>
+            </a:r>
+            <a:r>
+              <a:rPr lang="en-AU" sz="1000"/>
+              <a:t>severity rating.</a:t>
+            </a:r>
+          </a:p>
+        </p:txBody>
+      </p:sp>
+      <p:cxnSp>
+        <p:nvCxnSpPr>
+          <p:cNvPr id="38" name="Straight Arrow Connector 37">
+            <a:extLst>
+              <a:ext uri="{FF2B5EF4-FFF2-40B4-BE49-F238E27FC236}">
+                <a16:creationId xmlns:a16="http://schemas.microsoft.com/office/drawing/2014/main" id="{BB7EAFA3-B0AE-FC23-15CB-787C92DBCC82}"/>
+              </a:ext>
+            </a:extLst>
+          </p:cNvPr>
+          <p:cNvCxnSpPr>
+            <a:cxnSpLocks/>
+          </p:cNvCxnSpPr>
+          <p:nvPr/>
+        </p:nvCxnSpPr>
+        <p:spPr>
+          <a:xfrm flipH="1" flipV="1">
+            <a:off x="5251482" y="3385226"/>
+            <a:ext cx="1411723" cy="43774"/>
+          </a:xfrm>
+          <a:prstGeom prst="straightConnector1">
+            <a:avLst/>
+          </a:prstGeom>
+          <a:ln>
+            <a:tailEnd type="triangle"/>
+          </a:ln>
+        </p:spPr>
+        <p:style>
+          <a:lnRef idx="2">
+            <a:schemeClr val="accent1"/>
+          </a:lnRef>
+          <a:fillRef idx="0">
+            <a:schemeClr val="accent1"/>
+          </a:fillRef>
+          <a:effectRef idx="1">
+            <a:schemeClr val="accent1"/>
+          </a:effectRef>
+          <a:fontRef idx="minor">
+            <a:schemeClr val="tx1"/>
+          </a:fontRef>
+        </p:style>
+      </p:cxnSp>
+      <p:sp>
+        <p:nvSpPr>
+          <p:cNvPr id="40" name="TextBox 39">
+            <a:extLst>
+              <a:ext uri="{FF2B5EF4-FFF2-40B4-BE49-F238E27FC236}">
+                <a16:creationId xmlns:a16="http://schemas.microsoft.com/office/drawing/2014/main" id="{DC032CDB-AEF6-0A41-FB5C-3C63D8D880F9}"/>
+              </a:ext>
+            </a:extLst>
+          </p:cNvPr>
+          <p:cNvSpPr txBox="1"/>
+          <p:nvPr/>
+        </p:nvSpPr>
+        <p:spPr>
+          <a:xfrm>
+            <a:off x="6663205" y="2353901"/>
+            <a:ext cx="1204256" cy="400110"/>
+          </a:xfrm>
+          <a:prstGeom prst="rect">
+            <a:avLst/>
+          </a:prstGeom>
+          <a:noFill/>
+        </p:spPr>
+        <p:txBody>
+          <a:bodyPr wrap="square" rtlCol="0">
+            <a:spAutoFit/>
+          </a:bodyPr>
+          <a:lstStyle/>
+          <a:p>
+            <a:r>
+              <a:rPr lang="en-AU" sz="1000" dirty="0"/>
+              <a:t>A user can add in the type of hazard</a:t>
+            </a:r>
+          </a:p>
+        </p:txBody>
+      </p:sp>
+      <p:cxnSp>
+        <p:nvCxnSpPr>
+          <p:cNvPr id="42" name="Straight Arrow Connector 41">
+            <a:extLst>
+              <a:ext uri="{FF2B5EF4-FFF2-40B4-BE49-F238E27FC236}">
+                <a16:creationId xmlns:a16="http://schemas.microsoft.com/office/drawing/2014/main" id="{0624A7F1-31E9-E196-A5E5-14733FB90C7D}"/>
+              </a:ext>
+            </a:extLst>
+          </p:cNvPr>
+          <p:cNvCxnSpPr>
+            <a:cxnSpLocks/>
+          </p:cNvCxnSpPr>
+          <p:nvPr/>
+        </p:nvCxnSpPr>
+        <p:spPr>
+          <a:xfrm flipH="1">
+            <a:off x="5499980" y="2658495"/>
+            <a:ext cx="1235798" cy="334826"/>
+          </a:xfrm>
+          <a:prstGeom prst="straightConnector1">
+            <a:avLst/>
+          </a:prstGeom>
+          <a:ln>
+            <a:tailEnd type="triangle"/>
+          </a:ln>
+        </p:spPr>
+        <p:style>
+          <a:lnRef idx="2">
+            <a:schemeClr val="accent1"/>
+          </a:lnRef>
+          <a:fillRef idx="0">
+            <a:schemeClr val="accent1"/>
+          </a:fillRef>
+          <a:effectRef idx="1">
+            <a:schemeClr val="accent1"/>
+          </a:effectRef>
+          <a:fontRef idx="minor">
+            <a:schemeClr val="tx1"/>
+          </a:fontRef>
+        </p:style>
+      </p:cxnSp>
+      <p:pic>
+        <p:nvPicPr>
+          <p:cNvPr id="48" name="Picture 47">
+            <a:extLst>
+              <a:ext uri="{FF2B5EF4-FFF2-40B4-BE49-F238E27FC236}">
+                <a16:creationId xmlns:a16="http://schemas.microsoft.com/office/drawing/2014/main" id="{510D08DD-5034-2A85-1765-580E481A43D9}"/>
+              </a:ext>
+            </a:extLst>
+          </p:cNvPr>
+          <p:cNvPicPr>
+            <a:picLocks noChangeAspect="1"/>
+          </p:cNvPicPr>
+          <p:nvPr/>
+        </p:nvPicPr>
+        <p:blipFill>
+          <a:blip r:embed="rId6"/>
+          <a:stretch>
+            <a:fillRect/>
+          </a:stretch>
+        </p:blipFill>
+        <p:spPr>
+          <a:xfrm>
+            <a:off x="7793003" y="1693866"/>
+            <a:ext cx="2095656" cy="4386120"/>
+          </a:xfrm>
+          <a:prstGeom prst="rect">
+            <a:avLst/>
+          </a:prstGeom>
+        </p:spPr>
+      </p:pic>
+      <p:sp>
+        <p:nvSpPr>
+          <p:cNvPr id="49" name="TextBox 48">
+            <a:extLst>
+              <a:ext uri="{FF2B5EF4-FFF2-40B4-BE49-F238E27FC236}">
+                <a16:creationId xmlns:a16="http://schemas.microsoft.com/office/drawing/2014/main" id="{F11C9D14-EC51-0A11-6014-7D3AD3D53F33}"/>
+              </a:ext>
+            </a:extLst>
+          </p:cNvPr>
+          <p:cNvSpPr txBox="1"/>
+          <p:nvPr/>
+        </p:nvSpPr>
+        <p:spPr>
+          <a:xfrm>
+            <a:off x="7867461" y="6177253"/>
+            <a:ext cx="1970638" cy="553998"/>
+          </a:xfrm>
+          <a:prstGeom prst="rect">
+            <a:avLst/>
+          </a:prstGeom>
+          <a:noFill/>
+        </p:spPr>
+        <p:txBody>
+          <a:bodyPr wrap="square" rtlCol="0">
+            <a:spAutoFit/>
+          </a:bodyPr>
+          <a:lstStyle/>
+          <a:p>
+            <a:r>
+              <a:rPr lang="en-AU" sz="1000" dirty="0"/>
+              <a:t>A user can select the hazard icon to receive more information and the ability to subscribe </a:t>
+            </a:r>
+          </a:p>
+        </p:txBody>
+      </p:sp>
+      <p:cxnSp>
+        <p:nvCxnSpPr>
+          <p:cNvPr id="51" name="Straight Arrow Connector 50">
+            <a:extLst>
+              <a:ext uri="{FF2B5EF4-FFF2-40B4-BE49-F238E27FC236}">
+                <a16:creationId xmlns:a16="http://schemas.microsoft.com/office/drawing/2014/main" id="{2D705919-B75C-865C-B7A0-0B86B3942053}"/>
+              </a:ext>
+            </a:extLst>
+          </p:cNvPr>
+          <p:cNvCxnSpPr/>
+          <p:nvPr/>
+        </p:nvCxnSpPr>
+        <p:spPr>
+          <a:xfrm flipV="1">
+            <a:off x="8510257" y="3793402"/>
+            <a:ext cx="226337" cy="2398592"/>
+          </a:xfrm>
+          <a:prstGeom prst="straightConnector1">
+            <a:avLst/>
+          </a:prstGeom>
+          <a:ln>
+            <a:tailEnd type="triangle"/>
+          </a:ln>
+        </p:spPr>
+        <p:style>
+          <a:lnRef idx="2">
+            <a:schemeClr val="accent1"/>
+          </a:lnRef>
+          <a:fillRef idx="0">
+            <a:schemeClr val="accent1"/>
+          </a:fillRef>
+          <a:effectRef idx="1">
+            <a:schemeClr val="accent1"/>
+          </a:effectRef>
+          <a:fontRef idx="minor">
+            <a:schemeClr val="tx1"/>
+          </a:fontRef>
+        </p:style>
+      </p:cxnSp>
+      <p:pic>
+        <p:nvPicPr>
+          <p:cNvPr id="53" name="Picture 52">
+            <a:extLst>
+              <a:ext uri="{FF2B5EF4-FFF2-40B4-BE49-F238E27FC236}">
+                <a16:creationId xmlns:a16="http://schemas.microsoft.com/office/drawing/2014/main" id="{55B96C23-0D3D-4089-AF59-D4D1B8D4C08F}"/>
+              </a:ext>
+            </a:extLst>
+          </p:cNvPr>
+          <p:cNvPicPr>
+            <a:picLocks noChangeAspect="1"/>
+          </p:cNvPicPr>
+          <p:nvPr/>
+        </p:nvPicPr>
+        <p:blipFill>
+          <a:blip r:embed="rId7"/>
+          <a:stretch>
+            <a:fillRect/>
+          </a:stretch>
+        </p:blipFill>
+        <p:spPr>
+          <a:xfrm>
+            <a:off x="9961882" y="1693867"/>
+            <a:ext cx="2113150" cy="4386119"/>
+          </a:xfrm>
+          <a:prstGeom prst="rect">
+            <a:avLst/>
+          </a:prstGeom>
+        </p:spPr>
+      </p:pic>
+      <p:sp>
+        <p:nvSpPr>
+          <p:cNvPr id="54" name="TextBox 53">
+            <a:extLst>
+              <a:ext uri="{FF2B5EF4-FFF2-40B4-BE49-F238E27FC236}">
+                <a16:creationId xmlns:a16="http://schemas.microsoft.com/office/drawing/2014/main" id="{7923AF35-3A2C-0341-7A61-4330246E9C39}"/>
+              </a:ext>
+            </a:extLst>
+          </p:cNvPr>
+          <p:cNvSpPr txBox="1"/>
+          <p:nvPr/>
+        </p:nvSpPr>
+        <p:spPr>
+          <a:xfrm>
+            <a:off x="10082958" y="1139868"/>
+            <a:ext cx="1925317" cy="553998"/>
+          </a:xfrm>
+          <a:prstGeom prst="rect">
+            <a:avLst/>
+          </a:prstGeom>
+          <a:noFill/>
+        </p:spPr>
+        <p:txBody>
+          <a:bodyPr wrap="square" rtlCol="0">
+            <a:spAutoFit/>
+          </a:bodyPr>
+          <a:lstStyle/>
+          <a:p>
+            <a:r>
+              <a:rPr lang="en-AU" sz="1000" dirty="0"/>
+              <a:t>A user can read the details originally submitted for the hazard</a:t>
+            </a:r>
+          </a:p>
+        </p:txBody>
+      </p:sp>
+      <p:cxnSp>
+        <p:nvCxnSpPr>
+          <p:cNvPr id="56" name="Straight Arrow Connector 55">
+            <a:extLst>
+              <a:ext uri="{FF2B5EF4-FFF2-40B4-BE49-F238E27FC236}">
+                <a16:creationId xmlns:a16="http://schemas.microsoft.com/office/drawing/2014/main" id="{9ACA32C1-38BA-F4EA-218C-930EA87A38B6}"/>
+              </a:ext>
+            </a:extLst>
+          </p:cNvPr>
+          <p:cNvCxnSpPr/>
+          <p:nvPr/>
+        </p:nvCxnSpPr>
+        <p:spPr>
+          <a:xfrm>
+            <a:off x="10664982" y="1566250"/>
+            <a:ext cx="172016" cy="1566249"/>
+          </a:xfrm>
+          <a:prstGeom prst="straightConnector1">
+            <a:avLst/>
+          </a:prstGeom>
+          <a:ln>
+            <a:tailEnd type="triangle"/>
+          </a:ln>
+        </p:spPr>
+        <p:style>
+          <a:lnRef idx="2">
+            <a:schemeClr val="accent1"/>
+          </a:lnRef>
+          <a:fillRef idx="0">
+            <a:schemeClr val="accent1"/>
+          </a:fillRef>
+          <a:effectRef idx="1">
+            <a:schemeClr val="accent1"/>
+          </a:effectRef>
+          <a:fontRef idx="minor">
+            <a:schemeClr val="tx1"/>
+          </a:fontRef>
+        </p:style>
+      </p:cxnSp>
+      <p:sp>
+        <p:nvSpPr>
+          <p:cNvPr id="58" name="TextBox 57">
+            <a:extLst>
+              <a:ext uri="{FF2B5EF4-FFF2-40B4-BE49-F238E27FC236}">
+                <a16:creationId xmlns:a16="http://schemas.microsoft.com/office/drawing/2014/main" id="{403E737F-F3EB-FDDB-3979-49D32914DDA3}"/>
+              </a:ext>
+            </a:extLst>
+          </p:cNvPr>
+          <p:cNvSpPr txBox="1"/>
+          <p:nvPr/>
+        </p:nvSpPr>
+        <p:spPr>
+          <a:xfrm>
+            <a:off x="10000863" y="6125111"/>
+            <a:ext cx="2095656" cy="707886"/>
+          </a:xfrm>
+          <a:prstGeom prst="rect">
+            <a:avLst/>
+          </a:prstGeom>
+          <a:noFill/>
+        </p:spPr>
+        <p:txBody>
+          <a:bodyPr wrap="square" rtlCol="0">
+            <a:spAutoFit/>
+          </a:bodyPr>
+          <a:lstStyle/>
+          <a:p>
+            <a:r>
+              <a:rPr lang="en-AU" sz="1000" dirty="0"/>
+              <a:t>A user can subscribe to updates. Any updates provided by a verified account will now be sent to the user as a push notification.</a:t>
+            </a:r>
+          </a:p>
+        </p:txBody>
+      </p:sp>
+      <p:cxnSp>
+        <p:nvCxnSpPr>
+          <p:cNvPr id="60" name="Straight Arrow Connector 59">
+            <a:extLst>
+              <a:ext uri="{FF2B5EF4-FFF2-40B4-BE49-F238E27FC236}">
+                <a16:creationId xmlns:a16="http://schemas.microsoft.com/office/drawing/2014/main" id="{3196D11B-63A5-9517-4E79-3AE42861D009}"/>
+              </a:ext>
+            </a:extLst>
+          </p:cNvPr>
+          <p:cNvCxnSpPr/>
+          <p:nvPr/>
+        </p:nvCxnSpPr>
+        <p:spPr>
+          <a:xfrm flipV="1">
+            <a:off x="10483913" y="5767057"/>
+            <a:ext cx="181069" cy="410196"/>
+          </a:xfrm>
+          <a:prstGeom prst="straightConnector1">
+            <a:avLst/>
+          </a:prstGeom>
+          <a:ln>
+            <a:tailEnd type="triangle"/>
+          </a:ln>
+        </p:spPr>
+        <p:style>
+          <a:lnRef idx="2">
+            <a:schemeClr val="accent1"/>
+          </a:lnRef>
+          <a:fillRef idx="0">
+            <a:schemeClr val="accent1"/>
+          </a:fillRef>
+          <a:effectRef idx="1">
+            <a:schemeClr val="accent1"/>
+          </a:effectRef>
+          <a:fontRef idx="minor">
+            <a:schemeClr val="tx1"/>
+          </a:fontRef>
+        </p:style>
+      </p:cxnSp>
+      <p:sp>
+        <p:nvSpPr>
+          <p:cNvPr id="61" name="Rectangle: Rounded Corners 60">
+            <a:extLst>
+              <a:ext uri="{FF2B5EF4-FFF2-40B4-BE49-F238E27FC236}">
+                <a16:creationId xmlns:a16="http://schemas.microsoft.com/office/drawing/2014/main" id="{3D179C27-D4D0-FC66-DBCC-8FD047C5515D}"/>
+              </a:ext>
+            </a:extLst>
+          </p:cNvPr>
+          <p:cNvSpPr/>
+          <p:nvPr/>
+        </p:nvSpPr>
+        <p:spPr>
+          <a:xfrm>
+            <a:off x="440540" y="202949"/>
+            <a:ext cx="2429164" cy="762000"/>
+          </a:xfrm>
+          <a:prstGeom prst="roundRect">
+            <a:avLst/>
+          </a:prstGeom>
+        </p:spPr>
+        <p:style>
+          <a:lnRef idx="2">
+            <a:schemeClr val="accent1">
+              <a:shade val="15000"/>
+            </a:schemeClr>
+          </a:lnRef>
+          <a:fillRef idx="1">
+            <a:schemeClr val="accent1"/>
+          </a:fillRef>
+          <a:effectRef idx="0">
+            <a:schemeClr val="accent1"/>
+          </a:effectRef>
+          <a:fontRef idx="minor">
+            <a:schemeClr val="lt1"/>
+          </a:fontRef>
+        </p:style>
+        <p:txBody>
+          <a:bodyPr rtlCol="0" anchor="ctr"/>
+          <a:lstStyle/>
+          <a:p>
+            <a:pPr algn="ctr"/>
+            <a:r>
+              <a:rPr lang="en-AU" sz="1200" dirty="0"/>
+              <a:t>Firebase Technologies</a:t>
+            </a:r>
+          </a:p>
+          <a:p>
+            <a:pPr marL="228600" indent="-228600" algn="ctr">
+              <a:buAutoNum type="arabicPeriod"/>
+            </a:pPr>
+            <a:r>
+              <a:rPr lang="en-AU" sz="1200" dirty="0"/>
+              <a:t>Authentication</a:t>
+            </a:r>
+          </a:p>
+          <a:p>
+            <a:pPr marL="228600" indent="-228600" algn="ctr">
+              <a:buAutoNum type="arabicPeriod"/>
+            </a:pPr>
+            <a:r>
+              <a:rPr lang="en-AU" sz="1200" dirty="0"/>
+              <a:t>Firestore</a:t>
+            </a:r>
+          </a:p>
+          <a:p>
+            <a:pPr marL="228600" indent="-228600" algn="ctr">
+              <a:buAutoNum type="arabicPeriod"/>
+            </a:pPr>
+            <a:r>
+              <a:rPr lang="en-AU" sz="1200" dirty="0"/>
+              <a:t>Test Lab</a:t>
+            </a:r>
+          </a:p>
+        </p:txBody>
+      </p:sp>
+      <p:sp>
+        <p:nvSpPr>
+          <p:cNvPr id="62" name="TextBox 61">
+            <a:extLst>
+              <a:ext uri="{FF2B5EF4-FFF2-40B4-BE49-F238E27FC236}">
+                <a16:creationId xmlns:a16="http://schemas.microsoft.com/office/drawing/2014/main" id="{EC21A496-C588-FA05-E0B7-61F3742F9661}"/>
+              </a:ext>
+            </a:extLst>
+          </p:cNvPr>
+          <p:cNvSpPr txBox="1"/>
+          <p:nvPr/>
+        </p:nvSpPr>
+        <p:spPr>
+          <a:xfrm>
+            <a:off x="8994701" y="308871"/>
+            <a:ext cx="2680063" cy="553998"/>
+          </a:xfrm>
+          <a:prstGeom prst="rect">
+            <a:avLst/>
+          </a:prstGeom>
+          <a:noFill/>
+        </p:spPr>
+        <p:txBody>
+          <a:bodyPr wrap="square" rtlCol="0">
+            <a:spAutoFit/>
+          </a:bodyPr>
+          <a:lstStyle/>
+          <a:p>
+            <a:r>
+              <a:rPr lang="en-AU" sz="1000" dirty="0"/>
+              <a:t>Hazards older than 3 days will be filtered out. If a hazard receives more than 5 “No” votes, the hazard will be filtered out.</a:t>
+            </a:r>
+          </a:p>
+        </p:txBody>
+      </p:sp>
+    </p:spTree>
+    <p:extLst>
+      <p:ext uri="{BB962C8B-B14F-4D97-AF65-F5344CB8AC3E}">
+        <p14:creationId xmlns:p14="http://schemas.microsoft.com/office/powerpoint/2010/main" val="3138381567"/>
       </p:ext>
     </p:extLst>
   </p:cSld>
@@ -5128,4 +7636,319 @@
     </a:ext>
   </a:extLst>
 </a:theme>
+</file>
+
+<file path=ppt/theme/theme2.xml><?xml version="1.0" encoding="utf-8"?>
+<a:theme xmlns:a="http://schemas.openxmlformats.org/drawingml/2006/main" name="Office Theme">
+  <a:themeElements>
+    <a:clrScheme name="Office">
+      <a:dk1>
+        <a:sysClr val="windowText" lastClr="000000"/>
+      </a:dk1>
+      <a:lt1>
+        <a:sysClr val="window" lastClr="FFFFFF"/>
+      </a:lt1>
+      <a:dk2>
+        <a:srgbClr val="0E2841"/>
+      </a:dk2>
+      <a:lt2>
+        <a:srgbClr val="E8E8E8"/>
+      </a:lt2>
+      <a:accent1>
+        <a:srgbClr val="156082"/>
+      </a:accent1>
+      <a:accent2>
+        <a:srgbClr val="E97132"/>
+      </a:accent2>
+      <a:accent3>
+        <a:srgbClr val="196B24"/>
+      </a:accent3>
+      <a:accent4>
+        <a:srgbClr val="0F9ED5"/>
+      </a:accent4>
+      <a:accent5>
+        <a:srgbClr val="A02B93"/>
+      </a:accent5>
+      <a:accent6>
+        <a:srgbClr val="4EA72E"/>
+      </a:accent6>
+      <a:hlink>
+        <a:srgbClr val="467886"/>
+      </a:hlink>
+      <a:folHlink>
+        <a:srgbClr val="96607D"/>
+      </a:folHlink>
+    </a:clrScheme>
+    <a:fontScheme name="Office">
+      <a:majorFont>
+        <a:latin typeface="Aptos Display" panose="02110004020202020204"/>
+        <a:ea typeface=""/>
+        <a:cs typeface=""/>
+        <a:font script="Jpan" typeface="游ゴシック Light"/>
+        <a:font script="Hang" typeface="맑은 고딕"/>
+        <a:font script="Hans" typeface="等线 Light"/>
+        <a:font script="Hant" typeface="新細明體"/>
+        <a:font script="Arab" typeface="Times New Roman"/>
+        <a:font script="Hebr" typeface="Times New Roman"/>
+        <a:font script="Thai" typeface="Angsana New"/>
+        <a:font script="Ethi" typeface="Nyala"/>
+        <a:font script="Beng" typeface="Vrinda"/>
+        <a:font script="Gujr" typeface="Shruti"/>
+        <a:font script="Khmr" typeface="MoolBoran"/>
+        <a:font script="Knda" typeface="Tunga"/>
+        <a:font script="Guru" typeface="Raavi"/>
+        <a:font script="Cans" typeface="Euphemia"/>
+        <a:font script="Cher" typeface="Plantagenet Cherokee"/>
+        <a:font script="Yiii" typeface="Microsoft Yi Baiti"/>
+        <a:font script="Tibt" typeface="Microsoft Himalaya"/>
+        <a:font script="Thaa" typeface="MV Boli"/>
+        <a:font script="Deva" typeface="Mangal"/>
+        <a:font script="Telu" typeface="Gautami"/>
+        <a:font script="Taml" typeface="Latha"/>
+        <a:font script="Syrc" typeface="Estrangelo Edessa"/>
+        <a:font script="Orya" typeface="Kalinga"/>
+        <a:font script="Mlym" typeface="Kartika"/>
+        <a:font script="Laoo" typeface="DokChampa"/>
+        <a:font script="Sinh" typeface="Iskoola Pota"/>
+        <a:font script="Mong" typeface="Mongolian Baiti"/>
+        <a:font script="Viet" typeface="Times New Roman"/>
+        <a:font script="Uigh" typeface="Microsoft Uighur"/>
+        <a:font script="Geor" typeface="Sylfaen"/>
+        <a:font script="Armn" typeface="Arial"/>
+        <a:font script="Bugi" typeface="Leelawadee UI"/>
+        <a:font script="Bopo" typeface="Microsoft JhengHei"/>
+        <a:font script="Java" typeface="Javanese Text"/>
+        <a:font script="Lisu" typeface="Segoe UI"/>
+        <a:font script="Mymr" typeface="Myanmar Text"/>
+        <a:font script="Nkoo" typeface="Ebrima"/>
+        <a:font script="Olck" typeface="Nirmala UI"/>
+        <a:font script="Osma" typeface="Ebrima"/>
+        <a:font script="Phag" typeface="Phagspa"/>
+        <a:font script="Syrn" typeface="Estrangelo Edessa"/>
+        <a:font script="Syrj" typeface="Estrangelo Edessa"/>
+        <a:font script="Syre" typeface="Estrangelo Edessa"/>
+        <a:font script="Sora" typeface="Nirmala UI"/>
+        <a:font script="Tale" typeface="Microsoft Tai Le"/>
+        <a:font script="Talu" typeface="Microsoft New Tai Lue"/>
+        <a:font script="Tfng" typeface="Ebrima"/>
+      </a:majorFont>
+      <a:minorFont>
+        <a:latin typeface="Aptos" panose="02110004020202020204"/>
+        <a:ea typeface=""/>
+        <a:cs typeface=""/>
+        <a:font script="Jpan" typeface="游ゴシック"/>
+        <a:font script="Hang" typeface="맑은 고딕"/>
+        <a:font script="Hans" typeface="等线"/>
+        <a:font script="Hant" typeface="新細明體"/>
+        <a:font script="Arab" typeface="Arial"/>
+        <a:font script="Hebr" typeface="Arial"/>
+        <a:font script="Thai" typeface="Cordia New"/>
+        <a:font script="Ethi" typeface="Nyala"/>
+        <a:font script="Beng" typeface="Vrinda"/>
+        <a:font script="Gujr" typeface="Shruti"/>
+        <a:font script="Khmr" typeface="DaunPenh"/>
+        <a:font script="Knda" typeface="Tunga"/>
+        <a:font script="Guru" typeface="Raavi"/>
+        <a:font script="Cans" typeface="Euphemia"/>
+        <a:font script="Cher" typeface="Plantagenet Cherokee"/>
+        <a:font script="Yiii" typeface="Microsoft Yi Baiti"/>
+        <a:font script="Tibt" typeface="Microsoft Himalaya"/>
+        <a:font script="Thaa" typeface="MV Boli"/>
+        <a:font script="Deva" typeface="Mangal"/>
+        <a:font script="Telu" typeface="Gautami"/>
+        <a:font script="Taml" typeface="Latha"/>
+        <a:font script="Syrc" typeface="Estrangelo Edessa"/>
+        <a:font script="Orya" typeface="Kalinga"/>
+        <a:font script="Mlym" typeface="Kartika"/>
+        <a:font script="Laoo" typeface="DokChampa"/>
+        <a:font script="Sinh" typeface="Iskoola Pota"/>
+        <a:font script="Mong" typeface="Mongolian Baiti"/>
+        <a:font script="Viet" typeface="Arial"/>
+        <a:font script="Uigh" typeface="Microsoft Uighur"/>
+        <a:font script="Geor" typeface="Sylfaen"/>
+        <a:font script="Armn" typeface="Arial"/>
+        <a:font script="Bugi" typeface="Leelawadee UI"/>
+        <a:font script="Bopo" typeface="Microsoft JhengHei"/>
+        <a:font script="Java" typeface="Javanese Text"/>
+        <a:font script="Lisu" typeface="Segoe UI"/>
+        <a:font script="Mymr" typeface="Myanmar Text"/>
+        <a:font script="Nkoo" typeface="Ebrima"/>
+        <a:font script="Olck" typeface="Nirmala UI"/>
+        <a:font script="Osma" typeface="Ebrima"/>
+        <a:font script="Phag" typeface="Phagspa"/>
+        <a:font script="Syrn" typeface="Estrangelo Edessa"/>
+        <a:font script="Syrj" typeface="Estrangelo Edessa"/>
+        <a:font script="Syre" typeface="Estrangelo Edessa"/>
+        <a:font script="Sora" typeface="Nirmala UI"/>
+        <a:font script="Tale" typeface="Microsoft Tai Le"/>
+        <a:font script="Talu" typeface="Microsoft New Tai Lue"/>
+        <a:font script="Tfng" typeface="Ebrima"/>
+      </a:minorFont>
+    </a:fontScheme>
+    <a:fmtScheme name="Office">
+      <a:fillStyleLst>
+        <a:solidFill>
+          <a:schemeClr val="phClr"/>
+        </a:solidFill>
+        <a:gradFill rotWithShape="1">
+          <a:gsLst>
+            <a:gs pos="0">
+              <a:schemeClr val="phClr">
+                <a:lumMod val="110000"/>
+                <a:satMod val="105000"/>
+                <a:tint val="67000"/>
+              </a:schemeClr>
+            </a:gs>
+            <a:gs pos="50000">
+              <a:schemeClr val="phClr">
+                <a:lumMod val="105000"/>
+                <a:satMod val="103000"/>
+                <a:tint val="73000"/>
+              </a:schemeClr>
+            </a:gs>
+            <a:gs pos="100000">
+              <a:schemeClr val="phClr">
+                <a:lumMod val="105000"/>
+                <a:satMod val="109000"/>
+                <a:tint val="81000"/>
+              </a:schemeClr>
+            </a:gs>
+          </a:gsLst>
+          <a:lin ang="5400000" scaled="0"/>
+        </a:gradFill>
+        <a:gradFill rotWithShape="1">
+          <a:gsLst>
+            <a:gs pos="0">
+              <a:schemeClr val="phClr">
+                <a:satMod val="103000"/>
+                <a:lumMod val="102000"/>
+                <a:tint val="94000"/>
+              </a:schemeClr>
+            </a:gs>
+            <a:gs pos="50000">
+              <a:schemeClr val="phClr">
+                <a:satMod val="110000"/>
+                <a:lumMod val="100000"/>
+                <a:shade val="100000"/>
+              </a:schemeClr>
+            </a:gs>
+            <a:gs pos="100000">
+              <a:schemeClr val="phClr">
+                <a:lumMod val="99000"/>
+                <a:satMod val="120000"/>
+                <a:shade val="78000"/>
+              </a:schemeClr>
+            </a:gs>
+          </a:gsLst>
+          <a:lin ang="5400000" scaled="0"/>
+        </a:gradFill>
+      </a:fillStyleLst>
+      <a:lnStyleLst>
+        <a:ln w="12700" cap="flat" cmpd="sng" algn="ctr">
+          <a:solidFill>
+            <a:schemeClr val="phClr"/>
+          </a:solidFill>
+          <a:prstDash val="solid"/>
+          <a:miter lim="800000"/>
+        </a:ln>
+        <a:ln w="19050" cap="flat" cmpd="sng" algn="ctr">
+          <a:solidFill>
+            <a:schemeClr val="phClr"/>
+          </a:solidFill>
+          <a:prstDash val="solid"/>
+          <a:miter lim="800000"/>
+        </a:ln>
+        <a:ln w="25400" cap="flat" cmpd="sng" algn="ctr">
+          <a:solidFill>
+            <a:schemeClr val="phClr"/>
+          </a:solidFill>
+          <a:prstDash val="solid"/>
+          <a:miter lim="800000"/>
+        </a:ln>
+      </a:lnStyleLst>
+      <a:effectStyleLst>
+        <a:effectStyle>
+          <a:effectLst/>
+        </a:effectStyle>
+        <a:effectStyle>
+          <a:effectLst/>
+        </a:effectStyle>
+        <a:effectStyle>
+          <a:effectLst>
+            <a:outerShdw blurRad="57150" dist="19050" dir="5400000" algn="ctr" rotWithShape="0">
+              <a:srgbClr val="000000">
+                <a:alpha val="63000"/>
+              </a:srgbClr>
+            </a:outerShdw>
+          </a:effectLst>
+        </a:effectStyle>
+      </a:effectStyleLst>
+      <a:bgFillStyleLst>
+        <a:solidFill>
+          <a:schemeClr val="phClr"/>
+        </a:solidFill>
+        <a:solidFill>
+          <a:schemeClr val="phClr">
+            <a:tint val="95000"/>
+            <a:satMod val="170000"/>
+          </a:schemeClr>
+        </a:solidFill>
+        <a:gradFill rotWithShape="1">
+          <a:gsLst>
+            <a:gs pos="0">
+              <a:schemeClr val="phClr">
+                <a:tint val="93000"/>
+                <a:satMod val="150000"/>
+                <a:shade val="98000"/>
+                <a:lumMod val="102000"/>
+              </a:schemeClr>
+            </a:gs>
+            <a:gs pos="50000">
+              <a:schemeClr val="phClr">
+                <a:tint val="98000"/>
+                <a:satMod val="130000"/>
+                <a:shade val="90000"/>
+                <a:lumMod val="103000"/>
+              </a:schemeClr>
+            </a:gs>
+            <a:gs pos="100000">
+              <a:schemeClr val="phClr">
+                <a:shade val="63000"/>
+                <a:satMod val="120000"/>
+              </a:schemeClr>
+            </a:gs>
+          </a:gsLst>
+          <a:lin ang="5400000" scaled="0"/>
+        </a:gradFill>
+      </a:bgFillStyleLst>
+    </a:fmtScheme>
+  </a:themeElements>
+  <a:objectDefaults>
+    <a:lnDef>
+      <a:spPr/>
+      <a:bodyPr/>
+      <a:lstStyle/>
+      <a:style>
+        <a:lnRef idx="2">
+          <a:schemeClr val="accent1"/>
+        </a:lnRef>
+        <a:fillRef idx="0">
+          <a:schemeClr val="accent1"/>
+        </a:fillRef>
+        <a:effectRef idx="1">
+          <a:schemeClr val="accent1"/>
+        </a:effectRef>
+        <a:fontRef idx="minor">
+          <a:schemeClr val="tx1"/>
+        </a:fontRef>
+      </a:style>
+    </a:lnDef>
+  </a:objectDefaults>
+  <a:extraClrSchemeLst/>
+  <a:extLst>
+    <a:ext uri="{05A4C25C-085E-4340-85A3-A5531E510DB2}">
+      <thm15:themeFamily xmlns:thm15="http://schemas.microsoft.com/office/thememl/2012/main" name="Office Theme" id="{2E142A2C-CD16-42D6-873A-C26D2A0506FA}" vid="{1BDDFF52-6CD6-40A5-AB3C-68EB2F1E4D0A}"/>
+    </a:ext>
+  </a:extLst>
+</a:theme>
 </file>
</xml_diff>

<commit_message>
added in additional slide
</commit_message>
<xml_diff>
--- a/LgFiles/Phase 3/Assessment 3 powerpoint.pptx
+++ b/LgFiles/Phase 3/Assessment 3 powerpoint.pptx
@@ -5,12 +5,13 @@
     <p:sldMasterId id="2147483648" r:id="rId1"/>
   </p:sldMasterIdLst>
   <p:notesMasterIdLst>
-    <p:notesMasterId r:id="rId5"/>
+    <p:notesMasterId r:id="rId6"/>
   </p:notesMasterIdLst>
   <p:sldIdLst>
-    <p:sldId id="256" r:id="rId2"/>
-    <p:sldId id="257" r:id="rId3"/>
-    <p:sldId id="258" r:id="rId4"/>
+    <p:sldId id="259" r:id="rId2"/>
+    <p:sldId id="256" r:id="rId3"/>
+    <p:sldId id="257" r:id="rId4"/>
+    <p:sldId id="258" r:id="rId5"/>
   </p:sldIdLst>
   <p:sldSz cx="12192000" cy="6858000"/>
   <p:notesSz cx="6858000" cy="9144000"/>
@@ -120,7 +121,7 @@
 <file path=ppt/revisionInfo.xml><?xml version="1.0" encoding="utf-8"?>
 <p1510:revInfo xmlns:a="http://schemas.openxmlformats.org/drawingml/2006/main" xmlns:r="http://schemas.openxmlformats.org/officeDocument/2006/relationships" xmlns:p1510="http://schemas.microsoft.com/office/powerpoint/2015/10/main">
   <p1510:revLst>
-    <p1510:client id="{6BAB4B05-1683-42F8-85CF-50B035D12F67}" v="45" dt="2025-06-01T00:03:08.692"/>
+    <p1510:client id="{6BAB4B05-1683-42F8-85CF-50B035D12F67}" v="46" dt="2025-06-01T00:25:46.845"/>
   </p1510:revLst>
 </p1510:revInfo>
 </file>
@@ -130,7 +131,7 @@
   <pc:docChgLst>
     <pc:chgData name="RICHARD AVERY" userId="33041ff4-ef49-46cd-b021-6ff8b9862bb2" providerId="ADAL" clId="{6BAB4B05-1683-42F8-85CF-50B035D12F67}"/>
     <pc:docChg chg="undo custSel addSld modSld">
-      <pc:chgData name="RICHARD AVERY" userId="33041ff4-ef49-46cd-b021-6ff8b9862bb2" providerId="ADAL" clId="{6BAB4B05-1683-42F8-85CF-50B035D12F67}" dt="2025-06-01T00:03:23.611" v="2459" actId="1076"/>
+      <pc:chgData name="RICHARD AVERY" userId="33041ff4-ef49-46cd-b021-6ff8b9862bb2" providerId="ADAL" clId="{6BAB4B05-1683-42F8-85CF-50B035D12F67}" dt="2025-06-01T00:25:46.845" v="2461"/>
       <pc:docMkLst>
         <pc:docMk/>
       </pc:docMkLst>
@@ -627,6 +628,61 @@
           </ac:cxnSpMkLst>
         </pc:cxnChg>
       </pc:sldChg>
+      <pc:sldChg chg="delSp add setBg delDesignElem">
+        <pc:chgData name="RICHARD AVERY" userId="33041ff4-ef49-46cd-b021-6ff8b9862bb2" providerId="ADAL" clId="{6BAB4B05-1683-42F8-85CF-50B035D12F67}" dt="2025-06-01T00:25:46.845" v="2461"/>
+        <pc:sldMkLst>
+          <pc:docMk/>
+          <pc:sldMk cId="2807950182" sldId="259"/>
+        </pc:sldMkLst>
+        <pc:spChg chg="del">
+          <ac:chgData name="RICHARD AVERY" userId="33041ff4-ef49-46cd-b021-6ff8b9862bb2" providerId="ADAL" clId="{6BAB4B05-1683-42F8-85CF-50B035D12F67}" dt="2025-06-01T00:25:46.845" v="2461"/>
+          <ac:spMkLst>
+            <pc:docMk/>
+            <pc:sldMk cId="2807950182" sldId="259"/>
+            <ac:spMk id="28" creationId="{E1750109-3B91-4506-B997-0CD8E35A1488}"/>
+          </ac:spMkLst>
+        </pc:spChg>
+        <pc:spChg chg="del">
+          <ac:chgData name="RICHARD AVERY" userId="33041ff4-ef49-46cd-b021-6ff8b9862bb2" providerId="ADAL" clId="{6BAB4B05-1683-42F8-85CF-50B035D12F67}" dt="2025-06-01T00:25:46.845" v="2461"/>
+          <ac:spMkLst>
+            <pc:docMk/>
+            <pc:sldMk cId="2807950182" sldId="259"/>
+            <ac:spMk id="30" creationId="{E72D8D1B-59F6-4FF3-8547-9BBB6129F2FA}"/>
+          </ac:spMkLst>
+        </pc:spChg>
+        <pc:spChg chg="del">
+          <ac:chgData name="RICHARD AVERY" userId="33041ff4-ef49-46cd-b021-6ff8b9862bb2" providerId="ADAL" clId="{6BAB4B05-1683-42F8-85CF-50B035D12F67}" dt="2025-06-01T00:25:46.845" v="2461"/>
+          <ac:spMkLst>
+            <pc:docMk/>
+            <pc:sldMk cId="2807950182" sldId="259"/>
+            <ac:spMk id="32" creationId="{14044C96-7CFD-44DB-A579-D77B0D37C681}"/>
+          </ac:spMkLst>
+        </pc:spChg>
+        <pc:spChg chg="del">
+          <ac:chgData name="RICHARD AVERY" userId="33041ff4-ef49-46cd-b021-6ff8b9862bb2" providerId="ADAL" clId="{6BAB4B05-1683-42F8-85CF-50B035D12F67}" dt="2025-06-01T00:25:46.845" v="2461"/>
+          <ac:spMkLst>
+            <pc:docMk/>
+            <pc:sldMk cId="2807950182" sldId="259"/>
+            <ac:spMk id="34" creationId="{8FC8C21F-9484-4A71-ABFA-6C10682FAC3E}"/>
+          </ac:spMkLst>
+        </pc:spChg>
+        <pc:spChg chg="del">
+          <ac:chgData name="RICHARD AVERY" userId="33041ff4-ef49-46cd-b021-6ff8b9862bb2" providerId="ADAL" clId="{6BAB4B05-1683-42F8-85CF-50B035D12F67}" dt="2025-06-01T00:25:46.845" v="2461"/>
+          <ac:spMkLst>
+            <pc:docMk/>
+            <pc:sldMk cId="2807950182" sldId="259"/>
+            <ac:spMk id="36" creationId="{2C444748-5A8D-4B53-89FE-42B455DFA2D1}"/>
+          </ac:spMkLst>
+        </pc:spChg>
+        <pc:spChg chg="del">
+          <ac:chgData name="RICHARD AVERY" userId="33041ff4-ef49-46cd-b021-6ff8b9862bb2" providerId="ADAL" clId="{6BAB4B05-1683-42F8-85CF-50B035D12F67}" dt="2025-06-01T00:25:46.845" v="2461"/>
+          <ac:spMkLst>
+            <pc:docMk/>
+            <pc:sldMk cId="2807950182" sldId="259"/>
+            <ac:spMk id="38" creationId="{F4FFA271-A10A-4AC3-8F06-E3313A197A80}"/>
+          </ac:spMkLst>
+        </pc:spChg>
+      </pc:sldChg>
     </pc:docChg>
   </pc:docChgLst>
 </pc:chgInfo>
@@ -1047,7 +1103,7 @@
           <a:p>
             <a:fld id="{BD6A8A3A-C051-4EC5-84FD-FFF9823CD921}" type="slidenum">
               <a:rPr lang="en-AU" smtClean="0"/>
-              <a:t>1</a:t>
+              <a:t>2</a:t>
             </a:fld>
             <a:endParaRPr lang="en-AU"/>
           </a:p>
@@ -1134,7 +1190,7 @@
           <a:p>
             <a:fld id="{BD6A8A3A-C051-4EC5-84FD-FFF9823CD921}" type="slidenum">
               <a:rPr lang="en-AU" smtClean="0"/>
-              <a:t>2</a:t>
+              <a:t>3</a:t>
             </a:fld>
             <a:endParaRPr lang="en-AU"/>
           </a:p>
@@ -1238,7 +1294,7 @@
           <a:p>
             <a:fld id="{BD6A8A3A-C051-4EC5-84FD-FFF9823CD921}" type="slidenum">
               <a:rPr lang="en-AU" smtClean="0"/>
-              <a:t>3</a:t>
+              <a:t>4</a:t>
             </a:fld>
             <a:endParaRPr lang="en-AU"/>
           </a:p>
@@ -4478,16 +4534,6 @@
 <file path=ppt/slides/slide1.xml><?xml version="1.0" encoding="utf-8"?>
 <p:sld xmlns:a="http://schemas.openxmlformats.org/drawingml/2006/main" xmlns:r="http://schemas.openxmlformats.org/officeDocument/2006/relationships" xmlns:p="http://schemas.openxmlformats.org/presentationml/2006/main">
   <p:cSld>
-    <p:bg>
-      <p:bgPr>
-        <a:solidFill>
-          <a:schemeClr val="bg1">
-            <a:lumMod val="95000"/>
-          </a:schemeClr>
-        </a:solidFill>
-        <a:effectLst/>
-      </p:bgPr>
-    </p:bg>
     <p:spTree>
       <p:nvGrpSpPr>
         <p:cNvPr id="1" name=""/>
@@ -4504,409 +4550,10 @@
       </p:grpSpPr>
       <p:pic>
         <p:nvPicPr>
-          <p:cNvPr id="1030" name="Picture 6" descr="⛈️ SEVERE STORM BRINGS FLASH FLOODING - #NEWCASTLE AREA - 6:40PM, Wednesday  30th April A severe storm has impacted the Newcastle and Hunter region this  afternoon, resulting in significant flash flooding across">
-            <a:extLst>
-              <a:ext uri="{FF2B5EF4-FFF2-40B4-BE49-F238E27FC236}">
-                <a16:creationId xmlns:a16="http://schemas.microsoft.com/office/drawing/2014/main" id="{445C3104-AD31-4505-1171-164EB9E1EAAF}"/>
-              </a:ext>
-            </a:extLst>
-          </p:cNvPr>
-          <p:cNvPicPr>
-            <a:picLocks noChangeAspect="1" noChangeArrowheads="1"/>
-          </p:cNvPicPr>
-          <p:nvPr/>
-        </p:nvPicPr>
-        <p:blipFill>
-          <a:blip r:embed="rId3">
-            <a:extLst>
-              <a:ext uri="{28A0092B-C50C-407E-A947-70E740481C1C}">
-                <a14:useLocalDpi xmlns:a14="http://schemas.microsoft.com/office/drawing/2010/main" val="0"/>
-              </a:ext>
-            </a:extLst>
-          </a:blip>
-          <a:srcRect/>
-          <a:stretch>
-            <a:fillRect/>
-          </a:stretch>
-        </p:blipFill>
-        <p:spPr bwMode="auto">
-          <a:xfrm>
-            <a:off x="691939" y="453238"/>
-            <a:ext cx="2173220" cy="2713822"/>
-          </a:xfrm>
-          <a:prstGeom prst="rect">
-            <a:avLst/>
-          </a:prstGeom>
-          <a:noFill/>
-          <a:extLst>
-            <a:ext uri="{909E8E84-426E-40DD-AFC4-6F175D3DCCD1}">
-              <a14:hiddenFill xmlns:a14="http://schemas.microsoft.com/office/drawing/2010/main">
-                <a:solidFill>
-                  <a:srgbClr val="FFFFFF"/>
-                </a:solidFill>
-              </a14:hiddenFill>
-            </a:ext>
-          </a:extLst>
-        </p:spPr>
-      </p:pic>
-      <p:pic>
-        <p:nvPicPr>
-          <p:cNvPr id="1032" name="Picture 8" descr="Death toll rises to three as NSW floods hammer Mid North Coast - ABC News">
-            <a:extLst>
-              <a:ext uri="{FF2B5EF4-FFF2-40B4-BE49-F238E27FC236}">
-                <a16:creationId xmlns:a16="http://schemas.microsoft.com/office/drawing/2014/main" id="{94FA7E5F-2DBF-F6F8-32D4-275375F816F4}"/>
-              </a:ext>
-            </a:extLst>
-          </p:cNvPr>
-          <p:cNvPicPr>
-            <a:picLocks noChangeAspect="1" noChangeArrowheads="1"/>
-          </p:cNvPicPr>
-          <p:nvPr/>
-        </p:nvPicPr>
-        <p:blipFill>
-          <a:blip r:embed="rId4">
-            <a:extLst>
-              <a:ext uri="{28A0092B-C50C-407E-A947-70E740481C1C}">
-                <a14:useLocalDpi xmlns:a14="http://schemas.microsoft.com/office/drawing/2010/main" val="0"/>
-              </a:ext>
-            </a:extLst>
-          </a:blip>
-          <a:srcRect/>
-          <a:stretch>
-            <a:fillRect/>
-          </a:stretch>
-        </p:blipFill>
-        <p:spPr bwMode="auto">
-          <a:xfrm>
-            <a:off x="494434" y="3690940"/>
-            <a:ext cx="5053296" cy="2843212"/>
-          </a:xfrm>
-          <a:prstGeom prst="rect">
-            <a:avLst/>
-          </a:prstGeom>
-          <a:noFill/>
-          <a:extLst>
-            <a:ext uri="{909E8E84-426E-40DD-AFC4-6F175D3DCCD1}">
-              <a14:hiddenFill xmlns:a14="http://schemas.microsoft.com/office/drawing/2010/main">
-                <a:solidFill>
-                  <a:srgbClr val="FFFFFF"/>
-                </a:solidFill>
-              </a14:hiddenFill>
-            </a:ext>
-          </a:extLst>
-        </p:spPr>
-      </p:pic>
-      <p:sp>
-        <p:nvSpPr>
-          <p:cNvPr id="4" name="Cloud 3">
-            <a:extLst>
-              <a:ext uri="{FF2B5EF4-FFF2-40B4-BE49-F238E27FC236}">
-                <a16:creationId xmlns:a16="http://schemas.microsoft.com/office/drawing/2014/main" id="{54A25444-AF9D-0465-313A-3273AF85D5D3}"/>
-              </a:ext>
-            </a:extLst>
-          </p:cNvPr>
-          <p:cNvSpPr/>
-          <p:nvPr/>
-        </p:nvSpPr>
-        <p:spPr>
-          <a:xfrm>
-            <a:off x="116172" y="2727515"/>
-            <a:ext cx="2593063" cy="1445442"/>
-          </a:xfrm>
-          <a:prstGeom prst="cloud">
-            <a:avLst/>
-          </a:prstGeom>
-        </p:spPr>
-        <p:style>
-          <a:lnRef idx="2">
-            <a:schemeClr val="accent1">
-              <a:shade val="15000"/>
-            </a:schemeClr>
-          </a:lnRef>
-          <a:fillRef idx="1">
-            <a:schemeClr val="accent1"/>
-          </a:fillRef>
-          <a:effectRef idx="0">
-            <a:schemeClr val="accent1"/>
-          </a:effectRef>
-          <a:fontRef idx="minor">
-            <a:schemeClr val="lt1"/>
-          </a:fontRef>
-        </p:style>
-        <p:txBody>
-          <a:bodyPr rtlCol="0" anchor="ctr"/>
-          <a:lstStyle/>
-          <a:p>
-            <a:pPr algn="ctr"/>
-            <a:r>
-              <a:rPr lang="en-AU" dirty="0"/>
-              <a:t>May 2025 Newcastle-Mid North Coast Floods</a:t>
-            </a:r>
-          </a:p>
-        </p:txBody>
-      </p:sp>
-      <p:sp>
-        <p:nvSpPr>
-          <p:cNvPr id="5" name="Speech Bubble: Rectangle 4">
-            <a:extLst>
-              <a:ext uri="{FF2B5EF4-FFF2-40B4-BE49-F238E27FC236}">
-                <a16:creationId xmlns:a16="http://schemas.microsoft.com/office/drawing/2014/main" id="{2730DF34-2086-9D48-B211-E99499482C36}"/>
-              </a:ext>
-            </a:extLst>
-          </p:cNvPr>
-          <p:cNvSpPr/>
-          <p:nvPr/>
-        </p:nvSpPr>
-        <p:spPr>
-          <a:xfrm>
-            <a:off x="3021082" y="1904634"/>
-            <a:ext cx="2414132" cy="1430448"/>
-          </a:xfrm>
-          <a:prstGeom prst="wedgeRectCallout">
-            <a:avLst/>
-          </a:prstGeom>
-        </p:spPr>
-        <p:style>
-          <a:lnRef idx="2">
-            <a:schemeClr val="accent1">
-              <a:shade val="15000"/>
-            </a:schemeClr>
-          </a:lnRef>
-          <a:fillRef idx="1">
-            <a:schemeClr val="accent1"/>
-          </a:fillRef>
-          <a:effectRef idx="0">
-            <a:schemeClr val="accent1"/>
-          </a:effectRef>
-          <a:fontRef idx="minor">
-            <a:schemeClr val="lt1"/>
-          </a:fontRef>
-        </p:style>
-        <p:txBody>
-          <a:bodyPr rtlCol="0" anchor="ctr"/>
-          <a:lstStyle/>
-          <a:p>
-            <a:pPr algn="ctr"/>
-            <a:r>
-              <a:rPr lang="en-AU" sz="1400" dirty="0"/>
-              <a:t>“I’ve been driving around for 7 hours trying to find a way north and all the navigational apps have been wrong” – (Post seen on Facebook)</a:t>
-            </a:r>
-          </a:p>
-        </p:txBody>
-      </p:sp>
-      <p:sp>
-        <p:nvSpPr>
-          <p:cNvPr id="7" name="Rectangle: Rounded Corners 6">
-            <a:extLst>
-              <a:ext uri="{FF2B5EF4-FFF2-40B4-BE49-F238E27FC236}">
-                <a16:creationId xmlns:a16="http://schemas.microsoft.com/office/drawing/2014/main" id="{A952360B-AA0A-B99E-A742-05502A9FBCB4}"/>
-              </a:ext>
-            </a:extLst>
-          </p:cNvPr>
-          <p:cNvSpPr/>
-          <p:nvPr/>
-        </p:nvSpPr>
-        <p:spPr>
-          <a:xfrm>
-            <a:off x="6219506" y="2540686"/>
-            <a:ext cx="5053295" cy="1588792"/>
-          </a:xfrm>
-          <a:prstGeom prst="roundRect">
-            <a:avLst/>
-          </a:prstGeom>
-        </p:spPr>
-        <p:style>
-          <a:lnRef idx="2">
-            <a:schemeClr val="accent1">
-              <a:shade val="15000"/>
-            </a:schemeClr>
-          </a:lnRef>
-          <a:fillRef idx="1">
-            <a:schemeClr val="accent1"/>
-          </a:fillRef>
-          <a:effectRef idx="0">
-            <a:schemeClr val="accent1"/>
-          </a:effectRef>
-          <a:fontRef idx="minor">
-            <a:schemeClr val="lt1"/>
-          </a:fontRef>
-        </p:style>
-        <p:txBody>
-          <a:bodyPr rtlCol="0" anchor="ctr"/>
-          <a:lstStyle/>
-          <a:p>
-            <a:pPr algn="ctr"/>
-            <a:r>
-              <a:rPr lang="en-AU" sz="1600" b="1" u="sng" dirty="0"/>
-              <a:t>Concept:</a:t>
-            </a:r>
-            <a:r>
-              <a:rPr lang="en-AU" sz="1400" dirty="0"/>
-              <a:t> During major weather events, users can view, and report hazards they have witnessed including exact locations, descriptions and images.</a:t>
-            </a:r>
-          </a:p>
-        </p:txBody>
-      </p:sp>
-      <p:sp>
-        <p:nvSpPr>
-          <p:cNvPr id="8" name="Rectangle: Rounded Corners 7">
-            <a:extLst>
-              <a:ext uri="{FF2B5EF4-FFF2-40B4-BE49-F238E27FC236}">
-                <a16:creationId xmlns:a16="http://schemas.microsoft.com/office/drawing/2014/main" id="{52C01278-3E2A-2FA0-8E59-305F6A29AAF0}"/>
-              </a:ext>
-            </a:extLst>
-          </p:cNvPr>
-          <p:cNvSpPr/>
-          <p:nvPr/>
-        </p:nvSpPr>
-        <p:spPr>
-          <a:xfrm>
-            <a:off x="8958518" y="323849"/>
-            <a:ext cx="2266201" cy="1815879"/>
-          </a:xfrm>
-          <a:prstGeom prst="roundRect">
-            <a:avLst/>
-          </a:prstGeom>
-        </p:spPr>
-        <p:style>
-          <a:lnRef idx="2">
-            <a:schemeClr val="accent1">
-              <a:shade val="15000"/>
-            </a:schemeClr>
-          </a:lnRef>
-          <a:fillRef idx="1">
-            <a:schemeClr val="accent1"/>
-          </a:fillRef>
-          <a:effectRef idx="0">
-            <a:schemeClr val="accent1"/>
-          </a:effectRef>
-          <a:fontRef idx="minor">
-            <a:schemeClr val="lt1"/>
-          </a:fontRef>
-        </p:style>
-        <p:txBody>
-          <a:bodyPr rtlCol="0" anchor="ctr"/>
-          <a:lstStyle/>
-          <a:p>
-            <a:r>
-              <a:rPr lang="en-AU" sz="1600" b="1" u="sng" dirty="0"/>
-              <a:t>Target Customers:</a:t>
-            </a:r>
-          </a:p>
-          <a:p>
-            <a:pPr marL="285750" indent="-285750">
-              <a:buFontTx/>
-              <a:buChar char="-"/>
-            </a:pPr>
-            <a:r>
-              <a:rPr lang="en-AU" sz="1400" dirty="0"/>
-              <a:t>Commuters</a:t>
-            </a:r>
-          </a:p>
-          <a:p>
-            <a:pPr marL="285750" indent="-285750">
-              <a:buFontTx/>
-              <a:buChar char="-"/>
-            </a:pPr>
-            <a:r>
-              <a:rPr lang="en-AU" sz="1400" dirty="0"/>
-              <a:t>Travellers</a:t>
-            </a:r>
-          </a:p>
-          <a:p>
-            <a:pPr marL="285750" indent="-285750">
-              <a:buFontTx/>
-              <a:buChar char="-"/>
-            </a:pPr>
-            <a:r>
-              <a:rPr lang="en-AU" sz="1400" dirty="0"/>
-              <a:t>Logistics Companies</a:t>
-            </a:r>
-          </a:p>
-          <a:p>
-            <a:pPr marL="285750" indent="-285750">
-              <a:buFontTx/>
-              <a:buChar char="-"/>
-            </a:pPr>
-            <a:r>
-              <a:rPr lang="en-AU" sz="1400" dirty="0"/>
-              <a:t>Government Agencies</a:t>
-            </a:r>
-          </a:p>
-          <a:p>
-            <a:pPr marL="285750" indent="-285750">
-              <a:buFontTx/>
-              <a:buChar char="-"/>
-            </a:pPr>
-            <a:r>
-              <a:rPr lang="en-AU" sz="1400" dirty="0"/>
-              <a:t>SES</a:t>
-            </a:r>
-          </a:p>
-        </p:txBody>
-      </p:sp>
-      <p:sp>
-        <p:nvSpPr>
-          <p:cNvPr id="9" name="Rectangle: Rounded Corners 8">
-            <a:extLst>
-              <a:ext uri="{FF2B5EF4-FFF2-40B4-BE49-F238E27FC236}">
-                <a16:creationId xmlns:a16="http://schemas.microsoft.com/office/drawing/2014/main" id="{ED847631-9825-C933-5C77-A1E25AE5A169}"/>
-              </a:ext>
-            </a:extLst>
-          </p:cNvPr>
-          <p:cNvSpPr/>
-          <p:nvPr/>
-        </p:nvSpPr>
-        <p:spPr>
-          <a:xfrm>
-            <a:off x="5832193" y="4516948"/>
-            <a:ext cx="5865373" cy="1923123"/>
-          </a:xfrm>
-          <a:prstGeom prst="roundRect">
-            <a:avLst/>
-          </a:prstGeom>
-        </p:spPr>
-        <p:style>
-          <a:lnRef idx="2">
-            <a:schemeClr val="accent1">
-              <a:shade val="15000"/>
-            </a:schemeClr>
-          </a:lnRef>
-          <a:fillRef idx="1">
-            <a:schemeClr val="accent1"/>
-          </a:fillRef>
-          <a:effectRef idx="0">
-            <a:schemeClr val="accent1"/>
-          </a:effectRef>
-          <a:fontRef idx="minor">
-            <a:schemeClr val="lt1"/>
-          </a:fontRef>
-        </p:style>
-        <p:txBody>
-          <a:bodyPr rtlCol="0" anchor="ctr"/>
-          <a:lstStyle/>
-          <a:p>
-            <a:pPr algn="ctr"/>
-            <a:r>
-              <a:rPr lang="en-AU" sz="1600" b="1" u="sng" dirty="0"/>
-              <a:t>Solving the issue</a:t>
-            </a:r>
-          </a:p>
-          <a:p>
-            <a:pPr algn="ctr"/>
-            <a:r>
-              <a:rPr lang="en-AU" sz="1400" dirty="0"/>
-              <a:t>The Disaster Map can provide users of the road with vital information before starting their commute. Unlike navigational apps, users can identify the roads that are blocked due to flooding, fallen trees etc.</a:t>
-            </a:r>
-          </a:p>
-        </p:txBody>
-      </p:sp>
-      <p:pic>
-        <p:nvPicPr>
-          <p:cNvPr id="15" name="Picture 14" descr="A black and blue logo&#10;&#10;AI-generated content may be incorrect.">
-            <a:extLst>
-              <a:ext uri="{FF2B5EF4-FFF2-40B4-BE49-F238E27FC236}">
-                <a16:creationId xmlns:a16="http://schemas.microsoft.com/office/drawing/2014/main" id="{0177F9A6-E538-34A4-A8F0-3CC5D09B1C16}"/>
+          <p:cNvPr id="23" name="Picture 22" descr="A fire on the road&#10;&#10;AI-generated content may be incorrect.">
+            <a:extLst>
+              <a:ext uri="{FF2B5EF4-FFF2-40B4-BE49-F238E27FC236}">
+                <a16:creationId xmlns:a16="http://schemas.microsoft.com/office/drawing/2014/main" id="{3CCDC3BA-36B3-F251-6C0B-C4804F5C463E}"/>
               </a:ext>
             </a:extLst>
           </p:cNvPr>
@@ -4916,10 +4563,13 @@
           <p:nvPr/>
         </p:nvPicPr>
         <p:blipFill>
-          <a:blip r:embed="rId5">
+          <a:blip r:embed="rId2">
             <a:extLst>
               <a:ext uri="{28A0092B-C50C-407E-A947-70E740481C1C}">
                 <a14:useLocalDpi xmlns:a14="http://schemas.microsoft.com/office/drawing/2010/main" val="0"/>
+              </a:ext>
+              <a:ext uri="{837473B0-CC2E-450A-ABE3-18F120FF3D39}">
+                <a1611:picAttrSrcUrl xmlns:a1611="http://schemas.microsoft.com/office/drawing/2016/11/main" r:id="rId3"/>
               </a:ext>
             </a:extLst>
           </a:blip>
@@ -4929,8 +4579,152 @@
         </p:blipFill>
         <p:spPr>
           <a:xfrm>
-            <a:off x="3177006" y="-33723"/>
-            <a:ext cx="5622882" cy="1938357"/>
+            <a:off x="8313518" y="800507"/>
+            <a:ext cx="3252903" cy="2168602"/>
+          </a:xfrm>
+          <a:prstGeom prst="rect">
+            <a:avLst/>
+          </a:prstGeom>
+        </p:spPr>
+      </p:pic>
+      <p:pic>
+        <p:nvPicPr>
+          <p:cNvPr id="20" name="Picture 19" descr="A map of a hurricane&#10;&#10;AI-generated content may be incorrect.">
+            <a:extLst>
+              <a:ext uri="{FF2B5EF4-FFF2-40B4-BE49-F238E27FC236}">
+                <a16:creationId xmlns:a16="http://schemas.microsoft.com/office/drawing/2014/main" id="{1DB03C59-D092-F4B1-3A46-35620F07C555}"/>
+              </a:ext>
+            </a:extLst>
+          </p:cNvPr>
+          <p:cNvPicPr>
+            <a:picLocks noChangeAspect="1"/>
+          </p:cNvPicPr>
+          <p:nvPr/>
+        </p:nvPicPr>
+        <p:blipFill>
+          <a:blip r:embed="rId4">
+            <a:extLst>
+              <a:ext uri="{28A0092B-C50C-407E-A947-70E740481C1C}">
+                <a14:useLocalDpi xmlns:a14="http://schemas.microsoft.com/office/drawing/2010/main" val="0"/>
+              </a:ext>
+              <a:ext uri="{837473B0-CC2E-450A-ABE3-18F120FF3D39}">
+                <a1611:picAttrSrcUrl xmlns:a1611="http://schemas.microsoft.com/office/drawing/2016/11/main" r:id="rId5"/>
+              </a:ext>
+            </a:extLst>
+          </a:blip>
+          <a:stretch>
+            <a:fillRect/>
+          </a:stretch>
+        </p:blipFill>
+        <p:spPr>
+          <a:xfrm>
+            <a:off x="622549" y="3897279"/>
+            <a:ext cx="3104943" cy="2173460"/>
+          </a:xfrm>
+          <a:prstGeom prst="rect">
+            <a:avLst/>
+          </a:prstGeom>
+        </p:spPr>
+      </p:pic>
+      <p:pic>
+        <p:nvPicPr>
+          <p:cNvPr id="11" name="Picture 10" descr="A logo on a black background&#10;&#10;AI-generated content may be incorrect.">
+            <a:extLst>
+              <a:ext uri="{FF2B5EF4-FFF2-40B4-BE49-F238E27FC236}">
+                <a16:creationId xmlns:a16="http://schemas.microsoft.com/office/drawing/2014/main" id="{04563644-4933-1DBD-8017-B6242666B3D7}"/>
+              </a:ext>
+            </a:extLst>
+          </p:cNvPr>
+          <p:cNvPicPr>
+            <a:picLocks noChangeAspect="1"/>
+          </p:cNvPicPr>
+          <p:nvPr/>
+        </p:nvPicPr>
+        <p:blipFill>
+          <a:blip r:embed="rId6"/>
+          <a:stretch>
+            <a:fillRect/>
+          </a:stretch>
+        </p:blipFill>
+        <p:spPr>
+          <a:xfrm>
+            <a:off x="4381676" y="1809578"/>
+            <a:ext cx="3252903" cy="3252903"/>
+          </a:xfrm>
+          <a:prstGeom prst="rect">
+            <a:avLst/>
+          </a:prstGeom>
+        </p:spPr>
+      </p:pic>
+      <p:pic>
+        <p:nvPicPr>
+          <p:cNvPr id="15" name="Picture 14" descr="A group of people walking in front of a fireworks&#10;&#10;AI-generated content may be incorrect.">
+            <a:extLst>
+              <a:ext uri="{FF2B5EF4-FFF2-40B4-BE49-F238E27FC236}">
+                <a16:creationId xmlns:a16="http://schemas.microsoft.com/office/drawing/2014/main" id="{AFA63ADB-78E3-56FD-6686-A5BB81893077}"/>
+              </a:ext>
+            </a:extLst>
+          </p:cNvPr>
+          <p:cNvPicPr>
+            <a:picLocks noChangeAspect="1"/>
+          </p:cNvPicPr>
+          <p:nvPr/>
+        </p:nvPicPr>
+        <p:blipFill>
+          <a:blip r:embed="rId7">
+            <a:extLst>
+              <a:ext uri="{28A0092B-C50C-407E-A947-70E740481C1C}">
+                <a14:useLocalDpi xmlns:a14="http://schemas.microsoft.com/office/drawing/2010/main" val="0"/>
+              </a:ext>
+              <a:ext uri="{837473B0-CC2E-450A-ABE3-18F120FF3D39}">
+                <a1611:picAttrSrcUrl xmlns:a1611="http://schemas.microsoft.com/office/drawing/2016/11/main" r:id="rId8"/>
+              </a:ext>
+            </a:extLst>
+          </a:blip>
+          <a:stretch>
+            <a:fillRect/>
+          </a:stretch>
+        </p:blipFill>
+        <p:spPr>
+          <a:xfrm>
+            <a:off x="548568" y="974182"/>
+            <a:ext cx="3252903" cy="1799829"/>
+          </a:xfrm>
+          <a:prstGeom prst="rect">
+            <a:avLst/>
+          </a:prstGeom>
+        </p:spPr>
+      </p:pic>
+      <p:pic>
+        <p:nvPicPr>
+          <p:cNvPr id="13" name="Picture 12" descr="Red pinpointers pinned on a road">
+            <a:extLst>
+              <a:ext uri="{FF2B5EF4-FFF2-40B4-BE49-F238E27FC236}">
+                <a16:creationId xmlns:a16="http://schemas.microsoft.com/office/drawing/2014/main" id="{A41591ED-3879-7641-579E-976277B0D191}"/>
+              </a:ext>
+            </a:extLst>
+          </p:cNvPr>
+          <p:cNvPicPr>
+            <a:picLocks noChangeAspect="1"/>
+          </p:cNvPicPr>
+          <p:nvPr/>
+        </p:nvPicPr>
+        <p:blipFill>
+          <a:blip r:embed="rId9">
+            <a:extLst>
+              <a:ext uri="{28A0092B-C50C-407E-A947-70E740481C1C}">
+                <a14:useLocalDpi xmlns:a14="http://schemas.microsoft.com/office/drawing/2010/main" val="0"/>
+              </a:ext>
+            </a:extLst>
+          </a:blip>
+          <a:stretch>
+            <a:fillRect/>
+          </a:stretch>
+        </p:blipFill>
+        <p:spPr>
+          <a:xfrm>
+            <a:off x="8378897" y="4020466"/>
+            <a:ext cx="3122143" cy="2084030"/>
           </a:xfrm>
           <a:prstGeom prst="rect">
             <a:avLst/>
@@ -4940,13 +4734,412 @@
     </p:spTree>
     <p:extLst>
       <p:ext uri="{BB962C8B-B14F-4D97-AF65-F5344CB8AC3E}">
-        <p14:creationId xmlns:p14="http://schemas.microsoft.com/office/powerpoint/2010/main" val="2908254028"/>
+        <p14:creationId xmlns:p14="http://schemas.microsoft.com/office/powerpoint/2010/main" val="2807950182"/>
       </p:ext>
     </p:extLst>
   </p:cSld>
   <p:clrMapOvr>
     <a:masterClrMapping/>
   </p:clrMapOvr>
+  <mc:AlternateContent xmlns:mc="http://schemas.openxmlformats.org/markup-compatibility/2006" xmlns:p14="http://schemas.microsoft.com/office/powerpoint/2010/main">
+    <mc:Choice Requires="p14">
+      <p:transition spd="slow" p14:dur="2000">
+        <p14:ferris dir="l"/>
+      </p:transition>
+    </mc:Choice>
+    <mc:Fallback xmlns="">
+      <p:transition spd="slow">
+        <p:fade/>
+      </p:transition>
+    </mc:Fallback>
+  </mc:AlternateContent>
+  <p:timing>
+    <p:tnLst>
+      <p:par>
+        <p:cTn id="1" dur="indefinite" restart="never" nodeType="tmRoot">
+          <p:childTnLst>
+            <p:seq concurrent="1" nextAc="seek">
+              <p:cTn id="2" dur="indefinite" nodeType="mainSeq">
+                <p:childTnLst>
+                  <p:par>
+                    <p:cTn id="3" fill="hold">
+                      <p:stCondLst>
+                        <p:cond delay="indefinite"/>
+                      </p:stCondLst>
+                      <p:childTnLst>
+                        <p:par>
+                          <p:cTn id="4" fill="hold">
+                            <p:stCondLst>
+                              <p:cond delay="0"/>
+                            </p:stCondLst>
+                            <p:childTnLst>
+                              <p:par>
+                                <p:cTn id="5" presetID="10" presetClass="entr" presetSubtype="0" fill="hold" nodeType="clickEffect">
+                                  <p:stCondLst>
+                                    <p:cond delay="0"/>
+                                  </p:stCondLst>
+                                  <p:childTnLst>
+                                    <p:set>
+                                      <p:cBhvr>
+                                        <p:cTn id="6" dur="1" fill="hold">
+                                          <p:stCondLst>
+                                            <p:cond delay="0"/>
+                                          </p:stCondLst>
+                                        </p:cTn>
+                                        <p:tgtEl>
+                                          <p:spTgt spid="15"/>
+                                        </p:tgtEl>
+                                        <p:attrNameLst>
+                                          <p:attrName>style.visibility</p:attrName>
+                                        </p:attrNameLst>
+                                      </p:cBhvr>
+                                      <p:to>
+                                        <p:strVal val="visible"/>
+                                      </p:to>
+                                    </p:set>
+                                    <p:animEffect transition="in" filter="fade">
+                                      <p:cBhvr>
+                                        <p:cTn id="7" dur="500"/>
+                                        <p:tgtEl>
+                                          <p:spTgt spid="15"/>
+                                        </p:tgtEl>
+                                      </p:cBhvr>
+                                    </p:animEffect>
+                                  </p:childTnLst>
+                                </p:cTn>
+                              </p:par>
+                            </p:childTnLst>
+                          </p:cTn>
+                        </p:par>
+                      </p:childTnLst>
+                    </p:cTn>
+                  </p:par>
+                  <p:par>
+                    <p:cTn id="8" fill="hold">
+                      <p:stCondLst>
+                        <p:cond delay="indefinite"/>
+                      </p:stCondLst>
+                      <p:childTnLst>
+                        <p:par>
+                          <p:cTn id="9" fill="hold">
+                            <p:stCondLst>
+                              <p:cond delay="0"/>
+                            </p:stCondLst>
+                            <p:childTnLst>
+                              <p:par>
+                                <p:cTn id="10" presetID="42" presetClass="entr" presetSubtype="0" fill="hold" nodeType="clickEffect">
+                                  <p:stCondLst>
+                                    <p:cond delay="0"/>
+                                  </p:stCondLst>
+                                  <p:childTnLst>
+                                    <p:set>
+                                      <p:cBhvr>
+                                        <p:cTn id="11" dur="1" fill="hold">
+                                          <p:stCondLst>
+                                            <p:cond delay="0"/>
+                                          </p:stCondLst>
+                                        </p:cTn>
+                                        <p:tgtEl>
+                                          <p:spTgt spid="20"/>
+                                        </p:tgtEl>
+                                        <p:attrNameLst>
+                                          <p:attrName>style.visibility</p:attrName>
+                                        </p:attrNameLst>
+                                      </p:cBhvr>
+                                      <p:to>
+                                        <p:strVal val="visible"/>
+                                      </p:to>
+                                    </p:set>
+                                    <p:animEffect transition="in" filter="fade">
+                                      <p:cBhvr>
+                                        <p:cTn id="12" dur="1000"/>
+                                        <p:tgtEl>
+                                          <p:spTgt spid="20"/>
+                                        </p:tgtEl>
+                                      </p:cBhvr>
+                                    </p:animEffect>
+                                    <p:anim calcmode="lin" valueType="num">
+                                      <p:cBhvr>
+                                        <p:cTn id="13" dur="1000" fill="hold"/>
+                                        <p:tgtEl>
+                                          <p:spTgt spid="20"/>
+                                        </p:tgtEl>
+                                        <p:attrNameLst>
+                                          <p:attrName>ppt_x</p:attrName>
+                                        </p:attrNameLst>
+                                      </p:cBhvr>
+                                      <p:tavLst>
+                                        <p:tav tm="0">
+                                          <p:val>
+                                            <p:strVal val="#ppt_x"/>
+                                          </p:val>
+                                        </p:tav>
+                                        <p:tav tm="100000">
+                                          <p:val>
+                                            <p:strVal val="#ppt_x"/>
+                                          </p:val>
+                                        </p:tav>
+                                      </p:tavLst>
+                                    </p:anim>
+                                    <p:anim calcmode="lin" valueType="num">
+                                      <p:cBhvr>
+                                        <p:cTn id="14" dur="1000" fill="hold"/>
+                                        <p:tgtEl>
+                                          <p:spTgt spid="20"/>
+                                        </p:tgtEl>
+                                        <p:attrNameLst>
+                                          <p:attrName>ppt_y</p:attrName>
+                                        </p:attrNameLst>
+                                      </p:cBhvr>
+                                      <p:tavLst>
+                                        <p:tav tm="0">
+                                          <p:val>
+                                            <p:strVal val="#ppt_y+.1"/>
+                                          </p:val>
+                                        </p:tav>
+                                        <p:tav tm="100000">
+                                          <p:val>
+                                            <p:strVal val="#ppt_y"/>
+                                          </p:val>
+                                        </p:tav>
+                                      </p:tavLst>
+                                    </p:anim>
+                                  </p:childTnLst>
+                                </p:cTn>
+                              </p:par>
+                            </p:childTnLst>
+                          </p:cTn>
+                        </p:par>
+                      </p:childTnLst>
+                    </p:cTn>
+                  </p:par>
+                  <p:par>
+                    <p:cTn id="15" fill="hold">
+                      <p:stCondLst>
+                        <p:cond delay="indefinite"/>
+                      </p:stCondLst>
+                      <p:childTnLst>
+                        <p:par>
+                          <p:cTn id="16" fill="hold">
+                            <p:stCondLst>
+                              <p:cond delay="0"/>
+                            </p:stCondLst>
+                            <p:childTnLst>
+                              <p:par>
+                                <p:cTn id="17" presetID="14" presetClass="entr" presetSubtype="10" fill="hold" nodeType="clickEffect">
+                                  <p:stCondLst>
+                                    <p:cond delay="0"/>
+                                  </p:stCondLst>
+                                  <p:childTnLst>
+                                    <p:set>
+                                      <p:cBhvr>
+                                        <p:cTn id="18" dur="1" fill="hold">
+                                          <p:stCondLst>
+                                            <p:cond delay="0"/>
+                                          </p:stCondLst>
+                                        </p:cTn>
+                                        <p:tgtEl>
+                                          <p:spTgt spid="23"/>
+                                        </p:tgtEl>
+                                        <p:attrNameLst>
+                                          <p:attrName>style.visibility</p:attrName>
+                                        </p:attrNameLst>
+                                      </p:cBhvr>
+                                      <p:to>
+                                        <p:strVal val="visible"/>
+                                      </p:to>
+                                    </p:set>
+                                    <p:animEffect transition="in" filter="randombar(horizontal)">
+                                      <p:cBhvr>
+                                        <p:cTn id="19" dur="500"/>
+                                        <p:tgtEl>
+                                          <p:spTgt spid="23"/>
+                                        </p:tgtEl>
+                                      </p:cBhvr>
+                                    </p:animEffect>
+                                  </p:childTnLst>
+                                </p:cTn>
+                              </p:par>
+                            </p:childTnLst>
+                          </p:cTn>
+                        </p:par>
+                      </p:childTnLst>
+                    </p:cTn>
+                  </p:par>
+                  <p:par>
+                    <p:cTn id="20" fill="hold">
+                      <p:stCondLst>
+                        <p:cond delay="indefinite"/>
+                      </p:stCondLst>
+                      <p:childTnLst>
+                        <p:par>
+                          <p:cTn id="21" fill="hold">
+                            <p:stCondLst>
+                              <p:cond delay="0"/>
+                            </p:stCondLst>
+                            <p:childTnLst>
+                              <p:par>
+                                <p:cTn id="22" presetID="45" presetClass="entr" presetSubtype="0" fill="hold" nodeType="clickEffect">
+                                  <p:stCondLst>
+                                    <p:cond delay="0"/>
+                                  </p:stCondLst>
+                                  <p:childTnLst>
+                                    <p:set>
+                                      <p:cBhvr>
+                                        <p:cTn id="23" dur="1" fill="hold">
+                                          <p:stCondLst>
+                                            <p:cond delay="0"/>
+                                          </p:stCondLst>
+                                        </p:cTn>
+                                        <p:tgtEl>
+                                          <p:spTgt spid="13"/>
+                                        </p:tgtEl>
+                                        <p:attrNameLst>
+                                          <p:attrName>style.visibility</p:attrName>
+                                        </p:attrNameLst>
+                                      </p:cBhvr>
+                                      <p:to>
+                                        <p:strVal val="visible"/>
+                                      </p:to>
+                                    </p:set>
+                                    <p:animEffect transition="in" filter="fade">
+                                      <p:cBhvr>
+                                        <p:cTn id="24" dur="2000"/>
+                                        <p:tgtEl>
+                                          <p:spTgt spid="13"/>
+                                        </p:tgtEl>
+                                      </p:cBhvr>
+                                    </p:animEffect>
+                                    <p:anim calcmode="lin" valueType="num">
+                                      <p:cBhvr>
+                                        <p:cTn id="25" dur="2000" fill="hold"/>
+                                        <p:tgtEl>
+                                          <p:spTgt spid="13"/>
+                                        </p:tgtEl>
+                                        <p:attrNameLst>
+                                          <p:attrName>ppt_w</p:attrName>
+                                        </p:attrNameLst>
+                                      </p:cBhvr>
+                                      <p:tavLst>
+                                        <p:tav tm="0" fmla="#ppt_w*sin(2.5*pi*$)">
+                                          <p:val>
+                                            <p:fltVal val="0"/>
+                                          </p:val>
+                                        </p:tav>
+                                        <p:tav tm="100000">
+                                          <p:val>
+                                            <p:fltVal val="1"/>
+                                          </p:val>
+                                        </p:tav>
+                                      </p:tavLst>
+                                    </p:anim>
+                                    <p:anim calcmode="lin" valueType="num">
+                                      <p:cBhvr>
+                                        <p:cTn id="26" dur="2000" fill="hold"/>
+                                        <p:tgtEl>
+                                          <p:spTgt spid="13"/>
+                                        </p:tgtEl>
+                                        <p:attrNameLst>
+                                          <p:attrName>ppt_h</p:attrName>
+                                        </p:attrNameLst>
+                                      </p:cBhvr>
+                                      <p:tavLst>
+                                        <p:tav tm="0">
+                                          <p:val>
+                                            <p:strVal val="#ppt_h"/>
+                                          </p:val>
+                                        </p:tav>
+                                        <p:tav tm="100000">
+                                          <p:val>
+                                            <p:strVal val="#ppt_h"/>
+                                          </p:val>
+                                        </p:tav>
+                                      </p:tavLst>
+                                    </p:anim>
+                                  </p:childTnLst>
+                                </p:cTn>
+                              </p:par>
+                            </p:childTnLst>
+                          </p:cTn>
+                        </p:par>
+                      </p:childTnLst>
+                    </p:cTn>
+                  </p:par>
+                  <p:par>
+                    <p:cTn id="27" fill="hold">
+                      <p:stCondLst>
+                        <p:cond delay="indefinite"/>
+                      </p:stCondLst>
+                      <p:childTnLst>
+                        <p:par>
+                          <p:cTn id="28" fill="hold">
+                            <p:stCondLst>
+                              <p:cond delay="0"/>
+                            </p:stCondLst>
+                            <p:childTnLst>
+                              <p:par>
+                                <p:cTn id="29" presetID="16" presetClass="entr" presetSubtype="21" fill="hold" nodeType="clickEffect">
+                                  <p:stCondLst>
+                                    <p:cond delay="0"/>
+                                  </p:stCondLst>
+                                  <p:childTnLst>
+                                    <p:set>
+                                      <p:cBhvr>
+                                        <p:cTn id="30" dur="1" fill="hold">
+                                          <p:stCondLst>
+                                            <p:cond delay="0"/>
+                                          </p:stCondLst>
+                                        </p:cTn>
+                                        <p:tgtEl>
+                                          <p:spTgt spid="11"/>
+                                        </p:tgtEl>
+                                        <p:attrNameLst>
+                                          <p:attrName>style.visibility</p:attrName>
+                                        </p:attrNameLst>
+                                      </p:cBhvr>
+                                      <p:to>
+                                        <p:strVal val="visible"/>
+                                      </p:to>
+                                    </p:set>
+                                    <p:animEffect transition="in" filter="barn(inVertical)">
+                                      <p:cBhvr>
+                                        <p:cTn id="31" dur="500"/>
+                                        <p:tgtEl>
+                                          <p:spTgt spid="11"/>
+                                        </p:tgtEl>
+                                      </p:cBhvr>
+                                    </p:animEffect>
+                                  </p:childTnLst>
+                                </p:cTn>
+                              </p:par>
+                            </p:childTnLst>
+                          </p:cTn>
+                        </p:par>
+                      </p:childTnLst>
+                    </p:cTn>
+                  </p:par>
+                </p:childTnLst>
+              </p:cTn>
+              <p:prevCondLst>
+                <p:cond evt="onPrev" delay="0">
+                  <p:tgtEl>
+                    <p:sldTgt/>
+                  </p:tgtEl>
+                </p:cond>
+              </p:prevCondLst>
+              <p:nextCondLst>
+                <p:cond evt="onNext" delay="0">
+                  <p:tgtEl>
+                    <p:sldTgt/>
+                  </p:tgtEl>
+                </p:cond>
+              </p:nextCondLst>
+            </p:seq>
+          </p:childTnLst>
+        </p:cTn>
+      </p:par>
+    </p:tnLst>
+  </p:timing>
 </p:sld>
 </file>
 
@@ -4977,6 +5170,481 @@
           <a:chExt cx="0" cy="0"/>
         </a:xfrm>
       </p:grpSpPr>
+      <p:pic>
+        <p:nvPicPr>
+          <p:cNvPr id="1030" name="Picture 6" descr="⛈️ SEVERE STORM BRINGS FLASH FLOODING - #NEWCASTLE AREA - 6:40PM, Wednesday  30th April A severe storm has impacted the Newcastle and Hunter region this  afternoon, resulting in significant flash flooding across">
+            <a:extLst>
+              <a:ext uri="{FF2B5EF4-FFF2-40B4-BE49-F238E27FC236}">
+                <a16:creationId xmlns:a16="http://schemas.microsoft.com/office/drawing/2014/main" id="{445C3104-AD31-4505-1171-164EB9E1EAAF}"/>
+              </a:ext>
+            </a:extLst>
+          </p:cNvPr>
+          <p:cNvPicPr>
+            <a:picLocks noChangeAspect="1" noChangeArrowheads="1"/>
+          </p:cNvPicPr>
+          <p:nvPr/>
+        </p:nvPicPr>
+        <p:blipFill>
+          <a:blip r:embed="rId3">
+            <a:extLst>
+              <a:ext uri="{28A0092B-C50C-407E-A947-70E740481C1C}">
+                <a14:useLocalDpi xmlns:a14="http://schemas.microsoft.com/office/drawing/2010/main" val="0"/>
+              </a:ext>
+            </a:extLst>
+          </a:blip>
+          <a:srcRect/>
+          <a:stretch>
+            <a:fillRect/>
+          </a:stretch>
+        </p:blipFill>
+        <p:spPr bwMode="auto">
+          <a:xfrm>
+            <a:off x="691939" y="453238"/>
+            <a:ext cx="2173220" cy="2713822"/>
+          </a:xfrm>
+          <a:prstGeom prst="rect">
+            <a:avLst/>
+          </a:prstGeom>
+          <a:noFill/>
+          <a:extLst>
+            <a:ext uri="{909E8E84-426E-40DD-AFC4-6F175D3DCCD1}">
+              <a14:hiddenFill xmlns:a14="http://schemas.microsoft.com/office/drawing/2010/main">
+                <a:solidFill>
+                  <a:srgbClr val="FFFFFF"/>
+                </a:solidFill>
+              </a14:hiddenFill>
+            </a:ext>
+          </a:extLst>
+        </p:spPr>
+      </p:pic>
+      <p:pic>
+        <p:nvPicPr>
+          <p:cNvPr id="1032" name="Picture 8" descr="Death toll rises to three as NSW floods hammer Mid North Coast - ABC News">
+            <a:extLst>
+              <a:ext uri="{FF2B5EF4-FFF2-40B4-BE49-F238E27FC236}">
+                <a16:creationId xmlns:a16="http://schemas.microsoft.com/office/drawing/2014/main" id="{94FA7E5F-2DBF-F6F8-32D4-275375F816F4}"/>
+              </a:ext>
+            </a:extLst>
+          </p:cNvPr>
+          <p:cNvPicPr>
+            <a:picLocks noChangeAspect="1" noChangeArrowheads="1"/>
+          </p:cNvPicPr>
+          <p:nvPr/>
+        </p:nvPicPr>
+        <p:blipFill>
+          <a:blip r:embed="rId4">
+            <a:extLst>
+              <a:ext uri="{28A0092B-C50C-407E-A947-70E740481C1C}">
+                <a14:useLocalDpi xmlns:a14="http://schemas.microsoft.com/office/drawing/2010/main" val="0"/>
+              </a:ext>
+            </a:extLst>
+          </a:blip>
+          <a:srcRect/>
+          <a:stretch>
+            <a:fillRect/>
+          </a:stretch>
+        </p:blipFill>
+        <p:spPr bwMode="auto">
+          <a:xfrm>
+            <a:off x="494434" y="3690940"/>
+            <a:ext cx="5053296" cy="2843212"/>
+          </a:xfrm>
+          <a:prstGeom prst="rect">
+            <a:avLst/>
+          </a:prstGeom>
+          <a:noFill/>
+          <a:extLst>
+            <a:ext uri="{909E8E84-426E-40DD-AFC4-6F175D3DCCD1}">
+              <a14:hiddenFill xmlns:a14="http://schemas.microsoft.com/office/drawing/2010/main">
+                <a:solidFill>
+                  <a:srgbClr val="FFFFFF"/>
+                </a:solidFill>
+              </a14:hiddenFill>
+            </a:ext>
+          </a:extLst>
+        </p:spPr>
+      </p:pic>
+      <p:sp>
+        <p:nvSpPr>
+          <p:cNvPr id="4" name="Cloud 3">
+            <a:extLst>
+              <a:ext uri="{FF2B5EF4-FFF2-40B4-BE49-F238E27FC236}">
+                <a16:creationId xmlns:a16="http://schemas.microsoft.com/office/drawing/2014/main" id="{54A25444-AF9D-0465-313A-3273AF85D5D3}"/>
+              </a:ext>
+            </a:extLst>
+          </p:cNvPr>
+          <p:cNvSpPr/>
+          <p:nvPr/>
+        </p:nvSpPr>
+        <p:spPr>
+          <a:xfrm>
+            <a:off x="116172" y="2727515"/>
+            <a:ext cx="2593063" cy="1445442"/>
+          </a:xfrm>
+          <a:prstGeom prst="cloud">
+            <a:avLst/>
+          </a:prstGeom>
+        </p:spPr>
+        <p:style>
+          <a:lnRef idx="2">
+            <a:schemeClr val="accent1">
+              <a:shade val="15000"/>
+            </a:schemeClr>
+          </a:lnRef>
+          <a:fillRef idx="1">
+            <a:schemeClr val="accent1"/>
+          </a:fillRef>
+          <a:effectRef idx="0">
+            <a:schemeClr val="accent1"/>
+          </a:effectRef>
+          <a:fontRef idx="minor">
+            <a:schemeClr val="lt1"/>
+          </a:fontRef>
+        </p:style>
+        <p:txBody>
+          <a:bodyPr rtlCol="0" anchor="ctr"/>
+          <a:lstStyle/>
+          <a:p>
+            <a:pPr algn="ctr"/>
+            <a:r>
+              <a:rPr lang="en-AU" dirty="0"/>
+              <a:t>May 2025 Newcastle-Mid North Coast Floods</a:t>
+            </a:r>
+          </a:p>
+        </p:txBody>
+      </p:sp>
+      <p:sp>
+        <p:nvSpPr>
+          <p:cNvPr id="5" name="Speech Bubble: Rectangle 4">
+            <a:extLst>
+              <a:ext uri="{FF2B5EF4-FFF2-40B4-BE49-F238E27FC236}">
+                <a16:creationId xmlns:a16="http://schemas.microsoft.com/office/drawing/2014/main" id="{2730DF34-2086-9D48-B211-E99499482C36}"/>
+              </a:ext>
+            </a:extLst>
+          </p:cNvPr>
+          <p:cNvSpPr/>
+          <p:nvPr/>
+        </p:nvSpPr>
+        <p:spPr>
+          <a:xfrm>
+            <a:off x="3021082" y="1904634"/>
+            <a:ext cx="2414132" cy="1430448"/>
+          </a:xfrm>
+          <a:prstGeom prst="wedgeRectCallout">
+            <a:avLst/>
+          </a:prstGeom>
+        </p:spPr>
+        <p:style>
+          <a:lnRef idx="2">
+            <a:schemeClr val="accent1">
+              <a:shade val="15000"/>
+            </a:schemeClr>
+          </a:lnRef>
+          <a:fillRef idx="1">
+            <a:schemeClr val="accent1"/>
+          </a:fillRef>
+          <a:effectRef idx="0">
+            <a:schemeClr val="accent1"/>
+          </a:effectRef>
+          <a:fontRef idx="minor">
+            <a:schemeClr val="lt1"/>
+          </a:fontRef>
+        </p:style>
+        <p:txBody>
+          <a:bodyPr rtlCol="0" anchor="ctr"/>
+          <a:lstStyle/>
+          <a:p>
+            <a:pPr algn="ctr"/>
+            <a:r>
+              <a:rPr lang="en-AU" sz="1400" dirty="0"/>
+              <a:t>“I’ve been driving around for 7 hours trying to find a way north and all the navigational apps have been wrong” – (Post seen on Facebook)</a:t>
+            </a:r>
+          </a:p>
+        </p:txBody>
+      </p:sp>
+      <p:sp>
+        <p:nvSpPr>
+          <p:cNvPr id="7" name="Rectangle: Rounded Corners 6">
+            <a:extLst>
+              <a:ext uri="{FF2B5EF4-FFF2-40B4-BE49-F238E27FC236}">
+                <a16:creationId xmlns:a16="http://schemas.microsoft.com/office/drawing/2014/main" id="{A952360B-AA0A-B99E-A742-05502A9FBCB4}"/>
+              </a:ext>
+            </a:extLst>
+          </p:cNvPr>
+          <p:cNvSpPr/>
+          <p:nvPr/>
+        </p:nvSpPr>
+        <p:spPr>
+          <a:xfrm>
+            <a:off x="6219506" y="2540686"/>
+            <a:ext cx="5053295" cy="1588792"/>
+          </a:xfrm>
+          <a:prstGeom prst="roundRect">
+            <a:avLst/>
+          </a:prstGeom>
+        </p:spPr>
+        <p:style>
+          <a:lnRef idx="2">
+            <a:schemeClr val="accent1">
+              <a:shade val="15000"/>
+            </a:schemeClr>
+          </a:lnRef>
+          <a:fillRef idx="1">
+            <a:schemeClr val="accent1"/>
+          </a:fillRef>
+          <a:effectRef idx="0">
+            <a:schemeClr val="accent1"/>
+          </a:effectRef>
+          <a:fontRef idx="minor">
+            <a:schemeClr val="lt1"/>
+          </a:fontRef>
+        </p:style>
+        <p:txBody>
+          <a:bodyPr rtlCol="0" anchor="ctr"/>
+          <a:lstStyle/>
+          <a:p>
+            <a:pPr algn="ctr"/>
+            <a:r>
+              <a:rPr lang="en-AU" sz="1600" b="1" u="sng" dirty="0"/>
+              <a:t>Concept:</a:t>
+            </a:r>
+            <a:r>
+              <a:rPr lang="en-AU" sz="1400" dirty="0"/>
+              <a:t> During major weather events, users can view, and report hazards they have witnessed including exact locations, descriptions and images.</a:t>
+            </a:r>
+          </a:p>
+        </p:txBody>
+      </p:sp>
+      <p:sp>
+        <p:nvSpPr>
+          <p:cNvPr id="8" name="Rectangle: Rounded Corners 7">
+            <a:extLst>
+              <a:ext uri="{FF2B5EF4-FFF2-40B4-BE49-F238E27FC236}">
+                <a16:creationId xmlns:a16="http://schemas.microsoft.com/office/drawing/2014/main" id="{52C01278-3E2A-2FA0-8E59-305F6A29AAF0}"/>
+              </a:ext>
+            </a:extLst>
+          </p:cNvPr>
+          <p:cNvSpPr/>
+          <p:nvPr/>
+        </p:nvSpPr>
+        <p:spPr>
+          <a:xfrm>
+            <a:off x="8958518" y="323849"/>
+            <a:ext cx="2266201" cy="1815879"/>
+          </a:xfrm>
+          <a:prstGeom prst="roundRect">
+            <a:avLst/>
+          </a:prstGeom>
+        </p:spPr>
+        <p:style>
+          <a:lnRef idx="2">
+            <a:schemeClr val="accent1">
+              <a:shade val="15000"/>
+            </a:schemeClr>
+          </a:lnRef>
+          <a:fillRef idx="1">
+            <a:schemeClr val="accent1"/>
+          </a:fillRef>
+          <a:effectRef idx="0">
+            <a:schemeClr val="accent1"/>
+          </a:effectRef>
+          <a:fontRef idx="minor">
+            <a:schemeClr val="lt1"/>
+          </a:fontRef>
+        </p:style>
+        <p:txBody>
+          <a:bodyPr rtlCol="0" anchor="ctr"/>
+          <a:lstStyle/>
+          <a:p>
+            <a:r>
+              <a:rPr lang="en-AU" sz="1600" b="1" u="sng" dirty="0"/>
+              <a:t>Target Customers:</a:t>
+            </a:r>
+          </a:p>
+          <a:p>
+            <a:pPr marL="285750" indent="-285750">
+              <a:buFontTx/>
+              <a:buChar char="-"/>
+            </a:pPr>
+            <a:r>
+              <a:rPr lang="en-AU" sz="1400" dirty="0"/>
+              <a:t>Commuters</a:t>
+            </a:r>
+          </a:p>
+          <a:p>
+            <a:pPr marL="285750" indent="-285750">
+              <a:buFontTx/>
+              <a:buChar char="-"/>
+            </a:pPr>
+            <a:r>
+              <a:rPr lang="en-AU" sz="1400" dirty="0"/>
+              <a:t>Travellers</a:t>
+            </a:r>
+          </a:p>
+          <a:p>
+            <a:pPr marL="285750" indent="-285750">
+              <a:buFontTx/>
+              <a:buChar char="-"/>
+            </a:pPr>
+            <a:r>
+              <a:rPr lang="en-AU" sz="1400" dirty="0"/>
+              <a:t>Logistics Companies</a:t>
+            </a:r>
+          </a:p>
+          <a:p>
+            <a:pPr marL="285750" indent="-285750">
+              <a:buFontTx/>
+              <a:buChar char="-"/>
+            </a:pPr>
+            <a:r>
+              <a:rPr lang="en-AU" sz="1400" dirty="0"/>
+              <a:t>Government Agencies</a:t>
+            </a:r>
+          </a:p>
+          <a:p>
+            <a:pPr marL="285750" indent="-285750">
+              <a:buFontTx/>
+              <a:buChar char="-"/>
+            </a:pPr>
+            <a:r>
+              <a:rPr lang="en-AU" sz="1400" dirty="0"/>
+              <a:t>SES</a:t>
+            </a:r>
+          </a:p>
+        </p:txBody>
+      </p:sp>
+      <p:sp>
+        <p:nvSpPr>
+          <p:cNvPr id="9" name="Rectangle: Rounded Corners 8">
+            <a:extLst>
+              <a:ext uri="{FF2B5EF4-FFF2-40B4-BE49-F238E27FC236}">
+                <a16:creationId xmlns:a16="http://schemas.microsoft.com/office/drawing/2014/main" id="{ED847631-9825-C933-5C77-A1E25AE5A169}"/>
+              </a:ext>
+            </a:extLst>
+          </p:cNvPr>
+          <p:cNvSpPr/>
+          <p:nvPr/>
+        </p:nvSpPr>
+        <p:spPr>
+          <a:xfrm>
+            <a:off x="5832193" y="4516948"/>
+            <a:ext cx="5865373" cy="1923123"/>
+          </a:xfrm>
+          <a:prstGeom prst="roundRect">
+            <a:avLst/>
+          </a:prstGeom>
+        </p:spPr>
+        <p:style>
+          <a:lnRef idx="2">
+            <a:schemeClr val="accent1">
+              <a:shade val="15000"/>
+            </a:schemeClr>
+          </a:lnRef>
+          <a:fillRef idx="1">
+            <a:schemeClr val="accent1"/>
+          </a:fillRef>
+          <a:effectRef idx="0">
+            <a:schemeClr val="accent1"/>
+          </a:effectRef>
+          <a:fontRef idx="minor">
+            <a:schemeClr val="lt1"/>
+          </a:fontRef>
+        </p:style>
+        <p:txBody>
+          <a:bodyPr rtlCol="0" anchor="ctr"/>
+          <a:lstStyle/>
+          <a:p>
+            <a:pPr algn="ctr"/>
+            <a:r>
+              <a:rPr lang="en-AU" sz="1600" b="1" u="sng" dirty="0"/>
+              <a:t>Solving the issue</a:t>
+            </a:r>
+          </a:p>
+          <a:p>
+            <a:pPr algn="ctr"/>
+            <a:r>
+              <a:rPr lang="en-AU" sz="1400" dirty="0"/>
+              <a:t>The Disaster Map can provide users of the road with vital information before starting their commute. Unlike navigational apps, users can identify the roads that are blocked due to flooding, fallen trees etc.</a:t>
+            </a:r>
+          </a:p>
+        </p:txBody>
+      </p:sp>
+      <p:pic>
+        <p:nvPicPr>
+          <p:cNvPr id="15" name="Picture 14" descr="A black and blue logo&#10;&#10;AI-generated content may be incorrect.">
+            <a:extLst>
+              <a:ext uri="{FF2B5EF4-FFF2-40B4-BE49-F238E27FC236}">
+                <a16:creationId xmlns:a16="http://schemas.microsoft.com/office/drawing/2014/main" id="{0177F9A6-E538-34A4-A8F0-3CC5D09B1C16}"/>
+              </a:ext>
+            </a:extLst>
+          </p:cNvPr>
+          <p:cNvPicPr>
+            <a:picLocks noChangeAspect="1"/>
+          </p:cNvPicPr>
+          <p:nvPr/>
+        </p:nvPicPr>
+        <p:blipFill>
+          <a:blip r:embed="rId5">
+            <a:extLst>
+              <a:ext uri="{28A0092B-C50C-407E-A947-70E740481C1C}">
+                <a14:useLocalDpi xmlns:a14="http://schemas.microsoft.com/office/drawing/2010/main" val="0"/>
+              </a:ext>
+            </a:extLst>
+          </a:blip>
+          <a:stretch>
+            <a:fillRect/>
+          </a:stretch>
+        </p:blipFill>
+        <p:spPr>
+          <a:xfrm>
+            <a:off x="3177006" y="-33723"/>
+            <a:ext cx="5622882" cy="1938357"/>
+          </a:xfrm>
+          <a:prstGeom prst="rect">
+            <a:avLst/>
+          </a:prstGeom>
+        </p:spPr>
+      </p:pic>
+    </p:spTree>
+    <p:extLst>
+      <p:ext uri="{BB962C8B-B14F-4D97-AF65-F5344CB8AC3E}">
+        <p14:creationId xmlns:p14="http://schemas.microsoft.com/office/powerpoint/2010/main" val="2908254028"/>
+      </p:ext>
+    </p:extLst>
+  </p:cSld>
+  <p:clrMapOvr>
+    <a:masterClrMapping/>
+  </p:clrMapOvr>
+</p:sld>
+</file>
+
+<file path=ppt/slides/slide3.xml><?xml version="1.0" encoding="utf-8"?>
+<p:sld xmlns:a="http://schemas.openxmlformats.org/drawingml/2006/main" xmlns:r="http://schemas.openxmlformats.org/officeDocument/2006/relationships" xmlns:p="http://schemas.openxmlformats.org/presentationml/2006/main">
+  <p:cSld>
+    <p:bg>
+      <p:bgPr>
+        <a:solidFill>
+          <a:schemeClr val="bg1">
+            <a:lumMod val="95000"/>
+          </a:schemeClr>
+        </a:solidFill>
+        <a:effectLst/>
+      </p:bgPr>
+    </p:bg>
+    <p:spTree>
+      <p:nvGrpSpPr>
+        <p:cNvPr id="1" name=""/>
+        <p:cNvGrpSpPr/>
+        <p:nvPr/>
+      </p:nvGrpSpPr>
+      <p:grpSpPr>
+        <a:xfrm>
+          <a:off x="0" y="0"/>
+          <a:ext cx="0" cy="0"/>
+          <a:chOff x="0" y="0"/>
+          <a:chExt cx="0" cy="0"/>
+        </a:xfrm>
+      </p:grpSpPr>
       <p:sp>
         <p:nvSpPr>
           <p:cNvPr id="4" name="Rectangle 3">
@@ -6036,7 +6704,7 @@
 </p:sld>
 </file>
 
-<file path=ppt/slides/slide3.xml><?xml version="1.0" encoding="utf-8"?>
+<file path=ppt/slides/slide4.xml><?xml version="1.0" encoding="utf-8"?>
 <p:sld xmlns:a="http://schemas.openxmlformats.org/drawingml/2006/main" xmlns:r="http://schemas.openxmlformats.org/officeDocument/2006/relationships" xmlns:p="http://schemas.openxmlformats.org/presentationml/2006/main">
   <p:cSld>
     <p:bg>

</xml_diff>